<commit_message>
final version of PS2 v2 submission
</commit_message>
<xml_diff>
--- a/PS2-FP05-TeamA-A0-Poster.pptx
+++ b/PS2-FP05-TeamA-A0-Poster.pptx
@@ -770,6 +770,7 @@
           <a:bodyPr/>
           <a:lstStyle/>
           <a:p>
+            <a:pPr latinLnBrk="0"/>
             <a:endParaRPr lang="en-US"/>
           </a:p>
         </p:txBody>
@@ -808,7 +809,7 @@
           </a:bodyPr>
           <a:lstStyle/>
           <a:p>
-            <a:pPr algn="l">
+            <a:pPr algn="l" latinLnBrk="0">
               <a:defRPr sz="2775" b="1">
                 <a:solidFill>
                   <a:srgbClr val="003399"/>
@@ -866,7 +867,7 @@
           </a:bodyPr>
           <a:lstStyle/>
           <a:p>
-            <a:pPr algn="r">
+            <a:pPr algn="r" latinLnBrk="0">
               <a:defRPr sz="2100" b="1">
                 <a:solidFill>
                   <a:srgbClr val="006633"/>
@@ -885,7 +886,7 @@
                 <a:ea typeface="Calibri"/>
                 <a:cs typeface="Calibri"/>
               </a:rPr>
-              <a:t>REVIEW-READY v1  ·  SEP 27, 2026</a:t>
+              <a:t>FINAL v2  ·  OCT 2026</a:t>
             </a:r>
           </a:p>
         </p:txBody>
@@ -924,7 +925,7 @@
           </a:bodyPr>
           <a:lstStyle/>
           <a:p>
-            <a:pPr algn="l">
+            <a:pPr algn="l" latinLnBrk="0">
               <a:defRPr sz="9450" b="1">
                 <a:solidFill>
                   <a:srgbClr val="003399"/>
@@ -947,7 +948,7 @@
             </a:r>
           </a:p>
           <a:p>
-            <a:pPr algn="l">
+            <a:pPr algn="l" latinLnBrk="0">
               <a:defRPr sz="9450" b="1">
                 <a:solidFill>
                   <a:srgbClr val="003399"/>
@@ -1005,7 +1006,7 @@
           </a:bodyPr>
           <a:lstStyle/>
           <a:p>
-            <a:pPr algn="l">
+            <a:pPr algn="l" latinLnBrk="0">
               <a:defRPr sz="4050" b="1">
                 <a:solidFill>
                   <a:srgbClr val="212A33"/>
@@ -1063,7 +1064,7 @@
           </a:bodyPr>
           <a:lstStyle/>
           <a:p>
-            <a:pPr algn="l">
+            <a:pPr algn="l" latinLnBrk="0">
               <a:defRPr sz="3000" b="0">
                 <a:solidFill>
                   <a:srgbClr val="212A33"/>
@@ -1143,6 +1144,7 @@
           <a:bodyPr/>
           <a:lstStyle/>
           <a:p>
+            <a:pPr latinLnBrk="0"/>
             <a:endParaRPr lang="en-US"/>
           </a:p>
         </p:txBody>
@@ -1181,7 +1183,7 @@
           </a:bodyPr>
           <a:lstStyle/>
           <a:p>
-            <a:pPr algn="l">
+            <a:pPr algn="l" latinLnBrk="0">
               <a:defRPr sz="2700" b="1">
                 <a:solidFill>
                   <a:srgbClr val="FFFFFF"/>
@@ -1239,7 +1241,7 @@
           </a:bodyPr>
           <a:lstStyle/>
           <a:p>
-            <a:pPr algn="l">
+            <a:pPr algn="l" latinLnBrk="0">
               <a:defRPr sz="4425" b="1">
                 <a:solidFill>
                   <a:srgbClr val="FFFFFF"/>
@@ -1258,21 +1260,22 @@
                 <a:ea typeface="Calibri"/>
                 <a:cs typeface="Calibri"/>
               </a:rPr>
-              <a:t>A published, carbon-aware VCG rule </a:t>
-            </a:r>
-            <a:r>
-              <a:rPr lang="en" sz="3600" b="1" dirty="0">
+              <a:t>A published, carbon-aware VCG rule beats or ties all 720 FCFS arrival orders on value net of carbon (19.2 vs. 16.96 mean),</a:t>
+            </a:r>
+          </a:p>
+          <a:p>
+            <a:pPr algn="l" latinLnBrk="0">
+              <a:defRPr sz="4425" b="1">
                 <a:solidFill>
                   <a:srgbClr val="FFFFFF"/>
                 </a:solidFill>
                 <a:latin typeface="Calibri"/>
                 <a:ea typeface="Calibri"/>
                 <a:cs typeface="Calibri"/>
-              </a:rPr>
-              <a:t>beats or ties a</a:t>
-            </a:r>
-            <a:r>
-              <a:rPr sz="3600" b="1" dirty="0" err="1">
+              </a:defRPr>
+            </a:pPr>
+            <a:r>
+              <a:rPr sz="3600" b="1" dirty="0">
                 <a:solidFill>
                   <a:srgbClr val="FFFFFF"/>
                 </a:solidFill>
@@ -1280,41 +1283,7 @@
                 <a:ea typeface="Calibri"/>
                 <a:cs typeface="Calibri"/>
               </a:rPr>
-              <a:t>ll</a:t>
-            </a:r>
-            <a:r>
-              <a:rPr sz="3600" b="1" dirty="0">
-                <a:solidFill>
-                  <a:srgbClr val="FFFFFF"/>
-                </a:solidFill>
-                <a:latin typeface="Calibri"/>
-                <a:ea typeface="Calibri"/>
-                <a:cs typeface="Calibri"/>
-              </a:rPr>
-              <a:t> 720 FCFS arrival orders on value net of carbon (19.2 vs. 16.96 mean),</a:t>
-            </a:r>
-          </a:p>
-          <a:p>
-            <a:pPr algn="l">
-              <a:defRPr sz="4425" b="1">
-                <a:solidFill>
-                  <a:srgbClr val="FFFFFF"/>
-                </a:solidFill>
-                <a:latin typeface="Calibri"/>
-                <a:ea typeface="Calibri"/>
-                <a:cs typeface="Calibri"/>
-              </a:defRPr>
-            </a:pPr>
-            <a:r>
-              <a:rPr sz="3600" b="1" dirty="0">
-                <a:solidFill>
-                  <a:srgbClr val="FFFFFF"/>
-                </a:solidFill>
-                <a:latin typeface="Calibri"/>
-                <a:ea typeface="Calibri"/>
-                <a:cs typeface="Calibri"/>
-              </a:rPr>
-              <a:t>cuts emissions per unit of value (0.72 vs. 0.81 kg), and keeps truthful reporting optimal, but serves fewer teams (4 vs. 4.93).</a:t>
+              <a:t>cuts emissions per unit of value (0.72 vs. 0.81 kg), and keeps truthful reporting optimal at every carbon weight tested, but serves fewer teams (4 vs. 4.93).</a:t>
             </a:r>
           </a:p>
         </p:txBody>
@@ -1353,7 +1322,7 @@
           </a:bodyPr>
           <a:lstStyle/>
           <a:p>
-            <a:pPr algn="l">
+            <a:pPr algn="l" latinLnBrk="0">
               <a:defRPr sz="4650" b="1">
                 <a:solidFill>
                   <a:srgbClr val="003399"/>
@@ -1411,6 +1380,7 @@
           <a:bodyPr/>
           <a:lstStyle/>
           <a:p>
+            <a:pPr latinLnBrk="0"/>
             <a:endParaRPr lang="en-US"/>
           </a:p>
         </p:txBody>
@@ -1449,7 +1419,7 @@
           </a:bodyPr>
           <a:lstStyle/>
           <a:p>
-            <a:pPr algn="l">
+            <a:pPr algn="l" latinLnBrk="0">
               <a:defRPr sz="3375" b="1">
                 <a:solidFill>
                   <a:srgbClr val="003399"/>
@@ -1468,7 +1438,7 @@
                 <a:ea typeface="Calibri"/>
                 <a:cs typeface="Calibri"/>
               </a:rPr>
-              <a:t>Research question &amp; verified gap</a:t>
+              <a:t>Setting &amp; verified gap</a:t>
             </a:r>
           </a:p>
         </p:txBody>
@@ -1489,8 +1459,8 @@
         </p:nvSpPr>
         <p:spPr>
           <a:xfrm>
-            <a:off x="1333500" y="11886438"/>
-            <a:ext cx="11049000" cy="3078480"/>
+            <a:off x="1333500" y="11841480"/>
+            <a:ext cx="11049000" cy="2286000"/>
           </a:xfrm>
           <a:prstGeom prst="rect">
             <a:avLst/>
@@ -1529,7 +1499,7 @@
                 <a:ea typeface="Calibri"/>
                 <a:cs typeface="Calibri"/>
               </a:rPr>
-              <a:t>Question: </a:t>
+              <a:t>Setting: </a:t>
             </a:r>
             <a:r>
               <a:rPr sz="2500" b="0" dirty="0">
@@ -1540,7 +1510,7 @@
                 <a:ea typeface="Calibri"/>
                 <a:cs typeface="Calibri"/>
               </a:rPr>
-              <a:t>How should a university allocate scarce shared GPU-hours when each team privately knows its project value, but requests and emissions are public?</a:t>
+              <a:t>AI demand outpaces compute; queues ignore both value and carbon.</a:t>
             </a:r>
           </a:p>
           <a:p>
@@ -1566,7 +1536,7 @@
                 <a:ea typeface="Calibri"/>
                 <a:cs typeface="Calibri"/>
               </a:rPr>
-              <a:t>Setting: </a:t>
+              <a:t>Gap: </a:t>
             </a:r>
             <a:r>
               <a:rPr sz="2500" b="0" dirty="0">
@@ -1577,44 +1547,7 @@
                 <a:ea typeface="Calibri"/>
                 <a:cs typeface="Calibri"/>
               </a:rPr>
-              <a:t>AI demand outpaces compute budgets; queues ignore both value and carbon. Stakeholders: research teams, cluster administrators, the public.</a:t>
-            </a:r>
-          </a:p>
-          <a:p>
-            <a:pPr algn="l" latinLnBrk="0">
-              <a:spcAft>
-                <a:spcPts val="600"/>
-              </a:spcAft>
-              <a:defRPr sz="3300" b="0">
-                <a:solidFill>
-                  <a:srgbClr val="212A33"/>
-                </a:solidFill>
-                <a:latin typeface="Calibri"/>
-                <a:ea typeface="Calibri"/>
-                <a:cs typeface="Calibri"/>
-              </a:defRPr>
-            </a:pPr>
-            <a:r>
-              <a:rPr sz="2500" b="1" dirty="0">
-                <a:solidFill>
-                  <a:srgbClr val="212A33"/>
-                </a:solidFill>
-                <a:latin typeface="Calibri"/>
-                <a:ea typeface="Calibri"/>
-                <a:cs typeface="Calibri"/>
-              </a:rPr>
-              <a:t>Gap: </a:t>
-            </a:r>
-            <a:r>
-              <a:rPr sz="2500" b="0" dirty="0">
-                <a:solidFill>
-                  <a:srgbClr val="212A33"/>
-                </a:solidFill>
-                <a:latin typeface="Calibri"/>
-                <a:ea typeface="Calibri"/>
-                <a:cs typeface="Calibri"/>
-              </a:rPr>
-              <a:t>FAIR-Compute [5] studies fair, efficient allocation of federated research compute. We add an exactly solved VCG rule with carbon in the objective, plus a public audit.</a:t>
+              <a:t>FAIR-Compute [5] shows that value-blind scheduling loses about a third of scientific value, but it does not quantify carbon and leaves truthful-reporting mechanisms to future work. We build that piece at an exactly solvable scale.</a:t>
             </a:r>
           </a:p>
         </p:txBody>
@@ -1635,7 +1568,7 @@
         </p:nvSpPr>
         <p:spPr>
           <a:xfrm>
-            <a:off x="1333500" y="15330678"/>
+            <a:off x="1333500" y="14310360"/>
             <a:ext cx="11049000" cy="666750"/>
           </a:xfrm>
           <a:prstGeom prst="rect">
@@ -1653,7 +1586,7 @@
           </a:bodyPr>
           <a:lstStyle/>
           <a:p>
-            <a:pPr algn="l">
+            <a:pPr algn="l" latinLnBrk="0">
               <a:defRPr sz="3375" b="1">
                 <a:solidFill>
                   <a:srgbClr val="003399"/>
@@ -1672,7 +1605,7 @@
                 <a:ea typeface="Calibri"/>
                 <a:cs typeface="Calibri"/>
               </a:rPr>
-              <a:t>Strategic model &amp; foundations</a:t>
+              <a:t>Strategic model</a:t>
             </a:r>
           </a:p>
         </p:txBody>
@@ -1693,8 +1626,8 @@
         </p:nvSpPr>
         <p:spPr>
           <a:xfrm>
-            <a:off x="1333500" y="16070580"/>
-            <a:ext cx="11049000" cy="3230880"/>
+            <a:off x="1333500" y="14996159"/>
+            <a:ext cx="11049000" cy="4663440"/>
           </a:xfrm>
           <a:prstGeom prst="rect">
             <a:avLst/>
@@ -1744,62 +1677,7 @@
                 <a:ea typeface="Calibri"/>
                 <a:cs typeface="Calibri"/>
               </a:rPr>
-              <a:t>six teams A–F; each reports rᵢ of its private value vᵢ ∈ </a:t>
-            </a:r>
-            <a:r>
-              <a:rPr lang="en-US" altLang="ko-KR" sz="2500" b="0" dirty="0">
-                <a:solidFill>
-                  <a:srgbClr val="212A33"/>
-                </a:solidFill>
-                <a:latin typeface="Calibri"/>
-                <a:ea typeface="Calibri"/>
-                <a:cs typeface="Calibri"/>
-              </a:rPr>
-              <a:t>[</a:t>
-            </a:r>
-            <a:r>
-              <a:rPr lang="en-US" altLang="ko-KR" sz="2500" dirty="0">
-                <a:solidFill>
-                  <a:srgbClr val="212A33"/>
-                </a:solidFill>
-                <a:latin typeface="Calibri"/>
-                <a:ea typeface="Calibri"/>
-                <a:cs typeface="Calibri"/>
-              </a:rPr>
-              <a:t>1</a:t>
-            </a:r>
-            <a:r>
-              <a:rPr sz="2500" b="0" dirty="0">
-                <a:solidFill>
-                  <a:srgbClr val="212A33"/>
-                </a:solidFill>
-                <a:latin typeface="Calibri"/>
-                <a:ea typeface="Calibri"/>
-                <a:cs typeface="Calibri"/>
-              </a:rPr>
-              <a:t>, </a:t>
-            </a:r>
-            <a:r>
-              <a:rPr lang="en-US" altLang="ko-KR" sz="2500" b="0" dirty="0">
-                <a:solidFill>
-                  <a:srgbClr val="212A33"/>
-                </a:solidFill>
-                <a:latin typeface="Calibri"/>
-                <a:ea typeface="Calibri"/>
-                <a:cs typeface="Calibri"/>
-              </a:rPr>
-              <a:t>10]</a:t>
-            </a:r>
-            <a:r>
-              <a:rPr sz="2500" b="0" dirty="0">
-                <a:solidFill>
-                  <a:srgbClr val="212A33"/>
-                </a:solidFill>
-                <a:latin typeface="Calibri"/>
-                <a:ea typeface="Calibri"/>
-                <a:cs typeface="Calibri"/>
-              </a:rPr>
-              <a:t>.</a:t>
+              <a:t>six teams A–F; each privately knows vᵢ ∈ {3, 6, 9} and sends one sealed report rᵢ (static game, incomplete information).</a:t>
             </a:r>
           </a:p>
           <a:p>
@@ -1836,29 +1714,7 @@
                 <a:ea typeface="Calibri"/>
                 <a:cs typeface="Calibri"/>
               </a:rPr>
-              <a:t>GPU request dᵢ, emissions eᵢ = 0.24 dᵢ kg CO₂, capacity K = 100, carbon weight </a:t>
-            </a:r>
-            <a:r>
-              <a:rPr sz="2500" b="0" dirty="0" err="1">
-                <a:solidFill>
-                  <a:srgbClr val="212A33"/>
-                </a:solidFill>
-                <a:latin typeface="Calibri"/>
-                <a:ea typeface="Calibri"/>
-                <a:cs typeface="Calibri"/>
-              </a:rPr>
-              <a:t>λ</a:t>
-            </a:r>
-            <a:r>
-              <a:rPr sz="2500" b="0" dirty="0">
-                <a:solidFill>
-                  <a:srgbClr val="212A33"/>
-                </a:solidFill>
-                <a:latin typeface="Calibri"/>
-                <a:ea typeface="Calibri"/>
-                <a:cs typeface="Calibri"/>
-              </a:rPr>
-              <a:t> = 0.5.</a:t>
+              <a:t>request dᵢ, emissions eᵢ = 0.24 dᵢ kg CO₂e, capacity K = 100, λ = 0.5.</a:t>
             </a:r>
           </a:p>
           <a:p>
@@ -1884,7 +1740,7 @@
                 <a:ea typeface="Calibri"/>
                 <a:cs typeface="Calibri"/>
               </a:rPr>
-              <a:t>Timing: </a:t>
+              <a:t>Rule: </a:t>
             </a:r>
             <a:r>
               <a:rPr sz="2500" b="0" dirty="0">
@@ -1895,7 +1751,7 @@
                 <a:ea typeface="Calibri"/>
                 <a:cs typeface="Calibri"/>
               </a:rPr>
-              <a:t>one simultaneous sealed report (static, incomplete information).</a:t>
+              <a:t>pick the feasible group S* maximizing Σ(rᵢ − λeᵢ) over all 64 groups; each winner pays the score the other teams lose because it is selected.</a:t>
             </a:r>
           </a:p>
           <a:p>
@@ -1932,29 +1788,7 @@
                 <a:ea typeface="Calibri"/>
                 <a:cs typeface="Calibri"/>
               </a:rPr>
-              <a:t>uᵢ = vᵢ − </a:t>
-            </a:r>
-            <a:r>
-              <a:rPr sz="2500" b="0" dirty="0" err="1">
-                <a:solidFill>
-                  <a:srgbClr val="212A33"/>
-                </a:solidFill>
-                <a:latin typeface="Calibri"/>
-                <a:ea typeface="Calibri"/>
-                <a:cs typeface="Calibri"/>
-              </a:rPr>
-              <a:t>λe</a:t>
-            </a:r>
-            <a:r>
-              <a:rPr sz="2500" b="0" dirty="0">
-                <a:solidFill>
-                  <a:srgbClr val="212A33"/>
-                </a:solidFill>
-                <a:latin typeface="Calibri"/>
-                <a:ea typeface="Calibri"/>
-                <a:cs typeface="Calibri"/>
-              </a:rPr>
-              <a:t>ᵢ − pᵢ if selected, else 0.</a:t>
+              <a:t>uᵢ = vᵢ − λeᵢ − pᵢ if selected, else 0.</a:t>
             </a:r>
           </a:p>
           <a:p>
@@ -1991,7 +1825,44 @@
                 <a:ea typeface="Calibri"/>
                 <a:cs typeface="Calibri"/>
               </a:rPr>
-              <a:t>truthful rᵢ = vᵢ is dominant (DSIC, so also BNE) [1–4], because each team bears its own carbon penalty.</a:t>
+              <a:t>truthful rᵢ = vᵢ is dominant (DSIC) [1–4]: the price never depends on a team's own report.</a:t>
+            </a:r>
+          </a:p>
+          <a:p>
+            <a:pPr algn="l" latinLnBrk="0">
+              <a:spcAft>
+                <a:spcPts val="600"/>
+              </a:spcAft>
+              <a:defRPr sz="3300" b="0">
+                <a:solidFill>
+                  <a:srgbClr val="212A33"/>
+                </a:solidFill>
+                <a:latin typeface="Calibri"/>
+                <a:ea typeface="Calibri"/>
+                <a:cs typeface="Calibri"/>
+              </a:defRPr>
+            </a:pPr>
+            <a:r>
+              <a:rPr sz="2500" b="1" dirty="0">
+                <a:solidFill>
+                  <a:srgbClr val="212A33"/>
+                </a:solidFill>
+                <a:latin typeface="Calibri"/>
+                <a:ea typeface="Calibri"/>
+                <a:cs typeface="Calibri"/>
+              </a:rPr>
+              <a:t>Analogy stops: </a:t>
+            </a:r>
+            <a:r>
+              <a:rPr sz="2500" b="0" dirty="0">
+                <a:solidFill>
+                  <a:srgbClr val="212A33"/>
+                </a:solidFill>
+                <a:latin typeface="Calibri"/>
+                <a:ea typeface="Calibri"/>
+                <a:cs typeface="Calibri"/>
+              </a:rPr>
+              <a:t>credits are not money; values are never verified.</a:t>
             </a:r>
           </a:p>
         </p:txBody>
@@ -2012,7 +1883,7 @@
         </p:nvSpPr>
         <p:spPr>
           <a:xfrm>
-            <a:off x="1333500" y="19667220"/>
+            <a:off x="1333500" y="23454360"/>
             <a:ext cx="11049000" cy="666750"/>
           </a:xfrm>
           <a:prstGeom prst="rect">
@@ -2030,7 +1901,7 @@
           </a:bodyPr>
           <a:lstStyle/>
           <a:p>
-            <a:pPr algn="l">
+            <a:pPr algn="l" latinLnBrk="0">
               <a:defRPr sz="3375" b="1">
                 <a:solidFill>
                   <a:srgbClr val="003399"/>
@@ -2049,7 +1920,7 @@
                 <a:ea typeface="Calibri"/>
                 <a:cs typeface="Calibri"/>
               </a:rPr>
-              <a:t>Three complementary lenses</a:t>
+              <a:t>Three lenses</a:t>
             </a:r>
           </a:p>
         </p:txBody>
@@ -2070,8 +1941,8 @@
         </p:nvSpPr>
         <p:spPr>
           <a:xfrm>
-            <a:off x="1333500" y="20407122"/>
-            <a:ext cx="11049000" cy="3078480"/>
+            <a:off x="1333500" y="24140160"/>
+            <a:ext cx="11049000" cy="2834640"/>
           </a:xfrm>
           <a:prstGeom prst="rect">
             <a:avLst/>
@@ -2113,24 +1984,16 @@
               <a:t>Game theory: </a:t>
             </a:r>
             <a:r>
-              <a:rPr lang="en" sz="2500" dirty="0">
-                <a:solidFill>
-                  <a:srgbClr val="212A33"/>
-                </a:solidFill>
-                <a:latin typeface="Calibri"/>
-                <a:ea typeface="Calibri"/>
-                <a:cs typeface="Calibri"/>
-              </a:rPr>
-              <a:t>Teams cannot benefit by lying about their value, so truthful reporting is the best strategy. </a:t>
-            </a:r>
-            <a:endParaRPr sz="2500" dirty="0">
-              <a:solidFill>
-                <a:srgbClr val="212A33"/>
-              </a:solidFill>
-              <a:latin typeface="Calibri"/>
-              <a:ea typeface="Calibri"/>
-              <a:cs typeface="Calibri"/>
-            </a:endParaRPr>
+              <a:rPr lang="en" sz="2500" b="0" dirty="0">
+                <a:solidFill>
+                  <a:srgbClr val="212A33"/>
+                </a:solidFill>
+                <a:latin typeface="Calibri"/>
+                <a:ea typeface="Calibri"/>
+                <a:cs typeface="Calibri"/>
+              </a:rPr>
+              <a:t>truthful reporting is each team's best strategy, whatever others report.</a:t>
+            </a:r>
           </a:p>
           <a:p>
             <a:pPr latinLnBrk="0">
@@ -2147,7 +2010,7 @@
               </a:defRPr>
             </a:pPr>
             <a:r>
-              <a:rPr lang="en" altLang="ko-KR" sz="2500" b="1" dirty="0">
+              <a:rPr lang="en" sz="2500" b="1" dirty="0">
                 <a:solidFill>
                   <a:srgbClr val="212A33"/>
                 </a:solidFill>
@@ -2158,24 +2021,16 @@
               <a:t>Social choice: </a:t>
             </a:r>
             <a:r>
-              <a:rPr lang="en" altLang="ko-KR" sz="2500" dirty="0">
-                <a:solidFill>
-                  <a:srgbClr val="212A33"/>
-                </a:solidFill>
-                <a:latin typeface="Calibri"/>
-                <a:ea typeface="Calibri"/>
-                <a:cs typeface="Calibri"/>
-              </a:rPr>
-              <a:t>We choose the set of teams that gives the highest total benefit while accounting for limited GPU capacity and carbon costs.</a:t>
-            </a:r>
-            <a:endParaRPr sz="2500" dirty="0">
-              <a:solidFill>
-                <a:srgbClr val="212A33"/>
-              </a:solidFill>
-              <a:latin typeface="Calibri"/>
-              <a:ea typeface="Calibri"/>
-              <a:cs typeface="Calibri"/>
-            </a:endParaRPr>
+              <a:rPr lang="en" sz="2500" b="0" dirty="0">
+                <a:solidFill>
+                  <a:srgbClr val="212A33"/>
+                </a:solidFill>
+                <a:latin typeface="Calibri"/>
+                <a:ea typeface="Calibri"/>
+                <a:cs typeface="Calibri"/>
+              </a:rPr>
+              <a:t>value net of carbon under capacity; the cost is fewer teams served (4 vs. 4.93).</a:t>
+            </a:r>
           </a:p>
           <a:p>
             <a:pPr latinLnBrk="0">
@@ -2192,7 +2047,7 @@
               </a:defRPr>
             </a:pPr>
             <a:r>
-              <a:rPr lang="en" altLang="ko-KR" sz="2500" b="1" dirty="0">
+              <a:rPr lang="en" sz="2500" b="1" dirty="0">
                 <a:solidFill>
                   <a:srgbClr val="212A33"/>
                 </a:solidFill>
@@ -2203,24 +2058,16 @@
               <a:t>Mechanism design: </a:t>
             </a:r>
             <a:r>
-              <a:rPr lang="en" altLang="ko-KR" sz="2500" dirty="0">
-                <a:solidFill>
-                  <a:srgbClr val="212A33"/>
-                </a:solidFill>
-                <a:latin typeface="Calibri"/>
-                <a:ea typeface="Calibri"/>
-                <a:cs typeface="Calibri"/>
-              </a:rPr>
-              <a:t>Instead of first-come-first-served, we use a transparent scoring rule and VCG payments. Changing the carbon weight changes which teams receive GPUs.</a:t>
-            </a:r>
-            <a:endParaRPr sz="2500" dirty="0">
-              <a:solidFill>
-                <a:srgbClr val="212A33"/>
-              </a:solidFill>
-              <a:latin typeface="Calibri"/>
-              <a:ea typeface="Calibri"/>
-              <a:cs typeface="Calibri"/>
-            </a:endParaRPr>
+              <a:rPr lang="en" sz="2500" b="0" dirty="0">
+                <a:solidFill>
+                  <a:srgbClr val="212A33"/>
+                </a:solidFill>
+                <a:latin typeface="Calibri"/>
+                <a:ea typeface="Calibri"/>
+                <a:cs typeface="Calibri"/>
+              </a:rPr>
+              <a:t>a published score rule with VCG prices replaces the queue; λ moves prices, not the winners or the best strategy.</a:t>
+            </a:r>
           </a:p>
         </p:txBody>
       </p:sp>
@@ -2240,7 +2087,7 @@
         </p:nvSpPr>
         <p:spPr>
           <a:xfrm>
-            <a:off x="1333500" y="23851362"/>
+            <a:off x="1333500" y="19705320"/>
             <a:ext cx="11049000" cy="666750"/>
           </a:xfrm>
           <a:prstGeom prst="rect">
@@ -2258,7 +2105,7 @@
           </a:bodyPr>
           <a:lstStyle/>
           <a:p>
-            <a:pPr algn="l">
+            <a:pPr algn="l" latinLnBrk="0">
               <a:defRPr sz="3375" b="1">
                 <a:solidFill>
                   <a:srgbClr val="003399"/>
@@ -2277,7 +2124,7 @@
                 <a:ea typeface="Calibri"/>
                 <a:cs typeface="Calibri"/>
               </a:rPr>
-              <a:t>Auction or allocation comparison</a:t>
+              <a:t>Reduced payoff matrix: Team C vs. Team E</a:t>
             </a:r>
           </a:p>
         </p:txBody>
@@ -2298,8 +2145,8 @@
         </p:nvSpPr>
         <p:spPr>
           <a:xfrm>
-            <a:off x="1333500" y="24464772"/>
-            <a:ext cx="11049000" cy="2773680"/>
+            <a:off x="1333500" y="22311360"/>
+            <a:ext cx="11049000" cy="1005840"/>
           </a:xfrm>
           <a:prstGeom prst="rect">
             <a:avLst/>
@@ -2330,211 +2177,15 @@
               </a:defRPr>
             </a:pPr>
             <a:r>
-              <a:rPr sz="2500" b="1" dirty="0">
-                <a:solidFill>
-                  <a:srgbClr val="212A33"/>
-                </a:solidFill>
-                <a:latin typeface="Calibri"/>
-                <a:ea typeface="Calibri"/>
-                <a:cs typeface="Calibri"/>
-              </a:rPr>
-              <a:t>Resource: </a:t>
-            </a:r>
-            <a:r>
-              <a:rPr sz="2500" b="0" dirty="0">
-                <a:solidFill>
-                  <a:srgbClr val="212A33"/>
-                </a:solidFill>
-                <a:latin typeface="Calibri"/>
-                <a:ea typeface="Calibri"/>
-                <a:cs typeface="Calibri"/>
-              </a:rPr>
-              <a:t>100 GPU-hours; private values vᵢ; sealed value reports rᵢ.</a:t>
-            </a:r>
-          </a:p>
-          <a:p>
-            <a:pPr latinLnBrk="0">
-              <a:spcAft>
-                <a:spcPts val="600"/>
-              </a:spcAft>
-              <a:defRPr sz="3150" b="0">
-                <a:solidFill>
-                  <a:srgbClr val="212A33"/>
-                </a:solidFill>
-                <a:latin typeface="Calibri"/>
-                <a:ea typeface="Calibri"/>
-                <a:cs typeface="Calibri"/>
-              </a:defRPr>
-            </a:pPr>
-            <a:r>
-              <a:rPr lang="en" sz="2500" b="1" dirty="0">
-                <a:solidFill>
-                  <a:srgbClr val="212A33"/>
-                </a:solidFill>
-                <a:latin typeface="Calibri"/>
-                <a:ea typeface="Calibri"/>
-                <a:cs typeface="Calibri"/>
-              </a:rPr>
-              <a:t>Rules: </a:t>
-            </a:r>
-            <a:r>
-              <a:rPr lang="en" sz="2500" dirty="0">
-                <a:solidFill>
-                  <a:srgbClr val="212A33"/>
-                </a:solidFill>
-                <a:latin typeface="Calibri"/>
-                <a:ea typeface="Calibri"/>
-                <a:cs typeface="Calibri"/>
-              </a:rPr>
-              <a:t>choose the feasible group S* maximizing </a:t>
-            </a:r>
-            <a:r>
-              <a:rPr lang="el-GR" sz="2500" dirty="0">
-                <a:solidFill>
-                  <a:srgbClr val="212A33"/>
-                </a:solidFill>
-                <a:latin typeface="Calibri"/>
-                <a:ea typeface="Calibri"/>
-                <a:cs typeface="Calibri"/>
-              </a:rPr>
-              <a:t>Σ(</a:t>
-            </a:r>
-            <a:r>
-              <a:rPr lang="en" sz="2500" dirty="0">
-                <a:solidFill>
-                  <a:srgbClr val="212A33"/>
-                </a:solidFill>
-                <a:latin typeface="Calibri"/>
-                <a:ea typeface="Calibri"/>
-                <a:cs typeface="Calibri"/>
-              </a:rPr>
-              <a:t>rᵢ − </a:t>
-            </a:r>
-            <a:r>
-              <a:rPr lang="el-GR" sz="2500" dirty="0">
-                <a:solidFill>
-                  <a:srgbClr val="212A33"/>
-                </a:solidFill>
-                <a:latin typeface="Calibri"/>
-                <a:ea typeface="Calibri"/>
-                <a:cs typeface="Calibri"/>
-              </a:rPr>
-              <a:t>λ</a:t>
-            </a:r>
-            <a:r>
-              <a:rPr lang="en" sz="2500" dirty="0">
-                <a:solidFill>
-                  <a:srgbClr val="212A33"/>
-                </a:solidFill>
-                <a:latin typeface="Calibri"/>
-                <a:ea typeface="Calibri"/>
-                <a:cs typeface="Calibri"/>
-              </a:rPr>
-              <a:t>eᵢ) over all 64 groups; each winner pays pᵢ = W*₋ᵢ − (sum of the other winners' scores), where W*₋ᵢ is the best total without </a:t>
-            </a:r>
-            <a:r>
-              <a:rPr lang="en" sz="2500" dirty="0" err="1">
-                <a:solidFill>
-                  <a:srgbClr val="212A33"/>
-                </a:solidFill>
-                <a:latin typeface="Calibri"/>
-                <a:ea typeface="Calibri"/>
-                <a:cs typeface="Calibri"/>
-              </a:rPr>
-              <a:t>i</a:t>
-            </a:r>
-            <a:r>
-              <a:rPr lang="en" sz="2500" dirty="0">
-                <a:solidFill>
-                  <a:srgbClr val="212A33"/>
-                </a:solidFill>
-                <a:latin typeface="Calibri"/>
-                <a:ea typeface="Calibri"/>
-                <a:cs typeface="Calibri"/>
-              </a:rPr>
-              <a:t> (×10 credits); one round.</a:t>
-            </a:r>
-            <a:endParaRPr sz="2500" dirty="0">
-              <a:solidFill>
-                <a:srgbClr val="212A33"/>
-              </a:solidFill>
-              <a:latin typeface="Calibri"/>
-              <a:ea typeface="Calibri"/>
-              <a:cs typeface="Calibri"/>
-            </a:endParaRPr>
-          </a:p>
-          <a:p>
-            <a:pPr algn="l" latinLnBrk="0">
-              <a:spcAft>
-                <a:spcPts val="600"/>
-              </a:spcAft>
-              <a:defRPr sz="3150" b="0">
-                <a:solidFill>
-                  <a:srgbClr val="212A33"/>
-                </a:solidFill>
-                <a:latin typeface="Calibri"/>
-                <a:ea typeface="Calibri"/>
-                <a:cs typeface="Calibri"/>
-              </a:defRPr>
-            </a:pPr>
-            <a:r>
-              <a:rPr sz="2500" b="1" dirty="0">
-                <a:solidFill>
-                  <a:srgbClr val="212A33"/>
-                </a:solidFill>
-                <a:latin typeface="Calibri"/>
-                <a:ea typeface="Calibri"/>
-                <a:cs typeface="Calibri"/>
-              </a:rPr>
-              <a:t>Compared: </a:t>
-            </a:r>
-            <a:r>
-              <a:rPr sz="2500" b="0" dirty="0">
-                <a:solidFill>
-                  <a:srgbClr val="212A33"/>
-                </a:solidFill>
-                <a:latin typeface="Calibri"/>
-                <a:ea typeface="Calibri"/>
-                <a:cs typeface="Calibri"/>
-              </a:rPr>
-              <a:t>random-order FCFS (all 720 orders) vs. carbon-aware VCG.</a:t>
-            </a:r>
-          </a:p>
-          <a:p>
-            <a:pPr algn="l" latinLnBrk="0">
-              <a:spcAft>
-                <a:spcPts val="600"/>
-              </a:spcAft>
-              <a:defRPr sz="3150" b="0">
-                <a:solidFill>
-                  <a:srgbClr val="212A33"/>
-                </a:solidFill>
-                <a:latin typeface="Calibri"/>
-                <a:ea typeface="Calibri"/>
-                <a:cs typeface="Calibri"/>
-              </a:defRPr>
-            </a:pPr>
-            <a:r>
-              <a:rPr sz="2500" b="1" dirty="0">
-                <a:solidFill>
-                  <a:srgbClr val="212A33"/>
-                </a:solidFill>
-                <a:latin typeface="Calibri"/>
-                <a:ea typeface="Calibri"/>
-                <a:cs typeface="Calibri"/>
-              </a:rPr>
-              <a:t>Analogy stops: </a:t>
-            </a:r>
-            <a:r>
-              <a:rPr sz="2500" b="0" dirty="0">
-                <a:solidFill>
-                  <a:srgbClr val="212A33"/>
-                </a:solidFill>
-                <a:latin typeface="Calibri"/>
-                <a:ea typeface="Calibri"/>
-                <a:cs typeface="Calibri"/>
-              </a:rPr>
-              <a:t>credits are non-transferable, values cannot be verified, and exact search does not scale.</a:t>
+              <a:rPr sz="2200" b="0" dirty="0">
+                <a:solidFill>
+                  <a:srgbClr val="212A33"/>
+                </a:solidFill>
+                <a:latin typeface="Calibri"/>
+                <a:ea typeface="Calibri"/>
+                <a:cs typeface="Calibri"/>
+              </a:rPr>
+              <a:t>Simplification: only C and E choose; A, B, D, F report truthfully. Truth is weakly dominant for both, and C's overreport pushes the truthful E out.</a:t>
             </a:r>
           </a:p>
         </p:txBody>
@@ -2573,7 +2224,7 @@
           </a:bodyPr>
           <a:lstStyle/>
           <a:p>
-            <a:pPr algn="l">
+            <a:pPr algn="l" latinLnBrk="0">
               <a:defRPr sz="4650" b="1">
                 <a:solidFill>
                   <a:srgbClr val="003399"/>
@@ -2631,6 +2282,7 @@
           <a:bodyPr/>
           <a:lstStyle/>
           <a:p>
+            <a:pPr latinLnBrk="0"/>
             <a:endParaRPr lang="en-US"/>
           </a:p>
         </p:txBody>
@@ -2671,6 +2323,7 @@
           <a:bodyPr/>
           <a:lstStyle/>
           <a:p>
+            <a:pPr latinLnBrk="0"/>
             <a:endParaRPr lang="en-US"/>
           </a:p>
         </p:txBody>
@@ -2739,7 +2392,7 @@
                 <a:ea typeface="Calibri"/>
                 <a:cs typeface="Calibri"/>
               </a:rPr>
-              <a:t>Research design. Tested (computed): exact VCG over all 64 groups vs. random-order FCFS over all 720 orders, and a misreport sweep for every team. Planned: classroom Hugging Face play recording reports, predictions, and reflections.</a:t>
+              <a:t>Research questions and setting. Six teams request 120 GPU-hours from a pool of 100. Values are private; requests and emissions are public. Q1 and Q2 are answered by the model and its exact computation, Q3 by play in the Hugging Face Space.</a:t>
             </a:r>
           </a:p>
         </p:txBody>
@@ -2780,6 +2433,7 @@
           <a:bodyPr/>
           <a:lstStyle/>
           <a:p>
+            <a:pPr latinLnBrk="0"/>
             <a:endParaRPr lang="en-US"/>
           </a:p>
         </p:txBody>
@@ -2801,7 +2455,7 @@
         <p:spPr>
           <a:xfrm>
             <a:off x="13335000" y="24241125"/>
-            <a:ext cx="16134000" cy="2714625"/>
+            <a:ext cx="16134000" cy="3200400"/>
           </a:xfrm>
           <a:prstGeom prst="rect">
             <a:avLst/>
@@ -2877,7 +2531,7 @@
                 <a:ea typeface="Calibri"/>
                 <a:cs typeface="Calibri"/>
               </a:rPr>
-              <a:t>Interpretation: </a:t>
+              <a:t>Result: </a:t>
             </a:r>
             <a:r>
               <a:rPr sz="2400" b="0" dirty="0">
@@ -2888,7 +2542,7 @@
                 <a:ea typeface="Calibri"/>
                 <a:cs typeface="Calibri"/>
               </a:rPr>
-              <a:t>VCG picks the highest-value, lowest-carbon group (A, B, D, E: value 30, 21.6 kg); no FCFS order beats it, but FCFS serves more teams on average.</a:t>
+              <a:t>VCG picks A, B, D, E (value 30, 21.6 kg CO₂e); no FCFS order beats it, but FCFS serves more teams on average.</a:t>
             </a:r>
           </a:p>
           <a:p>
@@ -2914,7 +2568,7 @@
                 <a:ea typeface="Calibri"/>
                 <a:cs typeface="Calibri"/>
               </a:rPr>
-              <a:t>Verification: </a:t>
+              <a:t>Parameter change: </a:t>
             </a:r>
             <a:r>
               <a:rPr sz="2400" b="0" dirty="0">
@@ -2925,51 +2579,7 @@
                 <a:ea typeface="Calibri"/>
                 <a:cs typeface="Calibri"/>
               </a:rPr>
-              <a:t>python </a:t>
-            </a:r>
-            <a:r>
-              <a:rPr sz="2400" b="0" dirty="0" err="1">
-                <a:solidFill>
-                  <a:srgbClr val="212A33"/>
-                </a:solidFill>
-                <a:latin typeface="Calibri"/>
-                <a:ea typeface="Calibri"/>
-                <a:cs typeface="Calibri"/>
-              </a:rPr>
-              <a:t>colab</a:t>
-            </a:r>
-            <a:r>
-              <a:rPr sz="2400" b="0" dirty="0">
-                <a:solidFill>
-                  <a:srgbClr val="212A33"/>
-                </a:solidFill>
-                <a:latin typeface="Calibri"/>
-                <a:ea typeface="Calibri"/>
-                <a:cs typeface="Calibri"/>
-              </a:rPr>
-              <a:t>/</a:t>
-            </a:r>
-            <a:r>
-              <a:rPr sz="2400" b="0" dirty="0" err="1">
-                <a:solidFill>
-                  <a:srgbClr val="212A33"/>
-                </a:solidFill>
-                <a:latin typeface="Calibri"/>
-                <a:ea typeface="Calibri"/>
-                <a:cs typeface="Calibri"/>
-              </a:rPr>
-              <a:t>run_simulation.py</a:t>
-            </a:r>
-            <a:r>
-              <a:rPr sz="2400" b="0" dirty="0">
-                <a:solidFill>
-                  <a:srgbClr val="212A33"/>
-                </a:solidFill>
-                <a:latin typeface="Calibri"/>
-                <a:ea typeface="Calibri"/>
-                <a:cs typeface="Calibri"/>
-              </a:rPr>
-              <a:t> reproduces the outputs; 5 unit tests pass; notebook 7/7 checks PASS; commit d93fc2e.</a:t>
+              <a:t>for λ from 0.1 to 1 the same group wins, the price per winner falls from 5.28 to 0, and truth stays optimal. With two GPU types (H100, A100) the same teams win and emissions fall from 21.6 to 16.6 kg.</a:t>
             </a:r>
           </a:p>
           <a:p>
@@ -2995,7 +2605,7 @@
                 <a:ea typeface="Calibri"/>
                 <a:cs typeface="Calibri"/>
               </a:rPr>
-              <a:t>Evidence status: </a:t>
+              <a:t>Verification: </a:t>
             </a:r>
             <a:r>
               <a:rPr sz="2400" b="0" dirty="0">
@@ -3006,7 +2616,7 @@
                 <a:ea typeface="Calibri"/>
                 <a:cs typeface="Calibri"/>
               </a:rPr>
-              <a:t>computed from one synthetic instance; behavioral play is planned, not observed.</a:t>
+              <a:t>python colab/run_simulation.py reproduces the outputs; 7 unit tests pass; notebook 9/9 checks PASS; commit 8a656a4.</a:t>
             </a:r>
           </a:p>
         </p:txBody>
@@ -3045,7 +2655,7 @@
           </a:bodyPr>
           <a:lstStyle/>
           <a:p>
-            <a:pPr algn="l">
+            <a:pPr algn="l" latinLnBrk="0">
               <a:defRPr sz="4650" b="1">
                 <a:solidFill>
                   <a:srgbClr val="003399"/>
@@ -3103,6 +2713,7 @@
           <a:bodyPr/>
           <a:lstStyle/>
           <a:p>
+            <a:pPr latinLnBrk="0"/>
             <a:endParaRPr lang="en-US"/>
           </a:p>
         </p:txBody>
@@ -3141,7 +2752,7 @@
           </a:bodyPr>
           <a:lstStyle/>
           <a:p>
-            <a:pPr algn="l">
+            <a:pPr algn="l" latinLnBrk="0">
               <a:defRPr sz="3375" b="1">
                 <a:solidFill>
                   <a:srgbClr val="003399"/>
@@ -3181,8 +2792,8 @@
         </p:nvSpPr>
         <p:spPr>
           <a:xfrm>
-            <a:off x="30421500" y="11886438"/>
-            <a:ext cx="11049000" cy="3992880"/>
+            <a:off x="30421500" y="11841480"/>
+            <a:ext cx="11049000" cy="4297680"/>
           </a:xfrm>
           <a:prstGeom prst="rect">
             <a:avLst/>
@@ -3232,7 +2843,7 @@
                 <a:ea typeface="Calibri"/>
                 <a:cs typeface="Calibri"/>
               </a:rPr>
-              <a:t>a university's shared GPU cluster (e.g., a lab pool at DKU); no adoption yet.</a:t>
+              <a:t>a university's shared GPU cluster replaces queue order with a published, re-runnable rule and a carbon weight λ set by the institution; no adoption yet.</a:t>
             </a:r>
           </a:p>
           <a:p>
@@ -3258,7 +2869,7 @@
                 <a:ea typeface="Calibri"/>
                 <a:cs typeface="Calibri"/>
               </a:rPr>
-              <a:t>Decision: </a:t>
+              <a:t>Benefits / risks: </a:t>
             </a:r>
             <a:r>
               <a:rPr sz="2500" b="0" dirty="0">
@@ -3269,29 +2880,7 @@
                 <a:ea typeface="Calibri"/>
                 <a:cs typeface="Calibri"/>
               </a:rPr>
-              <a:t>replace queue order with a published, re-runnable rule and a carbon weight </a:t>
-            </a:r>
-            <a:r>
-              <a:rPr sz="2500" b="0" dirty="0" err="1">
-                <a:solidFill>
-                  <a:srgbClr val="212A33"/>
-                </a:solidFill>
-                <a:latin typeface="Calibri"/>
-                <a:ea typeface="Calibri"/>
-                <a:cs typeface="Calibri"/>
-              </a:rPr>
-              <a:t>λ</a:t>
-            </a:r>
-            <a:r>
-              <a:rPr sz="2500" b="0" dirty="0">
-                <a:solidFill>
-                  <a:srgbClr val="212A33"/>
-                </a:solidFill>
-                <a:latin typeface="Calibri"/>
-                <a:ea typeface="Calibri"/>
-                <a:cs typeface="Calibri"/>
-              </a:rPr>
-              <a:t>.</a:t>
+              <a:t>compute goes to value net of carbon and every allocation is auditable; fewer teams are served, and a heavy λ penalizes compute-heavy research.</a:t>
             </a:r>
           </a:p>
           <a:p>
@@ -3317,7 +2906,7 @@
                 <a:ea typeface="Calibri"/>
                 <a:cs typeface="Calibri"/>
               </a:rPr>
-              <a:t>Benefits / risks: </a:t>
+              <a:t>Who needs what: </a:t>
             </a:r>
             <a:r>
               <a:rPr sz="2500" b="0" dirty="0">
@@ -3328,29 +2917,7 @@
                 <a:ea typeface="Calibri"/>
                 <a:cs typeface="Calibri"/>
               </a:rPr>
-              <a:t>high-value projects run first and allocations become auditable; </a:t>
-            </a:r>
-            <a:r>
-              <a:rPr sz="2500" b="0" dirty="0" err="1">
-                <a:solidFill>
-                  <a:srgbClr val="212A33"/>
-                </a:solidFill>
-                <a:latin typeface="Calibri"/>
-                <a:ea typeface="Calibri"/>
-                <a:cs typeface="Calibri"/>
-              </a:rPr>
-              <a:t>λ</a:t>
-            </a:r>
-            <a:r>
-              <a:rPr sz="2500" b="0" dirty="0">
-                <a:solidFill>
-                  <a:srgbClr val="212A33"/>
-                </a:solidFill>
-                <a:latin typeface="Calibri"/>
-                <a:ea typeface="Calibri"/>
-                <a:cs typeface="Calibri"/>
-              </a:rPr>
-              <a:t> can penalize compute-heavy research, and fewer teams are served.</a:t>
+              <a:t>academia, a transparent pilot; industry, robustness at hundreds of teams; public institutions, a re-runnable audit.</a:t>
             </a:r>
           </a:p>
           <a:p>
@@ -3376,7 +2943,7 @@
                 <a:ea typeface="Calibri"/>
                 <a:cs typeface="Calibri"/>
               </a:rPr>
-              <a:t>Before adoption: </a:t>
+              <a:t>Correction: </a:t>
             </a:r>
             <a:r>
               <a:rPr sz="2500" b="0" dirty="0">
@@ -3387,88 +2954,7 @@
                 <a:ea typeface="Calibri"/>
                 <a:cs typeface="Calibri"/>
               </a:rPr>
-              <a:t>credits need a real future cost; pilot reported values against ex-post outcomes.</a:t>
-            </a:r>
-          </a:p>
-          <a:p>
-            <a:pPr algn="l" latinLnBrk="0">
-              <a:spcAft>
-                <a:spcPts val="600"/>
-              </a:spcAft>
-              <a:defRPr sz="3300" b="0">
-                <a:solidFill>
-                  <a:srgbClr val="212A33"/>
-                </a:solidFill>
-                <a:latin typeface="Calibri"/>
-                <a:ea typeface="Calibri"/>
-                <a:cs typeface="Calibri"/>
-              </a:defRPr>
-            </a:pPr>
-            <a:r>
-              <a:rPr sz="2500" b="1" dirty="0">
-                <a:solidFill>
-                  <a:srgbClr val="212A33"/>
-                </a:solidFill>
-                <a:latin typeface="Calibri"/>
-                <a:ea typeface="Calibri"/>
-                <a:cs typeface="Calibri"/>
-              </a:rPr>
-              <a:t>Correction: </a:t>
-            </a:r>
-            <a:r>
-              <a:rPr sz="2500" b="0" dirty="0">
-                <a:solidFill>
-                  <a:srgbClr val="212A33"/>
-                </a:solidFill>
-                <a:latin typeface="Calibri"/>
-                <a:ea typeface="Calibri"/>
-                <a:cs typeface="Calibri"/>
-              </a:rPr>
-              <a:t>public audit log; </a:t>
-            </a:r>
-            <a:r>
-              <a:rPr sz="2500" b="0" dirty="0" err="1">
-                <a:solidFill>
-                  <a:srgbClr val="212A33"/>
-                </a:solidFill>
-                <a:latin typeface="Calibri"/>
-                <a:ea typeface="Calibri"/>
-                <a:cs typeface="Calibri"/>
-              </a:rPr>
-              <a:t>λ</a:t>
-            </a:r>
-            <a:r>
-              <a:rPr sz="2500" b="0" dirty="0">
-                <a:solidFill>
-                  <a:srgbClr val="212A33"/>
-                </a:solidFill>
-                <a:latin typeface="Calibri"/>
-                <a:ea typeface="Calibri"/>
-                <a:cs typeface="Calibri"/>
-              </a:rPr>
-              <a:t> revised through review</a:t>
-            </a:r>
-            <a:r>
-              <a:rPr lang="en-US" sz="2500" dirty="0">
-                <a:solidFill>
-                  <a:srgbClr val="212A33"/>
-                </a:solidFill>
-                <a:latin typeface="Calibri"/>
-                <a:ea typeface="Calibri"/>
-                <a:cs typeface="Calibri"/>
-              </a:rPr>
-              <a:t>s</a:t>
-            </a:r>
-            <a:r>
-              <a:rPr sz="2500" b="0" dirty="0">
-                <a:solidFill>
-                  <a:srgbClr val="212A33"/>
-                </a:solidFill>
-                <a:latin typeface="Calibri"/>
-                <a:ea typeface="Calibri"/>
-                <a:cs typeface="Calibri"/>
-              </a:rPr>
-              <a:t>.</a:t>
+              <a:t>rule, inputs, and code are public, so any team can re-run and challenge an allocation.</a:t>
             </a:r>
           </a:p>
         </p:txBody>
@@ -3489,7 +2975,7 @@
         </p:nvSpPr>
         <p:spPr>
           <a:xfrm>
-            <a:off x="30421500" y="16245078"/>
+            <a:off x="30421500" y="16322040"/>
             <a:ext cx="11049000" cy="666750"/>
           </a:xfrm>
           <a:prstGeom prst="rect">
@@ -3507,7 +2993,7 @@
           </a:bodyPr>
           <a:lstStyle/>
           <a:p>
-            <a:pPr algn="l">
+            <a:pPr algn="l" latinLnBrk="0">
               <a:defRPr sz="3375" b="1">
                 <a:solidFill>
                   <a:srgbClr val="003399"/>
@@ -3526,7 +3012,7 @@
                 <a:ea typeface="Calibri"/>
                 <a:cs typeface="Calibri"/>
               </a:rPr>
-              <a:t>Interdisciplinary evidence</a:t>
+              <a:t>Behavioral evidence: five self-plays (exploratory)</a:t>
             </a:r>
           </a:p>
         </p:txBody>
@@ -3547,8 +3033,8 @@
         </p:nvSpPr>
         <p:spPr>
           <a:xfrm>
-            <a:off x="30421500" y="16984980"/>
-            <a:ext cx="11049000" cy="4450080"/>
+            <a:off x="30421500" y="19888200"/>
+            <a:ext cx="11049000" cy="2743200"/>
           </a:xfrm>
           <a:prstGeom prst="rect">
             <a:avLst/>
@@ -3587,7 +3073,18 @@
                 <a:ea typeface="Calibri"/>
                 <a:cs typeface="Calibri"/>
               </a:rPr>
-              <a:t>Behavioral science</a:t>
+              <a:t>Agreement: </a:t>
+            </a:r>
+            <a:r>
+              <a:rPr sz="2500" b="0" dirty="0">
+                <a:solidFill>
+                  <a:srgbClr val="212A33"/>
+                </a:solidFill>
+                <a:latin typeface="Calibri"/>
+                <a:ea typeface="Calibri"/>
+                <a:cs typeface="Calibri"/>
+              </a:rPr>
+              <a:t>no misreport paid off; one overreport bought a seat for 36 credits and ended at u = −3.6.</a:t>
             </a:r>
           </a:p>
           <a:p>
@@ -3605,6 +3102,17 @@
               </a:defRPr>
             </a:pPr>
             <a:r>
+              <a:rPr sz="2500" b="1" dirty="0">
+                <a:solidFill>
+                  <a:srgbClr val="212A33"/>
+                </a:solidFill>
+                <a:latin typeface="Calibri"/>
+                <a:ea typeface="Calibri"/>
+                <a:cs typeface="Calibri"/>
+              </a:rPr>
+              <a:t>Gap: </a:t>
+            </a:r>
+            <a:r>
               <a:rPr sz="2500" b="0" dirty="0">
                 <a:solidFill>
                   <a:srgbClr val="212A33"/>
@@ -3613,7 +3121,7 @@
                 <a:ea typeface="Calibri"/>
                 <a:cs typeface="Calibri"/>
               </a:rPr>
-              <a:t>Players hold a private value, report, predict their selection, then see payments, utility, and a what-if curve; each copies a result line to a shared sheet.</a:t>
+              <a:t>three of five players overreported. Stated reasons: wanting to be selected, and misunderstanding the rule.</a:t>
             </a:r>
           </a:p>
           <a:p>
@@ -3639,7 +3147,7 @@
                 <a:ea typeface="Calibri"/>
                 <a:cs typeface="Calibri"/>
               </a:rPr>
-              <a:t>Boundary: </a:t>
+              <a:t>Integration: </a:t>
             </a:r>
             <a:r>
               <a:rPr sz="2500" b="0" dirty="0">
@@ -3650,178 +3158,7 @@
                 <a:ea typeface="Calibri"/>
                 <a:cs typeface="Calibri"/>
               </a:rPr>
-              <a:t>no plays collected yet; rivals are simulated</a:t>
-            </a:r>
-            <a:r>
-              <a:rPr lang="en-US" sz="2500" dirty="0">
-                <a:solidFill>
-                  <a:srgbClr val="212A33"/>
-                </a:solidFill>
-                <a:latin typeface="Calibri"/>
-                <a:ea typeface="Calibri"/>
-                <a:cs typeface="Calibri"/>
-              </a:rPr>
-              <a:t>.</a:t>
-            </a:r>
-            <a:endParaRPr lang="en-US" sz="2500" b="0" dirty="0">
-              <a:solidFill>
-                <a:srgbClr val="212A33"/>
-              </a:solidFill>
-              <a:latin typeface="Calibri"/>
-              <a:ea typeface="Calibri"/>
-              <a:cs typeface="Calibri"/>
-            </a:endParaRPr>
-          </a:p>
-          <a:p>
-            <a:pPr algn="l" latinLnBrk="0">
-              <a:spcAft>
-                <a:spcPts val="600"/>
-              </a:spcAft>
-              <a:defRPr sz="3225" b="0">
-                <a:solidFill>
-                  <a:srgbClr val="212A33"/>
-                </a:solidFill>
-                <a:latin typeface="Calibri"/>
-                <a:ea typeface="Calibri"/>
-                <a:cs typeface="Calibri"/>
-              </a:defRPr>
-            </a:pPr>
-            <a:r>
-              <a:rPr sz="2500" b="1" dirty="0">
-                <a:solidFill>
-                  <a:srgbClr val="212A33"/>
-                </a:solidFill>
-                <a:latin typeface="Calibri"/>
-                <a:ea typeface="Calibri"/>
-                <a:cs typeface="Calibri"/>
-              </a:rPr>
-              <a:t>Computer</a:t>
-            </a:r>
-            <a:r>
-              <a:rPr lang="en-US" sz="2500" b="1" dirty="0">
-                <a:solidFill>
-                  <a:srgbClr val="212A33"/>
-                </a:solidFill>
-                <a:latin typeface="Calibri"/>
-                <a:ea typeface="Calibri"/>
-                <a:cs typeface="Calibri"/>
-              </a:rPr>
-              <a:t> Science</a:t>
-            </a:r>
-            <a:endParaRPr sz="2500" b="1" dirty="0">
-              <a:solidFill>
-                <a:srgbClr val="212A33"/>
-              </a:solidFill>
-              <a:latin typeface="Calibri"/>
-              <a:ea typeface="Calibri"/>
-              <a:cs typeface="Calibri"/>
-            </a:endParaRPr>
-          </a:p>
-          <a:p>
-            <a:pPr algn="l" latinLnBrk="0">
-              <a:spcAft>
-                <a:spcPts val="600"/>
-              </a:spcAft>
-              <a:defRPr sz="3225" b="0">
-                <a:solidFill>
-                  <a:srgbClr val="212A33"/>
-                </a:solidFill>
-                <a:latin typeface="Calibri"/>
-                <a:ea typeface="Calibri"/>
-                <a:cs typeface="Calibri"/>
-              </a:defRPr>
-            </a:pPr>
-            <a:r>
-              <a:rPr sz="2500" b="0" dirty="0">
-                <a:solidFill>
-                  <a:srgbClr val="212A33"/>
-                </a:solidFill>
-                <a:latin typeface="Calibri"/>
-                <a:ea typeface="Calibri"/>
-                <a:cs typeface="Calibri"/>
-              </a:rPr>
-              <a:t>Exact 64-group VCG and 720-order FCFS; python </a:t>
-            </a:r>
-            <a:r>
-              <a:rPr sz="2500" b="0" dirty="0" err="1">
-                <a:solidFill>
-                  <a:srgbClr val="212A33"/>
-                </a:solidFill>
-                <a:latin typeface="Calibri"/>
-                <a:ea typeface="Calibri"/>
-                <a:cs typeface="Calibri"/>
-              </a:rPr>
-              <a:t>colab</a:t>
-            </a:r>
-            <a:r>
-              <a:rPr sz="2500" b="0" dirty="0">
-                <a:solidFill>
-                  <a:srgbClr val="212A33"/>
-                </a:solidFill>
-                <a:latin typeface="Calibri"/>
-                <a:ea typeface="Calibri"/>
-                <a:cs typeface="Calibri"/>
-              </a:rPr>
-              <a:t>/</a:t>
-            </a:r>
-            <a:r>
-              <a:rPr sz="2500" b="0" dirty="0" err="1">
-                <a:solidFill>
-                  <a:srgbClr val="212A33"/>
-                </a:solidFill>
-                <a:latin typeface="Calibri"/>
-                <a:ea typeface="Calibri"/>
-                <a:cs typeface="Calibri"/>
-              </a:rPr>
-              <a:t>run_simulation.py</a:t>
-            </a:r>
-            <a:r>
-              <a:rPr sz="2500" b="0" dirty="0">
-                <a:solidFill>
-                  <a:srgbClr val="212A33"/>
-                </a:solidFill>
-                <a:latin typeface="Calibri"/>
-                <a:ea typeface="Calibri"/>
-                <a:cs typeface="Calibri"/>
-              </a:rPr>
-              <a:t> reproduces the committed outputs; unit tests pass.</a:t>
-            </a:r>
-          </a:p>
-          <a:p>
-            <a:pPr algn="l" latinLnBrk="0">
-              <a:spcAft>
-                <a:spcPts val="600"/>
-              </a:spcAft>
-              <a:defRPr sz="3225" b="0">
-                <a:solidFill>
-                  <a:srgbClr val="212A33"/>
-                </a:solidFill>
-                <a:latin typeface="Calibri"/>
-                <a:ea typeface="Calibri"/>
-                <a:cs typeface="Calibri"/>
-              </a:defRPr>
-            </a:pPr>
-            <a:r>
-              <a:rPr sz="2500" b="1" dirty="0">
-                <a:solidFill>
-                  <a:srgbClr val="212A33"/>
-                </a:solidFill>
-                <a:latin typeface="Calibri"/>
-                <a:ea typeface="Calibri"/>
-                <a:cs typeface="Calibri"/>
-              </a:rPr>
-              <a:t>Integration: </a:t>
-            </a:r>
-            <a:r>
-              <a:rPr sz="2500" b="0" dirty="0">
-                <a:solidFill>
-                  <a:srgbClr val="212A33"/>
-                </a:solidFill>
-                <a:latin typeface="Calibri"/>
-                <a:ea typeface="Calibri"/>
-                <a:cs typeface="Calibri"/>
-              </a:rPr>
-              <a:t>building the Space's what-if curve exposed that utility vᵢ − pᵢ rewards overreporting, so the model now charges each team its own carbon.</a:t>
+              <a:t>the Space's what-if curve exposed that utility vᵢ − pᵢ rewards overreporting; each team now bears its own carbon.</a:t>
             </a:r>
           </a:p>
         </p:txBody>
@@ -3842,7 +3179,7 @@
         </p:nvSpPr>
         <p:spPr>
           <a:xfrm>
-            <a:off x="30421500" y="21800820"/>
+            <a:off x="30421500" y="23042880"/>
             <a:ext cx="11049000" cy="666750"/>
           </a:xfrm>
           <a:prstGeom prst="rect">
@@ -3860,7 +3197,7 @@
           </a:bodyPr>
           <a:lstStyle/>
           <a:p>
-            <a:pPr algn="l">
+            <a:pPr algn="l" latinLnBrk="0">
               <a:defRPr sz="3375" b="1">
                 <a:solidFill>
                   <a:srgbClr val="003399"/>
@@ -3879,7 +3216,7 @@
                 <a:ea typeface="Calibri"/>
                 <a:cs typeface="Calibri"/>
               </a:rPr>
-              <a:t>Limitations &amp; next test</a:t>
+              <a:t>Peer review, limits &amp; next test</a:t>
             </a:r>
           </a:p>
         </p:txBody>
@@ -3900,8 +3237,8 @@
         </p:nvSpPr>
         <p:spPr>
           <a:xfrm>
-            <a:off x="30421500" y="22540722"/>
-            <a:ext cx="11049000" cy="2316480"/>
+            <a:off x="30421500" y="23728680"/>
+            <a:ext cx="11049000" cy="3703320"/>
           </a:xfrm>
           <a:prstGeom prst="rect">
             <a:avLst/>
@@ -3940,7 +3277,7 @@
                 <a:ea typeface="Calibri"/>
                 <a:cs typeface="Calibri"/>
               </a:rPr>
-              <a:t>Limitation: </a:t>
+              <a:t>Why λ = 0.5? </a:t>
             </a:r>
             <a:r>
               <a:rPr sz="2500" b="0" dirty="0">
@@ -3951,29 +3288,7 @@
                 <a:ea typeface="Calibri"/>
                 <a:cs typeface="Calibri"/>
               </a:rPr>
-              <a:t>one synthetic instance; </a:t>
-            </a:r>
-            <a:r>
-              <a:rPr sz="2500" b="0" dirty="0" err="1">
-                <a:solidFill>
-                  <a:srgbClr val="212A33"/>
-                </a:solidFill>
-                <a:latin typeface="Calibri"/>
-                <a:ea typeface="Calibri"/>
-                <a:cs typeface="Calibri"/>
-              </a:rPr>
-              <a:t>λ</a:t>
-            </a:r>
-            <a:r>
-              <a:rPr sz="2500" b="0" dirty="0">
-                <a:solidFill>
-                  <a:srgbClr val="212A33"/>
-                </a:solidFill>
-                <a:latin typeface="Calibri"/>
-                <a:ea typeface="Calibri"/>
-                <a:cs typeface="Calibri"/>
-              </a:rPr>
-              <a:t> and 0.24 kg/GPU-h are assumptions; true values cannot be verified.</a:t>
+              <a:t>Sweep 0 to 1: prices change, the best strategy does not.</a:t>
             </a:r>
           </a:p>
           <a:p>
@@ -3999,7 +3314,7 @@
                 <a:ea typeface="Calibri"/>
                 <a:cs typeface="Calibri"/>
               </a:rPr>
-              <a:t>Next test: </a:t>
+              <a:t>One GPU type? </a:t>
             </a:r>
             <a:r>
               <a:rPr sz="2500" b="0" dirty="0">
@@ -4010,7 +3325,7 @@
                 <a:ea typeface="Calibri"/>
                 <a:cs typeface="Calibri"/>
               </a:rPr>
-              <a:t>pilot comparing reported values with ex-post project outcomes at a scale beyond exact search.</a:t>
+              <a:t>Two-pool extension: same winners, emissions −23%.</a:t>
             </a:r>
           </a:p>
           <a:p>
@@ -4036,7 +3351,7 @@
                 <a:ea typeface="Calibri"/>
                 <a:cs typeface="Calibri"/>
               </a:rPr>
-              <a:t>Question for reviewers: </a:t>
+              <a:t>No play data? </a:t>
             </a:r>
             <a:r>
               <a:rPr sz="2500" b="0" dirty="0">
@@ -4047,18 +3362,33 @@
                 <a:ea typeface="Calibri"/>
                 <a:cs typeface="Calibri"/>
               </a:rPr>
-              <a:t>how should </a:t>
-            </a:r>
-            <a:r>
-              <a:rPr sz="2500" b="0" dirty="0" err="1">
-                <a:solidFill>
-                  <a:srgbClr val="212A33"/>
-                </a:solidFill>
-                <a:latin typeface="Calibri"/>
-                <a:ea typeface="Calibri"/>
-                <a:cs typeface="Calibri"/>
-              </a:rPr>
-              <a:t>λ</a:t>
+              <a:t>Five recorded self-plays by the authors.</a:t>
+            </a:r>
+          </a:p>
+          <a:p>
+            <a:pPr algn="l" latinLnBrk="0">
+              <a:spcAft>
+                <a:spcPts val="600"/>
+              </a:spcAft>
+              <a:defRPr sz="3225" b="0">
+                <a:solidFill>
+                  <a:srgbClr val="212A33"/>
+                </a:solidFill>
+                <a:latin typeface="Calibri"/>
+                <a:ea typeface="Calibri"/>
+                <a:cs typeface="Calibri"/>
+              </a:defRPr>
+            </a:pPr>
+            <a:r>
+              <a:rPr sz="2500" b="1" dirty="0">
+                <a:solidFill>
+                  <a:srgbClr val="212A33"/>
+                </a:solidFill>
+                <a:latin typeface="Calibri"/>
+                <a:ea typeface="Calibri"/>
+                <a:cs typeface="Calibri"/>
+              </a:rPr>
+              <a:t>One instance? </a:t>
             </a:r>
             <a:r>
               <a:rPr sz="2500" b="0" dirty="0">
@@ -4069,49 +3399,17 @@
                 <a:ea typeface="Calibri"/>
                 <a:cs typeface="Calibri"/>
               </a:rPr>
-              <a:t> be set, and who should set it?</a:t>
-            </a:r>
-          </a:p>
-        </p:txBody>
-      </p:sp>
-      <p:sp>
-        <p:nvSpPr>
-          <p:cNvPr id="39" name="dates">
-            <a:extLst>
-              <a:ext uri="{FF2B5EF4-FFF2-40B4-BE49-F238E27FC236}">
-                <a16:creationId xmlns:a16="http://schemas.microsoft.com/office/drawing/2014/main" id="{EA157D18-CC9B-4A0B-91A5-3BE26B8F384A}"/>
-              </a:ext>
-            </a:extLst>
-          </p:cNvPr>
-          <p:cNvSpPr>
-            <a:spLocks noGrp="1"/>
-          </p:cNvSpPr>
-          <p:nvPr/>
-        </p:nvSpPr>
-        <p:spPr>
-          <a:xfrm>
-            <a:off x="30421500" y="25813512"/>
-            <a:ext cx="11049000" cy="1143000"/>
-          </a:xfrm>
-          <a:prstGeom prst="rect">
-            <a:avLst/>
-          </a:prstGeom>
-          <a:noFill/>
-          <a:ln w="0">
-            <a:noFill/>
-            <a:prstDash val="solid"/>
-          </a:ln>
-        </p:spPr>
-        <p:txBody>
-          <a:bodyPr>
-            <a:noAutofit/>
-          </a:bodyPr>
-          <a:lstStyle/>
-          <a:p>
-            <a:pPr algn="l">
-              <a:defRPr sz="2550" b="1">
-                <a:solidFill>
-                  <a:srgbClr val="006633"/>
+              <a:t>Truth also holds on 100 random instances; the FCFS comparison over random draws is next.</a:t>
+            </a:r>
+          </a:p>
+          <a:p>
+            <a:pPr algn="l" latinLnBrk="0">
+              <a:spcAft>
+                <a:spcPts val="600"/>
+              </a:spcAft>
+              <a:defRPr sz="3225" b="0">
+                <a:solidFill>
+                  <a:srgbClr val="212A33"/>
                 </a:solidFill>
                 <a:latin typeface="Calibri"/>
                 <a:ea typeface="Calibri"/>
@@ -4119,38 +3417,26 @@
               </a:defRPr>
             </a:pPr>
             <a:r>
-              <a:rPr sz="2550" b="1">
-                <a:solidFill>
-                  <a:srgbClr val="006633"/>
-                </a:solidFill>
-                <a:latin typeface="Calibri"/>
-                <a:ea typeface="Calibri"/>
-                <a:cs typeface="Calibri"/>
-              </a:rPr>
-              <a:t>SEP 28  Symposium, peer evaluation &amp; case impact</a:t>
-            </a:r>
-          </a:p>
-          <a:p>
-            <a:pPr algn="l">
-              <a:defRPr sz="2550" b="1">
-                <a:solidFill>
-                  <a:srgbClr val="006633"/>
-                </a:solidFill>
-                <a:latin typeface="Calibri"/>
-                <a:ea typeface="Calibri"/>
-                <a:cs typeface="Calibri"/>
-              </a:defRPr>
-            </a:pPr>
-            <a:r>
-              <a:rPr sz="2550" b="1">
-                <a:solidFill>
-                  <a:srgbClr val="006633"/>
-                </a:solidFill>
-                <a:latin typeface="Calibri"/>
-                <a:ea typeface="Calibri"/>
-                <a:cs typeface="Calibri"/>
-              </a:rPr>
-              <a:t>SEP 30  Final update</a:t>
+              <a:rPr sz="2500" b="1" dirty="0">
+                <a:solidFill>
+                  <a:srgbClr val="212A33"/>
+                </a:solidFill>
+                <a:latin typeface="Calibri"/>
+                <a:ea typeface="Calibri"/>
+                <a:cs typeface="Calibri"/>
+              </a:rPr>
+              <a:t>Limits: </a:t>
+            </a:r>
+            <a:r>
+              <a:rPr sz="2500" b="0" dirty="0">
+                <a:solidFill>
+                  <a:srgbClr val="212A33"/>
+                </a:solidFill>
+                <a:latin typeface="Calibri"/>
+                <a:ea typeface="Calibri"/>
+                <a:cs typeface="Calibri"/>
+              </a:rPr>
+              <a:t>λ and 0.24 kg/GPU-h are assumptions; true values cannot be verified; authors played against simulated rivals.</a:t>
             </a:r>
           </a:p>
         </p:txBody>
@@ -4189,6 +3475,7 @@
           <a:bodyPr/>
           <a:lstStyle/>
           <a:p>
+            <a:pPr latinLnBrk="0"/>
             <a:endParaRPr lang="en-US"/>
           </a:p>
         </p:txBody>
@@ -4227,7 +3514,7 @@
           </a:bodyPr>
           <a:lstStyle/>
           <a:p>
-            <a:pPr algn="l">
+            <a:pPr algn="l" latinLnBrk="0">
               <a:defRPr sz="3375" b="1">
                 <a:solidFill>
                   <a:srgbClr val="003399"/>
@@ -4285,7 +3572,7 @@
           </a:bodyPr>
           <a:lstStyle/>
           <a:p>
-            <a:pPr algn="l">
+            <a:pPr algn="l" latinLnBrk="0">
               <a:defRPr sz="2400" b="0">
                 <a:solidFill>
                   <a:srgbClr val="212A33"/>
@@ -4296,59 +3583,15 @@
               </a:defRPr>
             </a:pPr>
             <a:r>
-              <a:rPr sz="1900" b="0" dirty="0">
-                <a:solidFill>
-                  <a:srgbClr val="212A33"/>
-                </a:solidFill>
-                <a:latin typeface="Calibri"/>
-                <a:ea typeface="Calibri"/>
-                <a:cs typeface="Calibri"/>
-              </a:rPr>
-              <a:t>Instructor: Professor </a:t>
-            </a:r>
-            <a:r>
-              <a:rPr sz="1900" b="0" dirty="0" err="1">
-                <a:solidFill>
-                  <a:srgbClr val="212A33"/>
-                </a:solidFill>
-                <a:latin typeface="Calibri"/>
-                <a:ea typeface="Calibri"/>
-                <a:cs typeface="Calibri"/>
-              </a:rPr>
-              <a:t>Luyao</a:t>
-            </a:r>
-            <a:r>
-              <a:rPr sz="1900" b="0" dirty="0">
-                <a:solidFill>
-                  <a:srgbClr val="212A33"/>
-                </a:solidFill>
-                <a:latin typeface="Calibri"/>
-                <a:ea typeface="Calibri"/>
-                <a:cs typeface="Calibri"/>
-              </a:rPr>
-              <a:t> Zhang. Software: Python, Jupyter and Google </a:t>
-            </a:r>
-            <a:r>
-              <a:rPr sz="1900" b="0" dirty="0" err="1">
-                <a:solidFill>
-                  <a:srgbClr val="212A33"/>
-                </a:solidFill>
-                <a:latin typeface="Calibri"/>
-                <a:ea typeface="Calibri"/>
-                <a:cs typeface="Calibri"/>
-              </a:rPr>
-              <a:t>Colab</a:t>
-            </a:r>
-            <a:r>
-              <a:rPr sz="1900" b="0" dirty="0">
-                <a:solidFill>
-                  <a:srgbClr val="212A33"/>
-                </a:solidFill>
-                <a:latin typeface="Calibri"/>
-                <a:ea typeface="Calibri"/>
-                <a:cs typeface="Calibri"/>
-              </a:rPr>
-              <a:t>, matplotlib, Hugging Face Spaces. AI: Claude Code (Claude Opus 5.5) assisted the Space, notebook, tests, and figures; The authors are responsible for all content.</a:t>
+              <a:rPr sz="1700" b="0" dirty="0">
+                <a:solidFill>
+                  <a:srgbClr val="212A33"/>
+                </a:solidFill>
+                <a:latin typeface="Calibri"/>
+                <a:ea typeface="Calibri"/>
+                <a:cs typeface="Calibri"/>
+              </a:rPr>
+              <a:t>Instructor: Professor Luyao Zhang. Symposium reviewers: Y. Wu, Z. Zhou, Z. Wang, X. Sun, Y. Liu, A. Wang, M. Chen. Software: Python, Jupyter and Google Colab, matplotlib, Hugging Face Spaces. AI: Claude Code (Claude Opus 5.5) assisted the Space, notebook, tests, figures, and revision drafts; the authors are responsible for all content.</a:t>
             </a:r>
           </a:p>
         </p:txBody>
@@ -4387,7 +3630,7 @@
           </a:bodyPr>
           <a:lstStyle/>
           <a:p>
-            <a:pPr algn="l">
+            <a:pPr algn="l" latinLnBrk="0">
               <a:defRPr sz="3375" b="1">
                 <a:solidFill>
                   <a:srgbClr val="003399"/>
@@ -4445,7 +3688,7 @@
           </a:bodyPr>
           <a:lstStyle/>
           <a:p>
-            <a:pPr algn="l">
+            <a:pPr algn="l" latinLnBrk="0">
               <a:defRPr sz="2400" b="0">
                 <a:solidFill>
                   <a:srgbClr val="212A33"/>
@@ -4468,7 +3711,7 @@
             </a:r>
           </a:p>
           <a:p>
-            <a:pPr algn="l">
+            <a:pPr algn="l" latinLnBrk="0">
               <a:defRPr sz="2400" b="0">
                 <a:solidFill>
                   <a:srgbClr val="212A33"/>
@@ -4491,7 +3734,7 @@
             </a:r>
           </a:p>
           <a:p>
-            <a:pPr algn="l">
+            <a:pPr algn="l" latinLnBrk="0">
               <a:defRPr sz="2400" b="0">
                 <a:solidFill>
                   <a:srgbClr val="212A33"/>
@@ -4514,7 +3757,7 @@
             </a:r>
           </a:p>
           <a:p>
-            <a:pPr algn="l">
+            <a:pPr algn="l" latinLnBrk="0">
               <a:defRPr sz="2400" b="0">
                 <a:solidFill>
                   <a:srgbClr val="212A33"/>
@@ -4537,7 +3780,7 @@
             </a:r>
           </a:p>
           <a:p>
-            <a:pPr algn="l">
+            <a:pPr algn="l" latinLnBrk="0">
               <a:defRPr sz="2400" b="0">
                 <a:solidFill>
                   <a:srgbClr val="212A33"/>
@@ -4595,7 +3838,7 @@
           </a:bodyPr>
           <a:lstStyle/>
           <a:p>
-            <a:pPr algn="l">
+            <a:pPr algn="l" latinLnBrk="0">
               <a:defRPr sz="2400" b="1">
                 <a:solidFill>
                   <a:srgbClr val="003399"/>
@@ -4636,7 +3879,7 @@
         <p:spPr>
           <a:xfrm>
             <a:off x="30421500" y="28384500"/>
-            <a:ext cx="8096250" cy="1000125"/>
+            <a:ext cx="8096250" cy="1325880"/>
           </a:xfrm>
           <a:prstGeom prst="rect">
             <a:avLst/>
@@ -4653,7 +3896,7 @@
           </a:bodyPr>
           <a:lstStyle/>
           <a:p>
-            <a:pPr algn="l">
+            <a:pPr algn="l" latinLnBrk="0">
               <a:defRPr sz="2325" b="0">
                 <a:solidFill>
                   <a:srgbClr val="212A33"/>
@@ -4664,7 +3907,7 @@
               </a:defRPr>
             </a:pPr>
             <a:r>
-              <a:rPr sz="1700" b="0">
+              <a:rPr sz="1500" b="0">
                 <a:solidFill>
                   <a:srgbClr val="212A33"/>
                 </a:solidFill>
@@ -4677,7 +3920,7 @@
             </a:r>
           </a:p>
           <a:p>
-            <a:pPr algn="l">
+            <a:pPr algn="l" latinLnBrk="0">
               <a:defRPr sz="2325" b="0">
                 <a:solidFill>
                   <a:srgbClr val="212A33"/>
@@ -4688,16 +3931,40 @@
               </a:defRPr>
             </a:pPr>
             <a:r>
-              <a:rPr sz="1700" b="0">
-                <a:solidFill>
-                  <a:srgbClr val="212A33"/>
-                </a:solidFill>
-                <a:latin typeface="Calibri"/>
-                <a:ea typeface="Calibri"/>
-                <a:cs typeface="Calibri"/>
-                <a:hlinkClick r:id="rId5"/>
-              </a:rPr>
-              <a:t>GitHub: https://github.com/GihoonE/COMPSCI206-PS2 (commit d93fc2e)</a:t>
+              <a:rPr sz="1500" b="0">
+                <a:solidFill>
+                  <a:srgbClr val="212A33"/>
+                </a:solidFill>
+                <a:latin typeface="Calibri"/>
+                <a:ea typeface="Calibri"/>
+                <a:cs typeface="Calibri"/>
+                <a:hlinkClick r:id="rId4"/>
+              </a:rPr>
+              <a:t>GitHub: https://github.com/dku-comsci-econ206-Autumn2026/FP05-PS2-Team-A (commit 8a656a4)</a:t>
+            </a:r>
+          </a:p>
+          <a:p>
+            <a:pPr algn="l" latinLnBrk="0">
+              <a:defRPr sz="2325" b="0">
+                <a:solidFill>
+                  <a:srgbClr val="212A33"/>
+                </a:solidFill>
+                <a:latin typeface="Calibri"/>
+                <a:ea typeface="Calibri"/>
+                <a:cs typeface="Calibri"/>
+              </a:defRPr>
+            </a:pPr>
+            <a:r>
+              <a:rPr sz="1500" b="0">
+                <a:solidFill>
+                  <a:srgbClr val="212A33"/>
+                </a:solidFill>
+                <a:latin typeface="Calibri"/>
+                <a:ea typeface="Calibri"/>
+                <a:cs typeface="Calibri"/>
+                <a:hlinkClick r:id="rId4"/>
+              </a:rPr>
+              <a:t>Colab: https://colab.research.google.com/drive/14eo8a2HWUbbBtv-m-ia4xRiL4V6Iwtun</a:t>
             </a:r>
           </a:p>
         </p:txBody>
@@ -4718,8 +3985,8 @@
         </p:nvSpPr>
         <p:spPr>
           <a:xfrm>
-            <a:off x="1333500" y="29813250"/>
-            <a:ext cx="40137000" cy="400050"/>
+            <a:off x="35254071" y="27869878"/>
+            <a:ext cx="6527357" cy="476250"/>
           </a:xfrm>
           <a:prstGeom prst="rect">
             <a:avLst/>
@@ -4736,7 +4003,7 @@
           </a:bodyPr>
           <a:lstStyle/>
           <a:p>
-            <a:pPr algn="l">
+            <a:pPr algn="l" latinLnBrk="0">
               <a:defRPr sz="1950" b="0">
                 <a:solidFill>
                   <a:srgbClr val="56616B"/>
@@ -4755,21 +4022,342 @@
                 <a:ea typeface="Calibri"/>
                 <a:cs typeface="Calibri"/>
               </a:rPr>
-              <a:t>A0 landscape · 1189 × 841 mm  |  QR codes: left Hugging Face Space, right GitHub repository.</a:t>
-            </a:r>
-          </a:p>
-        </p:txBody>
-      </p:sp>
-      <p:sp>
-        <p:nvSpPr>
-          <p:cNvPr id="59" name="design-step-1"/>
+              <a:t>QR codes: left Hugging Face Space, right GitHub repository.</a:t>
+            </a:r>
+          </a:p>
+        </p:txBody>
+      </p:sp>
+      <p:pic>
+        <p:nvPicPr>
+          <p:cNvPr id="68" name="main-result-figure" descr="fig2.png"/>
+          <p:cNvPicPr>
+            <a:picLocks noChangeAspect="1"/>
+          </p:cNvPicPr>
+          <p:nvPr/>
+        </p:nvPicPr>
+        <p:blipFill>
+          <a:blip r:embed="rId5"/>
+          <a:stretch>
+            <a:fillRect/>
+          </a:stretch>
+        </p:blipFill>
+        <p:spPr>
+          <a:xfrm>
+            <a:off x="13517880" y="17794986"/>
+            <a:ext cx="15768240" cy="5958928"/>
+          </a:xfrm>
+          <a:prstGeom prst="rect">
+            <a:avLst/>
+          </a:prstGeom>
+        </p:spPr>
+      </p:pic>
+      <p:pic>
+        <p:nvPicPr>
+          <p:cNvPr id="69" name="hf-qr-code" descr="qr_hf.png"/>
+          <p:cNvPicPr>
+            <a:picLocks noChangeAspect="1"/>
+          </p:cNvPicPr>
+          <p:nvPr/>
+        </p:nvPicPr>
+        <p:blipFill>
+          <a:blip r:embed="rId6"/>
+          <a:stretch>
+            <a:fillRect/>
+          </a:stretch>
+        </p:blipFill>
+        <p:spPr>
+          <a:xfrm>
+            <a:off x="38907720" y="28300680"/>
+            <a:ext cx="1143000" cy="1143000"/>
+          </a:xfrm>
+          <a:prstGeom prst="rect">
+            <a:avLst/>
+          </a:prstGeom>
+        </p:spPr>
+      </p:pic>
+      <p:graphicFrame>
+        <p:nvGraphicFramePr>
+          <p:cNvPr id="71" name="payoff-matrix"/>
+          <p:cNvGraphicFramePr>
+            <a:graphicFrameLocks noGrp="1"/>
+          </p:cNvGraphicFramePr>
+          <p:nvPr/>
+        </p:nvGraphicFramePr>
+        <p:xfrm>
+          <a:off x="1335024" y="20391120"/>
+          <a:ext cx="11045952" cy="1810512"/>
+        </p:xfrm>
+        <a:graphic>
+          <a:graphicData uri="http://schemas.openxmlformats.org/drawingml/2006/table">
+            <a:tbl>
+              <a:tblPr firstRow="1" bandRow="1">
+                <a:tableStyleId>{5C22544A-7EE6-4342-B048-85BDC9FD1C3A}</a:tableStyleId>
+              </a:tblPr>
+              <a:tblGrid>
+                <a:gridCol w="4206240">
+                  <a:extLst>
+                    <a:ext uri="{9D8B030D-6E8A-4147-A177-3AD203B41FA5}">
+                      <a16:colId xmlns:a16="http://schemas.microsoft.com/office/drawing/2014/main" val="20000"/>
+                    </a:ext>
+                  </a:extLst>
+                </a:gridCol>
+                <a:gridCol w="3291840">
+                  <a:extLst>
+                    <a:ext uri="{9D8B030D-6E8A-4147-A177-3AD203B41FA5}">
+                      <a16:colId xmlns:a16="http://schemas.microsoft.com/office/drawing/2014/main" val="20001"/>
+                    </a:ext>
+                  </a:extLst>
+                </a:gridCol>
+                <a:gridCol w="3547872">
+                  <a:extLst>
+                    <a:ext uri="{9D8B030D-6E8A-4147-A177-3AD203B41FA5}">
+                      <a16:colId xmlns:a16="http://schemas.microsoft.com/office/drawing/2014/main" val="20002"/>
+                    </a:ext>
+                  </a:extLst>
+                </a:gridCol>
+              </a:tblGrid>
+              <a:tr h="603504">
+                <a:tc>
+                  <a:txBody>
+                    <a:bodyPr/>
+                    <a:lstStyle/>
+                    <a:p>
+                      <a:pPr algn="l" latinLnBrk="0"/>
+                      <a:r>
+                        <a:rPr sz="2200" b="1">
+                          <a:solidFill>
+                            <a:srgbClr val="FFFFFF"/>
+                          </a:solidFill>
+                          <a:latin typeface="Calibri"/>
+                        </a:rPr>
+                        <a:t>(u_C, u_E)</a:t>
+                      </a:r>
+                    </a:p>
+                  </a:txBody>
+                  <a:tcPr marL="109728" marR="109728" anchor="ctr">
+                    <a:solidFill>
+                      <a:srgbClr val="003399"/>
+                    </a:solidFill>
+                  </a:tcPr>
+                </a:tc>
+                <a:tc>
+                  <a:txBody>
+                    <a:bodyPr/>
+                    <a:lstStyle/>
+                    <a:p>
+                      <a:pPr algn="ctr" latinLnBrk="0"/>
+                      <a:r>
+                        <a:rPr sz="2200" b="1">
+                          <a:solidFill>
+                            <a:srgbClr val="FFFFFF"/>
+                          </a:solidFill>
+                          <a:latin typeface="Calibri"/>
+                        </a:rPr>
+                        <a:t>E truthful (r = 6)</a:t>
+                      </a:r>
+                    </a:p>
+                  </a:txBody>
+                  <a:tcPr marL="109728" marR="109728" anchor="ctr">
+                    <a:solidFill>
+                      <a:srgbClr val="003399"/>
+                    </a:solidFill>
+                  </a:tcPr>
+                </a:tc>
+                <a:tc>
+                  <a:txBody>
+                    <a:bodyPr/>
+                    <a:lstStyle/>
+                    <a:p>
+                      <a:pPr algn="ctr" latinLnBrk="0"/>
+                      <a:r>
+                        <a:rPr sz="2200" b="1">
+                          <a:solidFill>
+                            <a:srgbClr val="FFFFFF"/>
+                          </a:solidFill>
+                          <a:latin typeface="Calibri"/>
+                        </a:rPr>
+                        <a:t>E underreports (r = 4)</a:t>
+                      </a:r>
+                    </a:p>
+                  </a:txBody>
+                  <a:tcPr marL="109728" marR="109728" anchor="ctr">
+                    <a:solidFill>
+                      <a:srgbClr val="003399"/>
+                    </a:solidFill>
+                  </a:tcPr>
+                </a:tc>
+                <a:extLst>
+                  <a:ext uri="{0D108BD9-81ED-4DB2-BD59-A6C34878D82A}">
+                    <a16:rowId xmlns:a16="http://schemas.microsoft.com/office/drawing/2014/main" val="10000"/>
+                  </a:ext>
+                </a:extLst>
+              </a:tr>
+              <a:tr h="603504">
+                <a:tc>
+                  <a:txBody>
+                    <a:bodyPr/>
+                    <a:lstStyle/>
+                    <a:p>
+                      <a:pPr algn="l" latinLnBrk="0"/>
+                      <a:r>
+                        <a:rPr sz="2200" b="1">
+                          <a:solidFill>
+                            <a:srgbClr val="212A33"/>
+                          </a:solidFill>
+                          <a:latin typeface="Calibri"/>
+                        </a:rPr>
+                        <a:t>C truthful (r = 3)</a:t>
+                      </a:r>
+                    </a:p>
+                  </a:txBody>
+                  <a:tcPr marL="109728" marR="109728" anchor="ctr">
+                    <a:solidFill>
+                      <a:srgbClr val="FFFFFF"/>
+                    </a:solidFill>
+                  </a:tcPr>
+                </a:tc>
+                <a:tc>
+                  <a:txBody>
+                    <a:bodyPr/>
+                    <a:lstStyle/>
+                    <a:p>
+                      <a:pPr algn="ctr" latinLnBrk="0"/>
+                      <a:r>
+                        <a:rPr sz="2200" b="0">
+                          <a:solidFill>
+                            <a:srgbClr val="212A33"/>
+                          </a:solidFill>
+                          <a:latin typeface="Calibri"/>
+                        </a:rPr>
+                        <a:t>(0, 1.2)</a:t>
+                      </a:r>
+                    </a:p>
+                  </a:txBody>
+                  <a:tcPr marL="109728" marR="109728" anchor="ctr">
+                    <a:solidFill>
+                      <a:srgbClr val="FFFFFF"/>
+                    </a:solidFill>
+                  </a:tcPr>
+                </a:tc>
+                <a:tc>
+                  <a:txBody>
+                    <a:bodyPr/>
+                    <a:lstStyle/>
+                    <a:p>
+                      <a:pPr algn="ctr" latinLnBrk="0"/>
+                      <a:r>
+                        <a:rPr sz="2200" b="0">
+                          <a:solidFill>
+                            <a:srgbClr val="212A33"/>
+                          </a:solidFill>
+                          <a:latin typeface="Calibri"/>
+                        </a:rPr>
+                        <a:t>(0.8, 0)</a:t>
+                      </a:r>
+                    </a:p>
+                  </a:txBody>
+                  <a:tcPr marL="109728" marR="109728" anchor="ctr">
+                    <a:solidFill>
+                      <a:srgbClr val="FFFFFF"/>
+                    </a:solidFill>
+                  </a:tcPr>
+                </a:tc>
+                <a:extLst>
+                  <a:ext uri="{0D108BD9-81ED-4DB2-BD59-A6C34878D82A}">
+                    <a16:rowId xmlns:a16="http://schemas.microsoft.com/office/drawing/2014/main" val="10001"/>
+                  </a:ext>
+                </a:extLst>
+              </a:tr>
+              <a:tr h="603504">
+                <a:tc>
+                  <a:txBody>
+                    <a:bodyPr/>
+                    <a:lstStyle/>
+                    <a:p>
+                      <a:pPr algn="l" latinLnBrk="0"/>
+                      <a:r>
+                        <a:rPr sz="2200" b="1">
+                          <a:solidFill>
+                            <a:srgbClr val="212A33"/>
+                          </a:solidFill>
+                          <a:latin typeface="Calibri"/>
+                        </a:rPr>
+                        <a:t>C overreports (r = 4.5)</a:t>
+                      </a:r>
+                    </a:p>
+                  </a:txBody>
+                  <a:tcPr marL="109728" marR="109728" anchor="ctr">
+                    <a:solidFill>
+                      <a:srgbClr val="F4F6F7"/>
+                    </a:solidFill>
+                  </a:tcPr>
+                </a:tc>
+                <a:tc>
+                  <a:txBody>
+                    <a:bodyPr/>
+                    <a:lstStyle/>
+                    <a:p>
+                      <a:pPr algn="ctr" latinLnBrk="0"/>
+                      <a:r>
+                        <a:rPr sz="2200" b="0">
+                          <a:solidFill>
+                            <a:srgbClr val="212A33"/>
+                          </a:solidFill>
+                          <a:latin typeface="Calibri"/>
+                        </a:rPr>
+                        <a:t>(−1.2, 0)</a:t>
+                      </a:r>
+                    </a:p>
+                  </a:txBody>
+                  <a:tcPr marL="109728" marR="109728" anchor="ctr">
+                    <a:solidFill>
+                      <a:srgbClr val="F4F6F7"/>
+                    </a:solidFill>
+                  </a:tcPr>
+                </a:tc>
+                <a:tc>
+                  <a:txBody>
+                    <a:bodyPr/>
+                    <a:lstStyle/>
+                    <a:p>
+                      <a:pPr algn="ctr" latinLnBrk="0"/>
+                      <a:r>
+                        <a:rPr sz="2200" b="0">
+                          <a:solidFill>
+                            <a:srgbClr val="212A33"/>
+                          </a:solidFill>
+                          <a:latin typeface="Calibri"/>
+                        </a:rPr>
+                        <a:t>(0.8, 0)</a:t>
+                      </a:r>
+                    </a:p>
+                  </a:txBody>
+                  <a:tcPr marL="109728" marR="109728" anchor="ctr">
+                    <a:solidFill>
+                      <a:srgbClr val="F4F6F7"/>
+                    </a:solidFill>
+                  </a:tcPr>
+                </a:tc>
+                <a:extLst>
+                  <a:ext uri="{0D108BD9-81ED-4DB2-BD59-A6C34878D82A}">
+                    <a16:rowId xmlns:a16="http://schemas.microsoft.com/office/drawing/2014/main" val="10002"/>
+                  </a:ext>
+                </a:extLst>
+              </a:tr>
+            </a:tbl>
+          </a:graphicData>
+        </a:graphic>
+      </p:graphicFrame>
+      <p:sp>
+        <p:nvSpPr>
+          <p:cNvPr id="72" name="question-1"/>
           <p:cNvSpPr/>
           <p:nvPr/>
         </p:nvSpPr>
         <p:spPr>
           <a:xfrm>
-            <a:off x="13700760" y="11601450"/>
-            <a:ext cx="2678160" cy="3752850"/>
+            <a:off x="13697712" y="11384280"/>
+            <a:ext cx="4983480" cy="2377440"/>
           </a:xfrm>
           <a:prstGeom prst="roundRect">
             <a:avLst>
@@ -4804,7 +4392,7 @@
           <a:bodyPr wrap="square" rtlCol="0" anchor="ctr"/>
           <a:lstStyle/>
           <a:p>
-            <a:pPr algn="ctr"/>
+            <a:pPr algn="ctr" latinLnBrk="0"/>
             <a:r>
               <a:rPr sz="2800" b="1">
                 <a:solidFill>
@@ -4812,46 +4400,50 @@
                 </a:solidFill>
                 <a:latin typeface="Calibri"/>
               </a:rPr>
-              <a:t>1  Question</a:t>
-            </a:r>
-          </a:p>
-          <a:p>
-            <a:pPr algn="ctr">
+              <a:t>Q1  Economics</a:t>
+            </a:r>
+          </a:p>
+          <a:p>
+            <a:pPr algn="ctr" latinLnBrk="0">
               <a:spcBef>
                 <a:spcPts val="800"/>
               </a:spcBef>
             </a:pPr>
             <a:r>
-              <a:rPr sz="2000">
+              <a:rPr sz="2400">
                 <a:solidFill>
                   <a:srgbClr val="1F2937"/>
                 </a:solidFill>
                 <a:latin typeface="Calibri"/>
               </a:rPr>
-              <a:t>Value- and carbon-aware allocation of 100 GPU-h?</a:t>
-            </a:r>
-          </a:p>
-        </p:txBody>
-      </p:sp>
-      <p:sp>
-        <p:nvSpPr>
-          <p:cNvPr id="60" name="design-arrow-1"/>
+              <a:t>How should scarce GPU-hours be allocated for value net of carbon when teams can misreport their private value?</a:t>
+            </a:r>
+          </a:p>
+        </p:txBody>
+      </p:sp>
+      <p:sp>
+        <p:nvSpPr>
+          <p:cNvPr id="73" name="question-2"/>
           <p:cNvSpPr/>
           <p:nvPr/>
         </p:nvSpPr>
         <p:spPr>
           <a:xfrm>
-            <a:off x="16452072" y="13294995"/>
-            <a:ext cx="356616" cy="365760"/>
+            <a:off x="18909792" y="11384280"/>
+            <a:ext cx="4983480" cy="2377440"/>
           </a:xfrm>
-          <a:prstGeom prst="rightArrow">
-            <a:avLst/>
+          <a:prstGeom prst="roundRect">
+            <a:avLst>
+              <a:gd name="adj" fmla="val 8000"/>
+            </a:avLst>
           </a:prstGeom>
           <a:solidFill>
-            <a:srgbClr val="006633"/>
+            <a:srgbClr val="FFFFFF"/>
           </a:solidFill>
-          <a:ln>
-            <a:noFill/>
+          <a:ln w="31750">
+            <a:solidFill>
+              <a:srgbClr val="003399"/>
+            </a:solidFill>
           </a:ln>
           <a:effectLst/>
         </p:spPr>
@@ -4870,24 +4462,48 @@
           </a:fontRef>
         </p:style>
         <p:txBody>
-          <a:bodyPr rtlCol="0" anchor="ctr"/>
-          <a:lstStyle/>
-          <a:p>
-            <a:pPr algn="ctr"/>
-            <a:endParaRPr/>
-          </a:p>
-        </p:txBody>
-      </p:sp>
-      <p:sp>
-        <p:nvSpPr>
-          <p:cNvPr id="61" name="design-step-2"/>
+          <a:bodyPr wrap="square" rtlCol="0" anchor="ctr"/>
+          <a:lstStyle/>
+          <a:p>
+            <a:pPr algn="ctr" latinLnBrk="0"/>
+            <a:r>
+              <a:rPr sz="2800" b="1">
+                <a:solidFill>
+                  <a:srgbClr val="003399"/>
+                </a:solidFill>
+                <a:latin typeface="Calibri"/>
+              </a:rPr>
+              <a:t>Q2  Computation</a:t>
+            </a:r>
+          </a:p>
+          <a:p>
+            <a:pPr algn="ctr" latinLnBrk="0">
+              <a:spcBef>
+                <a:spcPts val="800"/>
+              </a:spcBef>
+            </a:pPr>
+            <a:r>
+              <a:rPr sz="2400">
+                <a:solidFill>
+                  <a:srgbClr val="1F2937"/>
+                </a:solidFill>
+                <a:latin typeface="Calibri"/>
+              </a:rPr>
+              <a:t>Can an exactly solved multi-team VCG beat first come, first served and stay auditable?</a:t>
+            </a:r>
+          </a:p>
+        </p:txBody>
+      </p:sp>
+      <p:sp>
+        <p:nvSpPr>
+          <p:cNvPr id="74" name="question-3"/>
           <p:cNvSpPr/>
           <p:nvPr/>
         </p:nvSpPr>
         <p:spPr>
           <a:xfrm>
-            <a:off x="16881840" y="11601450"/>
-            <a:ext cx="2678160" cy="3752850"/>
+            <a:off x="24121872" y="11384280"/>
+            <a:ext cx="4983480" cy="2377440"/>
           </a:xfrm>
           <a:prstGeom prst="roundRect">
             <a:avLst>
@@ -4922,7 +4538,7 @@
           <a:bodyPr wrap="square" rtlCol="0" anchor="ctr"/>
           <a:lstStyle/>
           <a:p>
-            <a:pPr algn="ctr"/>
+            <a:pPr algn="ctr" latinLnBrk="0"/>
             <a:r>
               <a:rPr sz="2800" b="1">
                 <a:solidFill>
@@ -4930,43 +4546,43 @@
                 </a:solidFill>
                 <a:latin typeface="Calibri"/>
               </a:rPr>
-              <a:t>2  Model</a:t>
-            </a:r>
-          </a:p>
-          <a:p>
-            <a:pPr algn="ctr">
+              <a:t>Q3  Behavior</a:t>
+            </a:r>
+          </a:p>
+          <a:p>
+            <a:pPr algn="ctr" latinLnBrk="0">
               <a:spcBef>
                 <a:spcPts val="800"/>
               </a:spcBef>
             </a:pPr>
             <a:r>
-              <a:rPr sz="2000">
+              <a:rPr sz="2400">
                 <a:solidFill>
                   <a:srgbClr val="1F2937"/>
                 </a:solidFill>
                 <a:latin typeface="Calibri"/>
               </a:rPr>
-              <a:t>Static game, private values; DSIC benchmark</a:t>
-            </a:r>
-          </a:p>
-        </p:txBody>
-      </p:sp>
-      <p:sp>
-        <p:nvSpPr>
-          <p:cNvPr id="62" name="design-arrow-2"/>
+              <a:t>Do people report truthfully and understand the rule?</a:t>
+            </a:r>
+          </a:p>
+        </p:txBody>
+      </p:sp>
+      <p:sp>
+        <p:nvSpPr>
+          <p:cNvPr id="75" name="request-A"/>
           <p:cNvSpPr/>
           <p:nvPr/>
         </p:nvSpPr>
         <p:spPr>
           <a:xfrm>
-            <a:off x="19633152" y="13294995"/>
-            <a:ext cx="356616" cy="365760"/>
+            <a:off x="13697712" y="14374368"/>
+            <a:ext cx="2363724" cy="777240"/>
           </a:xfrm>
-          <a:prstGeom prst="rightArrow">
+          <a:prstGeom prst="rect">
             <a:avLst/>
           </a:prstGeom>
           <a:solidFill>
-            <a:srgbClr val="006633"/>
+            <a:srgbClr val="003399"/>
           </a:solidFill>
           <a:ln>
             <a:noFill/>
@@ -4988,37 +4604,41 @@
           </a:fontRef>
         </p:style>
         <p:txBody>
-          <a:bodyPr rtlCol="0" anchor="ctr"/>
-          <a:lstStyle/>
-          <a:p>
-            <a:pPr algn="ctr"/>
-            <a:endParaRPr/>
-          </a:p>
-        </p:txBody>
-      </p:sp>
-      <p:sp>
-        <p:nvSpPr>
-          <p:cNvPr id="63" name="design-step-3"/>
+          <a:bodyPr wrap="square" lIns="45720" rIns="45720" rtlCol="0" anchor="ctr"/>
+          <a:lstStyle/>
+          <a:p>
+            <a:pPr algn="ctr" latinLnBrk="0"/>
+            <a:r>
+              <a:rPr sz="2400" b="1">
+                <a:solidFill>
+                  <a:srgbClr val="FFFFFF"/>
+                </a:solidFill>
+                <a:latin typeface="Calibri"/>
+              </a:rPr>
+              <a:t>A · 25 h</a:t>
+            </a:r>
+          </a:p>
+        </p:txBody>
+      </p:sp>
+      <p:sp>
+        <p:nvSpPr>
+          <p:cNvPr id="76" name="request-B"/>
           <p:cNvSpPr/>
           <p:nvPr/>
         </p:nvSpPr>
         <p:spPr>
           <a:xfrm>
-            <a:off x="20062920" y="11601450"/>
-            <a:ext cx="2678160" cy="3752850"/>
+            <a:off x="16098012" y="14374368"/>
+            <a:ext cx="1883664" cy="777240"/>
           </a:xfrm>
-          <a:prstGeom prst="roundRect">
-            <a:avLst>
-              <a:gd name="adj" fmla="val 8000"/>
-            </a:avLst>
+          <a:prstGeom prst="rect">
+            <a:avLst/>
           </a:prstGeom>
           <a:solidFill>
-            <a:srgbClr val="FFFFFF"/>
+            <a:srgbClr val="4F86E0"/>
           </a:solidFill>
-          <a:ln w="31750">
-            <a:solidFill>
-              <a:srgbClr val="003399"/>
-            </a:solidFill>
+          <a:ln>
+            <a:noFill/>
           </a:ln>
           <a:effectLst/>
         </p:spPr>
@@ -5037,54 +4657,38 @@
           </a:fontRef>
         </p:style>
         <p:txBody>
-          <a:bodyPr wrap="square" rtlCol="0" anchor="ctr"/>
-          <a:lstStyle/>
-          <a:p>
-            <a:pPr algn="ctr"/>
-            <a:r>
-              <a:rPr sz="2800" b="1" dirty="0">
-                <a:solidFill>
-                  <a:srgbClr val="003399"/>
-                </a:solidFill>
-                <a:latin typeface="Calibri"/>
-              </a:rPr>
-              <a:t>3  Test</a:t>
-            </a:r>
-          </a:p>
-          <a:p>
-            <a:pPr algn="ctr">
-              <a:spcBef>
-                <a:spcPts val="800"/>
-              </a:spcBef>
-            </a:pPr>
-            <a:r>
-              <a:rPr sz="2000" dirty="0">
-                <a:solidFill>
-                  <a:srgbClr val="1F2937"/>
-                </a:solidFill>
-                <a:latin typeface="Calibri"/>
-              </a:rPr>
-              <a:t>Exact VCG vs. 720 FCFS orders; misreport sweep</a:t>
-            </a:r>
-          </a:p>
-        </p:txBody>
-      </p:sp>
-      <p:sp>
-        <p:nvSpPr>
-          <p:cNvPr id="64" name="design-arrow-3"/>
+          <a:bodyPr wrap="square" lIns="45720" rIns="45720" rtlCol="0" anchor="ctr"/>
+          <a:lstStyle/>
+          <a:p>
+            <a:pPr algn="ctr" latinLnBrk="0"/>
+            <a:r>
+              <a:rPr sz="2400" b="1">
+                <a:solidFill>
+                  <a:srgbClr val="FFFFFF"/>
+                </a:solidFill>
+                <a:latin typeface="Calibri"/>
+              </a:rPr>
+              <a:t>B · 20 h</a:t>
+            </a:r>
+          </a:p>
+        </p:txBody>
+      </p:sp>
+      <p:sp>
+        <p:nvSpPr>
+          <p:cNvPr id="77" name="request-C"/>
           <p:cNvSpPr/>
           <p:nvPr/>
         </p:nvSpPr>
         <p:spPr>
           <a:xfrm>
-            <a:off x="22814232" y="13294995"/>
-            <a:ext cx="356616" cy="365760"/>
+            <a:off x="18018252" y="14374368"/>
+            <a:ext cx="1403604" cy="777240"/>
           </a:xfrm>
-          <a:prstGeom prst="rightArrow">
+          <a:prstGeom prst="rect">
             <a:avLst/>
           </a:prstGeom>
           <a:solidFill>
-            <a:srgbClr val="006633"/>
+            <a:srgbClr val="BFD3F6"/>
           </a:solidFill>
           <a:ln>
             <a:noFill/>
@@ -5106,37 +4710,41 @@
           </a:fontRef>
         </p:style>
         <p:txBody>
-          <a:bodyPr rtlCol="0" anchor="ctr"/>
-          <a:lstStyle/>
-          <a:p>
-            <a:pPr algn="ctr"/>
-            <a:endParaRPr/>
-          </a:p>
-        </p:txBody>
-      </p:sp>
-      <p:sp>
-        <p:nvSpPr>
-          <p:cNvPr id="65" name="design-step-4"/>
+          <a:bodyPr wrap="square" lIns="45720" rIns="45720" rtlCol="0" anchor="ctr"/>
+          <a:lstStyle/>
+          <a:p>
+            <a:pPr algn="ctr" latinLnBrk="0"/>
+            <a:r>
+              <a:rPr sz="2400" b="1">
+                <a:solidFill>
+                  <a:srgbClr val="212A33"/>
+                </a:solidFill>
+                <a:latin typeface="Calibri"/>
+              </a:rPr>
+              <a:t>C · 15 h</a:t>
+            </a:r>
+          </a:p>
+        </p:txBody>
+      </p:sp>
+      <p:sp>
+        <p:nvSpPr>
+          <p:cNvPr id="78" name="request-D"/>
           <p:cNvSpPr/>
           <p:nvPr/>
         </p:nvSpPr>
         <p:spPr>
           <a:xfrm>
-            <a:off x="23244000" y="11601450"/>
-            <a:ext cx="2678160" cy="3752850"/>
+            <a:off x="19458432" y="14374368"/>
+            <a:ext cx="2363724" cy="777240"/>
           </a:xfrm>
-          <a:prstGeom prst="roundRect">
-            <a:avLst>
-              <a:gd name="adj" fmla="val 8000"/>
-            </a:avLst>
+          <a:prstGeom prst="rect">
+            <a:avLst/>
           </a:prstGeom>
           <a:solidFill>
-            <a:srgbClr val="FFFFFF"/>
+            <a:srgbClr val="003399"/>
           </a:solidFill>
-          <a:ln w="31750">
-            <a:solidFill>
-              <a:srgbClr val="006633"/>
-            </a:solidFill>
+          <a:ln>
+            <a:noFill/>
           </a:ln>
           <a:effectLst/>
         </p:spPr>
@@ -5155,72 +4763,38 @@
           </a:fontRef>
         </p:style>
         <p:txBody>
-          <a:bodyPr wrap="square" rtlCol="0" anchor="ctr"/>
-          <a:lstStyle/>
-          <a:p>
-            <a:pPr algn="ctr"/>
-            <a:r>
-              <a:rPr sz="2800" b="1" dirty="0">
-                <a:solidFill>
-                  <a:srgbClr val="006633"/>
-                </a:solidFill>
-                <a:latin typeface="Calibri"/>
-              </a:rPr>
-              <a:t>4  Evidence</a:t>
-            </a:r>
-          </a:p>
-          <a:p>
-            <a:pPr algn="ctr">
-              <a:spcBef>
-                <a:spcPts val="800"/>
-              </a:spcBef>
-            </a:pPr>
-            <a:r>
-              <a:rPr sz="2000" dirty="0">
-                <a:solidFill>
-                  <a:srgbClr val="1F2937"/>
-                </a:solidFill>
-                <a:latin typeface="Calibri"/>
-              </a:rPr>
-              <a:t>GitHub + </a:t>
-            </a:r>
-            <a:r>
-              <a:rPr sz="2000" dirty="0" err="1">
-                <a:solidFill>
-                  <a:srgbClr val="1F2937"/>
-                </a:solidFill>
-                <a:latin typeface="Calibri"/>
-              </a:rPr>
-              <a:t>Colab</a:t>
-            </a:r>
-            <a:r>
-              <a:rPr sz="2000" dirty="0">
-                <a:solidFill>
-                  <a:srgbClr val="1F2937"/>
-                </a:solidFill>
-                <a:latin typeface="Calibri"/>
-              </a:rPr>
-              <a:t>: computed. HF play: planned</a:t>
-            </a:r>
-          </a:p>
-        </p:txBody>
-      </p:sp>
-      <p:sp>
-        <p:nvSpPr>
-          <p:cNvPr id="66" name="design-arrow-4"/>
+          <a:bodyPr wrap="square" lIns="45720" rIns="45720" rtlCol="0" anchor="ctr"/>
+          <a:lstStyle/>
+          <a:p>
+            <a:pPr algn="ctr" latinLnBrk="0"/>
+            <a:r>
+              <a:rPr sz="2400" b="1">
+                <a:solidFill>
+                  <a:srgbClr val="FFFFFF"/>
+                </a:solidFill>
+                <a:latin typeface="Calibri"/>
+              </a:rPr>
+              <a:t>D · 25 h</a:t>
+            </a:r>
+          </a:p>
+        </p:txBody>
+      </p:sp>
+      <p:sp>
+        <p:nvSpPr>
+          <p:cNvPr id="79" name="request-E"/>
           <p:cNvSpPr/>
           <p:nvPr/>
         </p:nvSpPr>
         <p:spPr>
           <a:xfrm>
-            <a:off x="25995312" y="13294995"/>
-            <a:ext cx="356616" cy="365760"/>
+            <a:off x="21858732" y="14374368"/>
+            <a:ext cx="1883664" cy="777240"/>
           </a:xfrm>
-          <a:prstGeom prst="rightArrow">
+          <a:prstGeom prst="rect">
             <a:avLst/>
           </a:prstGeom>
           <a:solidFill>
-            <a:srgbClr val="006633"/>
+            <a:srgbClr val="4F86E0"/>
           </a:solidFill>
           <a:ln>
             <a:noFill/>
@@ -5242,37 +4816,41 @@
           </a:fontRef>
         </p:style>
         <p:txBody>
-          <a:bodyPr rtlCol="0" anchor="ctr"/>
-          <a:lstStyle/>
-          <a:p>
-            <a:pPr algn="ctr"/>
-            <a:endParaRPr/>
-          </a:p>
-        </p:txBody>
-      </p:sp>
-      <p:sp>
-        <p:nvSpPr>
-          <p:cNvPr id="67" name="design-step-5"/>
+          <a:bodyPr wrap="square" lIns="45720" rIns="45720" rtlCol="0" anchor="ctr"/>
+          <a:lstStyle/>
+          <a:p>
+            <a:pPr algn="ctr" latinLnBrk="0"/>
+            <a:r>
+              <a:rPr sz="2400" b="1">
+                <a:solidFill>
+                  <a:srgbClr val="FFFFFF"/>
+                </a:solidFill>
+                <a:latin typeface="Calibri"/>
+              </a:rPr>
+              <a:t>E · 20 h</a:t>
+            </a:r>
+          </a:p>
+        </p:txBody>
+      </p:sp>
+      <p:sp>
+        <p:nvSpPr>
+          <p:cNvPr id="80" name="request-F"/>
           <p:cNvSpPr/>
           <p:nvPr/>
         </p:nvSpPr>
         <p:spPr>
           <a:xfrm>
-            <a:off x="26425080" y="11601450"/>
-            <a:ext cx="2678160" cy="3752850"/>
+            <a:off x="23778972" y="14374368"/>
+            <a:ext cx="1403604" cy="777240"/>
           </a:xfrm>
-          <a:prstGeom prst="roundRect">
-            <a:avLst>
-              <a:gd name="adj" fmla="val 8000"/>
-            </a:avLst>
+          <a:prstGeom prst="rect">
+            <a:avLst/>
           </a:prstGeom>
           <a:solidFill>
-            <a:srgbClr val="FFFFFF"/>
+            <a:srgbClr val="BFD3F6"/>
           </a:solidFill>
-          <a:ln w="31750">
-            <a:solidFill>
-              <a:srgbClr val="006633"/>
-            </a:solidFill>
+          <a:ln>
+            <a:noFill/>
           </a:ln>
           <a:effectLst/>
         </p:spPr>
@@ -5291,65 +4869,649 @@
           </a:fontRef>
         </p:style>
         <p:txBody>
-          <a:bodyPr wrap="square" rtlCol="0" anchor="ctr"/>
-          <a:lstStyle/>
-          <a:p>
-            <a:pPr algn="ctr"/>
-            <a:r>
-              <a:rPr sz="2800" b="1">
-                <a:solidFill>
-                  <a:srgbClr val="006633"/>
-                </a:solidFill>
-                <a:latin typeface="Calibri"/>
-              </a:rPr>
-              <a:t>5  Revision</a:t>
-            </a:r>
-          </a:p>
-          <a:p>
-            <a:pPr algn="ctr">
-              <a:spcBef>
-                <a:spcPts val="800"/>
-              </a:spcBef>
-            </a:pPr>
-            <a:r>
-              <a:rPr sz="2000">
-                <a:solidFill>
-                  <a:srgbClr val="1F2937"/>
-                </a:solidFill>
-                <a:latin typeface="Calibri"/>
-              </a:rPr>
-              <a:t>Utility charges own carbon; FCFS → 720 orders</a:t>
-            </a:r>
-          </a:p>
-        </p:txBody>
-      </p:sp>
-      <p:pic>
-        <p:nvPicPr>
-          <p:cNvPr id="68" name="main-result-figure" descr="fig2.png"/>
-          <p:cNvPicPr>
-            <a:picLocks noChangeAspect="1"/>
-          </p:cNvPicPr>
+          <a:bodyPr wrap="square" lIns="45720" rIns="45720" rtlCol="0" anchor="ctr"/>
+          <a:lstStyle/>
+          <a:p>
+            <a:pPr algn="ctr" latinLnBrk="0"/>
+            <a:r>
+              <a:rPr sz="2400" b="1">
+                <a:solidFill>
+                  <a:srgbClr val="212A33"/>
+                </a:solidFill>
+                <a:latin typeface="Calibri"/>
+              </a:rPr>
+              <a:t>F · 15 h</a:t>
+            </a:r>
+          </a:p>
+        </p:txBody>
+      </p:sp>
+      <p:sp>
+        <p:nvSpPr>
+          <p:cNvPr id="81" name="capacity-line"/>
+          <p:cNvSpPr/>
           <p:nvPr/>
-        </p:nvPicPr>
-        <p:blipFill>
-          <a:blip r:embed="rId6"/>
-          <a:stretch>
-            <a:fillRect/>
-          </a:stretch>
-        </p:blipFill>
+        </p:nvSpPr>
         <p:spPr>
           <a:xfrm>
-            <a:off x="13517880" y="17794986"/>
-            <a:ext cx="15768240" cy="5958928"/>
+            <a:off x="23271480" y="14026896"/>
+            <a:ext cx="54864" cy="1344168"/>
           </a:xfrm>
           <a:prstGeom prst="rect">
             <a:avLst/>
           </a:prstGeom>
-        </p:spPr>
-      </p:pic>
+          <a:solidFill>
+            <a:srgbClr val="212A33"/>
+          </a:solidFill>
+          <a:ln>
+            <a:noFill/>
+          </a:ln>
+          <a:effectLst/>
+        </p:spPr>
+        <p:style>
+          <a:lnRef idx="1">
+            <a:schemeClr val="accent1"/>
+          </a:lnRef>
+          <a:fillRef idx="3">
+            <a:schemeClr val="accent1"/>
+          </a:fillRef>
+          <a:effectRef idx="2">
+            <a:schemeClr val="accent1"/>
+          </a:effectRef>
+          <a:fontRef idx="minor">
+            <a:schemeClr val="lt1"/>
+          </a:fontRef>
+        </p:style>
+        <p:txBody>
+          <a:bodyPr wrap="square" lIns="45720" rIns="45720" rtlCol="0" anchor="ctr"/>
+          <a:lstStyle/>
+          <a:p>
+            <a:pPr algn="ctr" latinLnBrk="0"/>
+            <a:endParaRPr/>
+          </a:p>
+        </p:txBody>
+      </p:sp>
+      <p:sp>
+        <p:nvSpPr>
+          <p:cNvPr id="82" name="capacity-label"/>
+          <p:cNvSpPr/>
+          <p:nvPr/>
+        </p:nvSpPr>
+        <p:spPr>
+          <a:xfrm>
+            <a:off x="19915632" y="13825728"/>
+            <a:ext cx="3291840" cy="402336"/>
+          </a:xfrm>
+          <a:prstGeom prst="rect">
+            <a:avLst/>
+          </a:prstGeom>
+          <a:noFill/>
+          <a:ln>
+            <a:noFill/>
+          </a:ln>
+          <a:effectLst/>
+        </p:spPr>
+        <p:style>
+          <a:lnRef idx="1">
+            <a:schemeClr val="accent1"/>
+          </a:lnRef>
+          <a:fillRef idx="3">
+            <a:schemeClr val="accent1"/>
+          </a:fillRef>
+          <a:effectRef idx="2">
+            <a:schemeClr val="accent1"/>
+          </a:effectRef>
+          <a:fontRef idx="minor">
+            <a:schemeClr val="lt1"/>
+          </a:fontRef>
+        </p:style>
+        <p:txBody>
+          <a:bodyPr wrap="square" lIns="45720" rIns="45720" rtlCol="0" anchor="ctr"/>
+          <a:lstStyle/>
+          <a:p>
+            <a:pPr algn="r" latinLnBrk="0"/>
+            <a:r>
+              <a:rPr sz="2200" b="1">
+                <a:solidFill>
+                  <a:srgbClr val="212A33"/>
+                </a:solidFill>
+                <a:latin typeface="Calibri"/>
+              </a:rPr>
+              <a:t>capacity K = 100 GPU-h</a:t>
+            </a:r>
+          </a:p>
+        </p:txBody>
+      </p:sp>
+      <p:sp>
+        <p:nvSpPr>
+          <p:cNvPr id="83" name="overflow-label"/>
+          <p:cNvSpPr/>
+          <p:nvPr/>
+        </p:nvSpPr>
+        <p:spPr>
+          <a:xfrm>
+            <a:off x="25356311" y="14328648"/>
+            <a:ext cx="3657600" cy="868680"/>
+          </a:xfrm>
+          <a:prstGeom prst="rect">
+            <a:avLst/>
+          </a:prstGeom>
+          <a:noFill/>
+          <a:ln>
+            <a:noFill/>
+          </a:ln>
+          <a:effectLst/>
+        </p:spPr>
+        <p:style>
+          <a:lnRef idx="1">
+            <a:schemeClr val="accent1"/>
+          </a:lnRef>
+          <a:fillRef idx="3">
+            <a:schemeClr val="accent1"/>
+          </a:fillRef>
+          <a:effectRef idx="2">
+            <a:schemeClr val="accent1"/>
+          </a:effectRef>
+          <a:fontRef idx="minor">
+            <a:schemeClr val="lt1"/>
+          </a:fontRef>
+        </p:style>
+        <p:txBody>
+          <a:bodyPr wrap="square" lIns="45720" rIns="45720" rtlCol="0" anchor="ctr"/>
+          <a:lstStyle/>
+          <a:p>
+            <a:pPr algn="l" latinLnBrk="0"/>
+            <a:r>
+              <a:rPr sz="2400" b="1">
+                <a:solidFill>
+                  <a:srgbClr val="C2410C"/>
+                </a:solidFill>
+                <a:latin typeface="Calibri"/>
+              </a:rPr>
+              <a:t>120 GPU-h requested:
+who is left out?</a:t>
+            </a:r>
+          </a:p>
+        </p:txBody>
+      </p:sp>
+      <p:sp>
+        <p:nvSpPr>
+          <p:cNvPr id="84" name="setting-legend"/>
+          <p:cNvSpPr/>
+          <p:nvPr/>
+        </p:nvSpPr>
+        <p:spPr>
+          <a:xfrm>
+            <a:off x="13697712" y="15243048"/>
+            <a:ext cx="15361920" cy="457200"/>
+          </a:xfrm>
+          <a:prstGeom prst="rect">
+            <a:avLst/>
+          </a:prstGeom>
+          <a:noFill/>
+          <a:ln>
+            <a:noFill/>
+          </a:ln>
+          <a:effectLst/>
+        </p:spPr>
+        <p:style>
+          <a:lnRef idx="1">
+            <a:schemeClr val="accent1"/>
+          </a:lnRef>
+          <a:fillRef idx="3">
+            <a:schemeClr val="accent1"/>
+          </a:fillRef>
+          <a:effectRef idx="2">
+            <a:schemeClr val="accent1"/>
+          </a:effectRef>
+          <a:fontRef idx="minor">
+            <a:schemeClr val="lt1"/>
+          </a:fontRef>
+        </p:style>
+        <p:txBody>
+          <a:bodyPr wrap="square" lIns="45720" rIns="45720" rtlCol="0" anchor="ctr"/>
+          <a:lstStyle/>
+          <a:p>
+            <a:pPr algn="l" latinLnBrk="0"/>
+            <a:r>
+              <a:rPr sz="2100" b="0">
+                <a:solidFill>
+                  <a:srgbClr val="56616B"/>
+                </a:solidFill>
+                <a:latin typeface="Calibri"/>
+              </a:rPr>
+              <a:t>Block width = public request dᵢ.  Shade = private value vᵢ (dark 9, medium 6, light 3).  Emissions eᵢ = 0.24 dᵢ kg CO₂e;  λ = 0.5.</a:t>
+            </a:r>
+          </a:p>
+        </p:txBody>
+      </p:sp>
+      <p:graphicFrame>
+        <p:nvGraphicFramePr>
+          <p:cNvPr id="85" name="plays-table"/>
+          <p:cNvGraphicFramePr>
+            <a:graphicFrameLocks noGrp="1"/>
+          </p:cNvGraphicFramePr>
+          <p:nvPr/>
+        </p:nvGraphicFramePr>
+        <p:xfrm>
+          <a:off x="30422088" y="17007840"/>
+          <a:ext cx="11045952" cy="2743200"/>
+        </p:xfrm>
+        <a:graphic>
+          <a:graphicData uri="http://schemas.openxmlformats.org/drawingml/2006/table">
+            <a:tbl>
+              <a:tblPr firstRow="1" bandRow="1">
+                <a:tableStyleId>{5C22544A-7EE6-4342-B048-85BDC9FD1C3A}</a:tableStyleId>
+              </a:tblPr>
+              <a:tblGrid>
+                <a:gridCol w="6583680">
+                  <a:extLst>
+                    <a:ext uri="{9D8B030D-6E8A-4147-A177-3AD203B41FA5}">
+                      <a16:colId xmlns:a16="http://schemas.microsoft.com/office/drawing/2014/main" val="20000"/>
+                    </a:ext>
+                  </a:extLst>
+                </a:gridCol>
+                <a:gridCol w="2231136">
+                  <a:extLst>
+                    <a:ext uri="{9D8B030D-6E8A-4147-A177-3AD203B41FA5}">
+                      <a16:colId xmlns:a16="http://schemas.microsoft.com/office/drawing/2014/main" val="20001"/>
+                    </a:ext>
+                  </a:extLst>
+                </a:gridCol>
+                <a:gridCol w="2231136">
+                  <a:extLst>
+                    <a:ext uri="{9D8B030D-6E8A-4147-A177-3AD203B41FA5}">
+                      <a16:colId xmlns:a16="http://schemas.microsoft.com/office/drawing/2014/main" val="20002"/>
+                    </a:ext>
+                  </a:extLst>
+                </a:gridCol>
+              </a:tblGrid>
+              <a:tr h="548640">
+                <a:tc>
+                  <a:txBody>
+                    <a:bodyPr/>
+                    <a:lstStyle/>
+                    <a:p>
+                      <a:pPr algn="l" latinLnBrk="0"/>
+                      <a:r>
+                        <a:rPr sz="2200" b="1">
+                          <a:solidFill>
+                            <a:srgbClr val="FFFFFF"/>
+                          </a:solidFill>
+                          <a:latin typeface="Calibri"/>
+                        </a:rPr>
+                        <a:t>Measure</a:t>
+                      </a:r>
+                    </a:p>
+                  </a:txBody>
+                  <a:tcPr marL="109728" marR="109728" anchor="ctr">
+                    <a:solidFill>
+                      <a:srgbClr val="003399"/>
+                    </a:solidFill>
+                  </a:tcPr>
+                </a:tc>
+                <a:tc>
+                  <a:txBody>
+                    <a:bodyPr/>
+                    <a:lstStyle/>
+                    <a:p>
+                      <a:pPr algn="ctr" latinLnBrk="0"/>
+                      <a:r>
+                        <a:rPr sz="2200" b="1">
+                          <a:solidFill>
+                            <a:srgbClr val="FFFFFF"/>
+                          </a:solidFill>
+                          <a:latin typeface="Calibri"/>
+                        </a:rPr>
+                        <a:t>Benchmark</a:t>
+                      </a:r>
+                    </a:p>
+                  </a:txBody>
+                  <a:tcPr marL="109728" marR="109728" anchor="ctr">
+                    <a:solidFill>
+                      <a:srgbClr val="003399"/>
+                    </a:solidFill>
+                  </a:tcPr>
+                </a:tc>
+                <a:tc>
+                  <a:txBody>
+                    <a:bodyPr/>
+                    <a:lstStyle/>
+                    <a:p>
+                      <a:pPr algn="ctr" latinLnBrk="0"/>
+                      <a:r>
+                        <a:rPr sz="2200" b="1">
+                          <a:solidFill>
+                            <a:srgbClr val="FFFFFF"/>
+                          </a:solidFill>
+                          <a:latin typeface="Calibri"/>
+                        </a:rPr>
+                        <a:t>Observed</a:t>
+                      </a:r>
+                    </a:p>
+                  </a:txBody>
+                  <a:tcPr marL="109728" marR="109728" anchor="ctr">
+                    <a:solidFill>
+                      <a:srgbClr val="003399"/>
+                    </a:solidFill>
+                  </a:tcPr>
+                </a:tc>
+                <a:extLst>
+                  <a:ext uri="{0D108BD9-81ED-4DB2-BD59-A6C34878D82A}">
+                    <a16:rowId xmlns:a16="http://schemas.microsoft.com/office/drawing/2014/main" val="10000"/>
+                  </a:ext>
+                </a:extLst>
+              </a:tr>
+              <a:tr h="548640">
+                <a:tc>
+                  <a:txBody>
+                    <a:bodyPr/>
+                    <a:lstStyle/>
+                    <a:p>
+                      <a:pPr algn="l" latinLnBrk="0"/>
+                      <a:r>
+                        <a:rPr sz="2200" b="1">
+                          <a:solidFill>
+                            <a:srgbClr val="212A33"/>
+                          </a:solidFill>
+                          <a:latin typeface="Calibri"/>
+                        </a:rPr>
+                        <a:t>Truthful reports (r = v)</a:t>
+                      </a:r>
+                    </a:p>
+                  </a:txBody>
+                  <a:tcPr marL="109728" marR="109728" anchor="ctr">
+                    <a:solidFill>
+                      <a:srgbClr val="FFFFFF"/>
+                    </a:solidFill>
+                  </a:tcPr>
+                </a:tc>
+                <a:tc>
+                  <a:txBody>
+                    <a:bodyPr/>
+                    <a:lstStyle/>
+                    <a:p>
+                      <a:pPr algn="ctr" latinLnBrk="0"/>
+                      <a:r>
+                        <a:rPr sz="2200" b="0">
+                          <a:solidFill>
+                            <a:srgbClr val="212A33"/>
+                          </a:solidFill>
+                          <a:latin typeface="Calibri"/>
+                        </a:rPr>
+                        <a:t>5 / 5</a:t>
+                      </a:r>
+                    </a:p>
+                  </a:txBody>
+                  <a:tcPr marL="109728" marR="109728" anchor="ctr">
+                    <a:solidFill>
+                      <a:srgbClr val="FFFFFF"/>
+                    </a:solidFill>
+                  </a:tcPr>
+                </a:tc>
+                <a:tc>
+                  <a:txBody>
+                    <a:bodyPr/>
+                    <a:lstStyle/>
+                    <a:p>
+                      <a:pPr algn="ctr" latinLnBrk="0"/>
+                      <a:r>
+                        <a:rPr sz="2200" b="0">
+                          <a:solidFill>
+                            <a:srgbClr val="212A33"/>
+                          </a:solidFill>
+                          <a:latin typeface="Calibri"/>
+                        </a:rPr>
+                        <a:t>2 / 5</a:t>
+                      </a:r>
+                    </a:p>
+                  </a:txBody>
+                  <a:tcPr marL="109728" marR="109728" anchor="ctr">
+                    <a:solidFill>
+                      <a:srgbClr val="FFFFFF"/>
+                    </a:solidFill>
+                  </a:tcPr>
+                </a:tc>
+                <a:extLst>
+                  <a:ext uri="{0D108BD9-81ED-4DB2-BD59-A6C34878D82A}">
+                    <a16:rowId xmlns:a16="http://schemas.microsoft.com/office/drawing/2014/main" val="10001"/>
+                  </a:ext>
+                </a:extLst>
+              </a:tr>
+              <a:tr h="548640">
+                <a:tc>
+                  <a:txBody>
+                    <a:bodyPr/>
+                    <a:lstStyle/>
+                    <a:p>
+                      <a:pPr algn="l" latinLnBrk="0"/>
+                      <a:r>
+                        <a:rPr sz="2200" b="1">
+                          <a:solidFill>
+                            <a:srgbClr val="212A33"/>
+                          </a:solidFill>
+                          <a:latin typeface="Calibri"/>
+                        </a:rPr>
+                        <a:t>Overreports</a:t>
+                      </a:r>
+                    </a:p>
+                  </a:txBody>
+                  <a:tcPr marL="109728" marR="109728" anchor="ctr">
+                    <a:solidFill>
+                      <a:srgbClr val="F4F6F7"/>
+                    </a:solidFill>
+                  </a:tcPr>
+                </a:tc>
+                <a:tc>
+                  <a:txBody>
+                    <a:bodyPr/>
+                    <a:lstStyle/>
+                    <a:p>
+                      <a:pPr algn="ctr" latinLnBrk="0"/>
+                      <a:r>
+                        <a:rPr sz="2200" b="0">
+                          <a:solidFill>
+                            <a:srgbClr val="212A33"/>
+                          </a:solidFill>
+                          <a:latin typeface="Calibri"/>
+                        </a:rPr>
+                        <a:t>0</a:t>
+                      </a:r>
+                    </a:p>
+                  </a:txBody>
+                  <a:tcPr marL="109728" marR="109728" anchor="ctr">
+                    <a:solidFill>
+                      <a:srgbClr val="F4F6F7"/>
+                    </a:solidFill>
+                  </a:tcPr>
+                </a:tc>
+                <a:tc>
+                  <a:txBody>
+                    <a:bodyPr/>
+                    <a:lstStyle/>
+                    <a:p>
+                      <a:pPr algn="ctr" latinLnBrk="0"/>
+                      <a:r>
+                        <a:rPr sz="2200" b="0">
+                          <a:solidFill>
+                            <a:srgbClr val="212A33"/>
+                          </a:solidFill>
+                          <a:latin typeface="Calibri"/>
+                        </a:rPr>
+                        <a:t>3</a:t>
+                      </a:r>
+                    </a:p>
+                  </a:txBody>
+                  <a:tcPr marL="109728" marR="109728" anchor="ctr">
+                    <a:solidFill>
+                      <a:srgbClr val="F4F6F7"/>
+                    </a:solidFill>
+                  </a:tcPr>
+                </a:tc>
+                <a:extLst>
+                  <a:ext uri="{0D108BD9-81ED-4DB2-BD59-A6C34878D82A}">
+                    <a16:rowId xmlns:a16="http://schemas.microsoft.com/office/drawing/2014/main" val="10002"/>
+                  </a:ext>
+                </a:extLst>
+              </a:tr>
+              <a:tr h="548640">
+                <a:tc>
+                  <a:txBody>
+                    <a:bodyPr/>
+                    <a:lstStyle/>
+                    <a:p>
+                      <a:pPr algn="l" latinLnBrk="0"/>
+                      <a:r>
+                        <a:rPr sz="2200" b="1">
+                          <a:solidFill>
+                            <a:srgbClr val="212A33"/>
+                          </a:solidFill>
+                          <a:latin typeface="Calibri"/>
+                        </a:rPr>
+                        <a:t>Selection predicted correctly</a:t>
+                      </a:r>
+                    </a:p>
+                  </a:txBody>
+                  <a:tcPr marL="109728" marR="109728" anchor="ctr">
+                    <a:solidFill>
+                      <a:srgbClr val="FFFFFF"/>
+                    </a:solidFill>
+                  </a:tcPr>
+                </a:tc>
+                <a:tc>
+                  <a:txBody>
+                    <a:bodyPr/>
+                    <a:lstStyle/>
+                    <a:p>
+                      <a:pPr algn="ctr" latinLnBrk="0"/>
+                      <a:r>
+                        <a:rPr sz="2200" b="0">
+                          <a:solidFill>
+                            <a:srgbClr val="212A33"/>
+                          </a:solidFill>
+                          <a:latin typeface="Calibri"/>
+                        </a:rPr>
+                        <a:t>—</a:t>
+                      </a:r>
+                    </a:p>
+                  </a:txBody>
+                  <a:tcPr marL="109728" marR="109728" anchor="ctr">
+                    <a:solidFill>
+                      <a:srgbClr val="FFFFFF"/>
+                    </a:solidFill>
+                  </a:tcPr>
+                </a:tc>
+                <a:tc>
+                  <a:txBody>
+                    <a:bodyPr/>
+                    <a:lstStyle/>
+                    <a:p>
+                      <a:pPr algn="ctr" latinLnBrk="0"/>
+                      <a:r>
+                        <a:rPr sz="2200" b="0">
+                          <a:solidFill>
+                            <a:srgbClr val="212A33"/>
+                          </a:solidFill>
+                          <a:latin typeface="Calibri"/>
+                        </a:rPr>
+                        <a:t>3 / 5</a:t>
+                      </a:r>
+                    </a:p>
+                  </a:txBody>
+                  <a:tcPr marL="109728" marR="109728" anchor="ctr">
+                    <a:solidFill>
+                      <a:srgbClr val="FFFFFF"/>
+                    </a:solidFill>
+                  </a:tcPr>
+                </a:tc>
+                <a:extLst>
+                  <a:ext uri="{0D108BD9-81ED-4DB2-BD59-A6C34878D82A}">
+                    <a16:rowId xmlns:a16="http://schemas.microsoft.com/office/drawing/2014/main" val="10003"/>
+                  </a:ext>
+                </a:extLst>
+              </a:tr>
+              <a:tr h="548640">
+                <a:tc>
+                  <a:txBody>
+                    <a:bodyPr/>
+                    <a:lstStyle/>
+                    <a:p>
+                      <a:pPr algn="l" latinLnBrk="0"/>
+                      <a:r>
+                        <a:rPr sz="2200" b="1">
+                          <a:solidFill>
+                            <a:srgbClr val="212A33"/>
+                          </a:solidFill>
+                          <a:latin typeface="Calibri"/>
+                        </a:rPr>
+                        <a:t>Plays where a misreport raised utility</a:t>
+                      </a:r>
+                    </a:p>
+                  </a:txBody>
+                  <a:tcPr marL="109728" marR="109728" anchor="ctr">
+                    <a:solidFill>
+                      <a:srgbClr val="F4F6F7"/>
+                    </a:solidFill>
+                  </a:tcPr>
+                </a:tc>
+                <a:tc>
+                  <a:txBody>
+                    <a:bodyPr/>
+                    <a:lstStyle/>
+                    <a:p>
+                      <a:pPr algn="ctr" latinLnBrk="0"/>
+                      <a:r>
+                        <a:rPr sz="2200" b="0">
+                          <a:solidFill>
+                            <a:srgbClr val="212A33"/>
+                          </a:solidFill>
+                          <a:latin typeface="Calibri"/>
+                        </a:rPr>
+                        <a:t>0</a:t>
+                      </a:r>
+                    </a:p>
+                  </a:txBody>
+                  <a:tcPr marL="109728" marR="109728" anchor="ctr">
+                    <a:solidFill>
+                      <a:srgbClr val="F4F6F7"/>
+                    </a:solidFill>
+                  </a:tcPr>
+                </a:tc>
+                <a:tc>
+                  <a:txBody>
+                    <a:bodyPr/>
+                    <a:lstStyle/>
+                    <a:p>
+                      <a:pPr algn="ctr" latinLnBrk="0"/>
+                      <a:r>
+                        <a:rPr sz="2200" b="0">
+                          <a:solidFill>
+                            <a:srgbClr val="212A33"/>
+                          </a:solidFill>
+                          <a:latin typeface="Calibri"/>
+                        </a:rPr>
+                        <a:t>0</a:t>
+                      </a:r>
+                    </a:p>
+                  </a:txBody>
+                  <a:tcPr marL="109728" marR="109728" anchor="ctr">
+                    <a:solidFill>
+                      <a:srgbClr val="F4F6F7"/>
+                    </a:solidFill>
+                  </a:tcPr>
+                </a:tc>
+                <a:extLst>
+                  <a:ext uri="{0D108BD9-81ED-4DB2-BD59-A6C34878D82A}">
+                    <a16:rowId xmlns:a16="http://schemas.microsoft.com/office/drawing/2014/main" val="10004"/>
+                  </a:ext>
+                </a:extLst>
+              </a:tr>
+            </a:tbl>
+          </a:graphicData>
+        </a:graphic>
+      </p:graphicFrame>
       <p:pic>
         <p:nvPicPr>
-          <p:cNvPr id="69" name="hf-qr-code" descr="qr_hf.png"/>
+          <p:cNvPr id="86" name="github-qr-code" descr="image.png"/>
           <p:cNvPicPr>
             <a:picLocks noChangeAspect="1"/>
           </p:cNvPicPr>
@@ -5357,30 +5519,6 @@
         </p:nvPicPr>
         <p:blipFill>
           <a:blip r:embed="rId7"/>
-          <a:stretch>
-            <a:fillRect/>
-          </a:stretch>
-        </p:blipFill>
-        <p:spPr>
-          <a:xfrm>
-            <a:off x="38907720" y="28300680"/>
-            <a:ext cx="1143000" cy="1143000"/>
-          </a:xfrm>
-          <a:prstGeom prst="rect">
-            <a:avLst/>
-          </a:prstGeom>
-        </p:spPr>
-      </p:pic>
-      <p:pic>
-        <p:nvPicPr>
-          <p:cNvPr id="70" name="github-qr-code" descr="qr_gh.png"/>
-          <p:cNvPicPr>
-            <a:picLocks noChangeAspect="1"/>
-          </p:cNvPicPr>
-          <p:nvPr/>
-        </p:nvPicPr>
-        <p:blipFill>
-          <a:blip r:embed="rId8"/>
           <a:stretch>
             <a:fillRect/>
           </a:stretch>

</xml_diff>

<commit_message>
Final project v3: two-page paper, diagrams, poster, README
- Main text compressed to two pages with the eight named parts and a
  Future Research Roadmap subsection; full v2 argument kept as Appendix G
- Figure 1 annotated with C1-C3 and the inherited/new/evidence map
- New SDG impact and roadmap diagrams (official UN icons)
- Appendix D rebuilt: instructor feedback, symposium, FP8 duet and
  roundtable, self-challenges, synthesis, prize comparison, correspondence
- Full acknowledgments and named contributions in paper and poster
- A0 poster v3; poster/final-poster.pdf and .png embedded in README
- Tested commit 2045024 recorded in paper, poster, and README

Co-Authored-By: Claude Opus 5.5 <noreply@anthropic.com>
</commit_message>
<xml_diff>
--- a/PS2-FP05-TeamA-A0-Poster.pptx
+++ b/PS2-FP05-TeamA-A0-Poster.pptx
@@ -828,7 +828,7 @@
                 <a:ea typeface="Calibri"/>
                 <a:cs typeface="Calibri"/>
               </a:rPr>
-              <a:t>COMSCI / ECON 206   |   PS2 RESEARCH SYMPOSIUM   |   FALL 2026</a:t>
+              <a:t>COMSCI / ECON 206   |   FINAL PROJECT: VERIFIED CONTRIBUTION &amp; REPRODUCIBLE RELEASE   |   FALL 2026</a:t>
             </a:r>
           </a:p>
         </p:txBody>
@@ -886,7 +886,7 @@
                 <a:ea typeface="Calibri"/>
                 <a:cs typeface="Calibri"/>
               </a:rPr>
-              <a:t>FINAL v2  ·  OCT 2026</a:t>
+              <a:t>FINAL v3  ·  OCT 21, 2026  ·  commit 2045024</a:t>
             </a:r>
           </a:p>
         </p:txBody>
@@ -1283,7 +1283,7 @@
                 <a:ea typeface="Calibri"/>
                 <a:cs typeface="Calibri"/>
               </a:rPr>
-              <a:t>cuts emissions per unit of value (0.72 vs. 0.81 kg), and keeps truthful reporting optimal at every carbon weight tested, but serves fewer teams (4 vs. 4.93).</a:t>
+              <a:t>cuts emissions per unit of value (0.72 vs. 0.81 kg), and keeps truthful reporting optimal when credits are a fixed budget (C1–C3), but serves fewer teams (4 vs. 4.93).</a:t>
             </a:r>
           </a:p>
         </p:txBody>
@@ -1510,7 +1510,7 @@
                 <a:ea typeface="Calibri"/>
                 <a:cs typeface="Calibri"/>
               </a:rPr>
-              <a:t>AI demand outpaces compute; queues ignore both value and carbon.</a:t>
+              <a:t>university GPU queues ignore both project value and carbon.</a:t>
             </a:r>
           </a:p>
           <a:p>
@@ -1547,7 +1547,7 @@
                 <a:ea typeface="Calibri"/>
                 <a:cs typeface="Calibri"/>
               </a:rPr>
-              <a:t>FAIR-Compute [5] shows that value-blind scheduling loses about a third of scientific value, but it does not quantify carbon and leaves truthful-reporting mechanisms to future work. We build that piece at an exactly solvable scale.</a:t>
+              <a:t>FAIR-Compute [5] shows value-blind rules lose about a third of value but leaves carbon and truthful mechanisms open. Truthful cloud auctions price server costs [6]; carbon-aware schedulers shift load without prices [7]. We build the missing rule at an exactly solvable scale.</a:t>
             </a:r>
           </a:p>
         </p:txBody>
@@ -1627,7 +1627,7 @@
         <p:spPr>
           <a:xfrm>
             <a:off x="1333500" y="14996159"/>
-            <a:ext cx="11049000" cy="4663440"/>
+            <a:ext cx="11049000" cy="5328000"/>
           </a:xfrm>
           <a:prstGeom prst="rect">
             <a:avLst/>
@@ -1751,7 +1751,7 @@
                 <a:ea typeface="Calibri"/>
                 <a:cs typeface="Calibri"/>
               </a:rPr>
-              <a:t>pick the feasible group S* maximizing Σ(rᵢ − λeᵢ) over all 64 groups; each winner pays the score the other teams lose because it is selected.</a:t>
+              <a:t>pick the feasible group S* maximizing Σ(rᵢ − λeᵢ) over all 64 groups; each winner pays the score the others lose (VCG) in credits.</a:t>
             </a:r>
           </a:p>
           <a:p>
@@ -1825,44 +1825,7 @@
                 <a:ea typeface="Calibri"/>
                 <a:cs typeface="Calibri"/>
               </a:rPr>
-              <a:t>truthful rᵢ = vᵢ is dominant (DSIC) [1–4]: the price never depends on a team's own report.</a:t>
-            </a:r>
-          </a:p>
-          <a:p>
-            <a:pPr algn="l" latinLnBrk="0">
-              <a:spcAft>
-                <a:spcPts val="600"/>
-              </a:spcAft>
-              <a:defRPr sz="3300" b="0">
-                <a:solidFill>
-                  <a:srgbClr val="212A33"/>
-                </a:solidFill>
-                <a:latin typeface="Calibri"/>
-                <a:ea typeface="Calibri"/>
-                <a:cs typeface="Calibri"/>
-              </a:defRPr>
-            </a:pPr>
-            <a:r>
-              <a:rPr sz="2500" b="1" dirty="0">
-                <a:solidFill>
-                  <a:srgbClr val="212A33"/>
-                </a:solidFill>
-                <a:latin typeface="Calibri"/>
-                <a:ea typeface="Calibri"/>
-                <a:cs typeface="Calibri"/>
-              </a:rPr>
-              <a:t>Analogy stops: </a:t>
-            </a:r>
-            <a:r>
-              <a:rPr sz="2500" b="0" dirty="0">
-                <a:solidFill>
-                  <a:srgbClr val="212A33"/>
-                </a:solidFill>
-                <a:latin typeface="Calibri"/>
-                <a:ea typeface="Calibri"/>
-                <a:cs typeface="Calibri"/>
-              </a:rPr>
-              <a:t>credits are not money; values are never verified.</a:t>
+              <a:t>truthful rᵢ = vᵢ is dominant (DSIC) [1–4] only if C1 each winner pays its own carbon charge λeᵢ in credits; C2 each team holds a fixed 100-credit budget per round, no top-ups; C3 the budget never binds (largest spend 60, checked).</a:t>
             </a:r>
           </a:p>
         </p:txBody>
@@ -2087,7 +2050,7 @@
         </p:nvSpPr>
         <p:spPr>
           <a:xfrm>
-            <a:off x="1333500" y="19705320"/>
+            <a:off x="1333500" y="19908000"/>
             <a:ext cx="11049000" cy="666750"/>
           </a:xfrm>
           <a:prstGeom prst="rect">
@@ -2124,7 +2087,7 @@
                 <a:ea typeface="Calibri"/>
                 <a:cs typeface="Calibri"/>
               </a:rPr>
-              <a:t>Reduced payoff matrix: Team C vs. Team E</a:t>
+              <a:t>Named contributions</a:t>
             </a:r>
           </a:p>
         </p:txBody>
@@ -2145,8 +2108,8 @@
         </p:nvSpPr>
         <p:spPr>
           <a:xfrm>
-            <a:off x="1333500" y="22311360"/>
-            <a:ext cx="11049000" cy="1005840"/>
+            <a:off x="1333500" y="20556000"/>
+            <a:ext cx="11049000" cy="2808000"/>
           </a:xfrm>
           <a:prstGeom prst="rect">
             <a:avLst/>
@@ -2177,15 +2140,137 @@
               </a:defRPr>
             </a:pPr>
             <a:r>
-              <a:rPr sz="2200" b="0" dirty="0">
-                <a:solidFill>
-                  <a:srgbClr val="212A33"/>
-                </a:solidFill>
-                <a:latin typeface="Calibri"/>
-                <a:ea typeface="Calibri"/>
-                <a:cs typeface="Calibri"/>
-              </a:rPr>
-              <a:t>Simplification: only C and E choose; A, B, D, F report truthfully. Truth is weakly dominant for both, and C's overreport pushes the truthful E out.</a:t>
+              <a:rPr sz="2100" b="1" dirty="0">
+                <a:solidFill>
+                  <a:srgbClr val="212A33"/>
+                </a:solidFill>
+                <a:latin typeface="Calibri"/>
+                <a:ea typeface="Calibri"/>
+                <a:cs typeface="Calibri"/>
+              </a:rPr>
+              <a:t>Mustafa Ayub Khan: </a:t>
+            </a:r>
+            <a:r>
+              <a:rPr sz="2100" b="0" dirty="0">
+                <a:solidFill>
+                  <a:srgbClr val="212A33"/>
+                </a:solidFill>
+                <a:latin typeface="Calibri"/>
+                <a:ea typeface="Calibri"/>
+                <a:cs typeface="Calibri"/>
+              </a:rPr>
+              <a:t>framing and closest work; credit design C2 from his self-challenge; Practical Impacts and SDG targets; checks names in paper and poster.</a:t>
+            </a:r>
+          </a:p>
+          <a:p>
+            <a:pPr algn="l" latinLnBrk="0">
+              <a:spcAft>
+                <a:spcPts val="600"/>
+              </a:spcAft>
+              <a:defRPr sz="3150" b="0">
+                <a:solidFill>
+                  <a:srgbClr val="212A33"/>
+                </a:solidFill>
+                <a:latin typeface="Calibri"/>
+                <a:ea typeface="Calibri"/>
+                <a:cs typeface="Calibri"/>
+              </a:defRPr>
+            </a:pPr>
+            <a:r>
+              <a:rPr sz="2100" b="1" dirty="0">
+                <a:solidFill>
+                  <a:srgbClr val="212A33"/>
+                </a:solidFill>
+                <a:latin typeface="Calibri"/>
+                <a:ea typeface="Calibri"/>
+                <a:cs typeface="Calibri"/>
+              </a:rPr>
+              <a:t>Temur Akhtamjonov: </a:t>
+            </a:r>
+            <a:r>
+              <a:rPr sz="2100" b="0" dirty="0">
+                <a:solidFill>
+                  <a:srgbClr val="212A33"/>
+                </a:solidFill>
+                <a:latin typeface="Calibri"/>
+                <a:ea typeface="Calibri"/>
+                <a:cs typeface="Calibri"/>
+              </a:rPr>
+              <a:t>model and exact solver; FCFS–VCG comparison; GPU-type and measured-emission study; verifies revisions across artifacts.</a:t>
+            </a:r>
+          </a:p>
+          <a:p>
+            <a:pPr algn="l" latinLnBrk="0">
+              <a:spcAft>
+                <a:spcPts val="600"/>
+              </a:spcAft>
+              <a:defRPr sz="3150" b="0">
+                <a:solidFill>
+                  <a:srgbClr val="212A33"/>
+                </a:solidFill>
+                <a:latin typeface="Calibri"/>
+                <a:ea typeface="Calibri"/>
+                <a:cs typeface="Calibri"/>
+              </a:defRPr>
+            </a:pPr>
+            <a:r>
+              <a:rPr sz="2100" b="1" dirty="0">
+                <a:solidFill>
+                  <a:srgbClr val="212A33"/>
+                </a:solidFill>
+                <a:latin typeface="Calibri"/>
+                <a:ea typeface="Calibri"/>
+                <a:cs typeface="Calibri"/>
+              </a:rPr>
+              <a:t>Gihun Lee: </a:t>
+            </a:r>
+            <a:r>
+              <a:rPr sz="2100" b="0" dirty="0">
+                <a:solidFill>
+                  <a:srgbClr val="212A33"/>
+                </a:solidFill>
+                <a:latin typeface="Calibri"/>
+                <a:ea typeface="Calibri"/>
+                <a:cs typeface="Calibri"/>
+              </a:rPr>
+              <a:t>Space and notebook; λ sweep, two-pool and C3 budget checks; Figure 1 annotations, roadmap, two-page paper, Appendix D.</a:t>
+            </a:r>
+          </a:p>
+          <a:p>
+            <a:pPr algn="l" latinLnBrk="0">
+              <a:spcAft>
+                <a:spcPts val="600"/>
+              </a:spcAft>
+              <a:defRPr sz="3150" b="0">
+                <a:solidFill>
+                  <a:srgbClr val="212A33"/>
+                </a:solidFill>
+                <a:latin typeface="Calibri"/>
+                <a:ea typeface="Calibri"/>
+                <a:cs typeface="Calibri"/>
+              </a:defRPr>
+            </a:pPr>
+            <a:r>
+              <a:rPr sz="2100" b="1" dirty="0">
+                <a:solidFill>
+                  <a:srgbClr val="212A33"/>
+                </a:solidFill>
+                <a:latin typeface="Calibri"/>
+                <a:ea typeface="Calibri"/>
+                <a:cs typeface="Calibri"/>
+              </a:rPr>
+              <a:t>Joint: </a:t>
+            </a:r>
+            <a:r>
+              <a:rPr sz="2100" b="0" dirty="0">
+                <a:solidFill>
+                  <a:srgbClr val="212A33"/>
+                </a:solidFill>
+                <a:latin typeface="Calibri"/>
+                <a:ea typeface="Calibri"/>
+                <a:cs typeface="Calibri"/>
+              </a:rPr>
+              <a:t>question, model, and every artifact, reviewed by all three.</a:t>
             </a:r>
           </a:p>
         </p:txBody>
@@ -2579,7 +2664,7 @@
                 <a:ea typeface="Calibri"/>
                 <a:cs typeface="Calibri"/>
               </a:rPr>
-              <a:t>for λ from 0.1 to 1 the same group wins, the price per winner falls from 5.28 to 0, and truth stays optimal. With two GPU types (H100, A100) the same teams win and emissions fall from 21.6 to 16.6 kg.</a:t>
+              <a:t>for λ from 0.1 to 1 the same group wins and truth stays optimal; with two GPU pools emissions fall from 21.6 to 16.6 kg. Winners spend 48–54 of 100 credits.</a:t>
             </a:r>
           </a:p>
           <a:p>
@@ -2616,7 +2701,7 @@
                 <a:ea typeface="Calibri"/>
                 <a:cs typeface="Calibri"/>
               </a:rPr>
-              <a:t>python colab/run_simulation.py reproduces the outputs; 7 unit tests pass; notebook 9/9 checks PASS; commit 8a656a4.</a:t>
+              <a:t>run_simulation.py reproduces the outputs; 8 unit tests pass; notebook 10/10 checks PASS; tested commit 2045024.</a:t>
             </a:r>
           </a:p>
         </p:txBody>
@@ -2771,7 +2856,7 @@
                 <a:ea typeface="Calibri"/>
                 <a:cs typeface="Calibri"/>
               </a:rPr>
-              <a:t>Practical impact: a real-world case</a:t>
+              <a:t>Practical impact &amp; SDG targets</a:t>
             </a:r>
           </a:p>
         </p:txBody>
@@ -2792,8 +2877,8 @@
         </p:nvSpPr>
         <p:spPr>
           <a:xfrm>
-            <a:off x="30421500" y="11841480"/>
-            <a:ext cx="11049000" cy="4297680"/>
+            <a:off x="31536000" y="11844000"/>
+            <a:ext cx="9936000" cy="4356000"/>
           </a:xfrm>
           <a:prstGeom prst="rect">
             <a:avLst/>
@@ -2824,26 +2909,26 @@
               </a:defRPr>
             </a:pPr>
             <a:r>
-              <a:rPr sz="2500" b="1" dirty="0">
-                <a:solidFill>
-                  <a:srgbClr val="212A33"/>
-                </a:solidFill>
-                <a:latin typeface="Calibri"/>
-                <a:ea typeface="Calibri"/>
-                <a:cs typeface="Calibri"/>
-              </a:rPr>
-              <a:t>Case: </a:t>
-            </a:r>
-            <a:r>
-              <a:rPr sz="2500" b="0" dirty="0">
-                <a:solidFill>
-                  <a:srgbClr val="212A33"/>
-                </a:solidFill>
-                <a:latin typeface="Calibri"/>
-                <a:ea typeface="Calibri"/>
-                <a:cs typeface="Calibri"/>
-              </a:rPr>
-              <a:t>a university's shared GPU cluster replaces queue order with a published, re-runnable rule and a carbon weight λ set by the institution; no adoption yet.</a:t>
+              <a:rPr sz="2200" b="1" dirty="0">
+                <a:solidFill>
+                  <a:srgbClr val="212A33"/>
+                </a:solidFill>
+                <a:latin typeface="Calibri"/>
+                <a:ea typeface="Calibri"/>
+                <a:cs typeface="Calibri"/>
+              </a:rPr>
+              <a:t>9.5 research capability: </a:t>
+            </a:r>
+            <a:r>
+              <a:rPr sz="2200" b="0" dirty="0">
+                <a:solidFill>
+                  <a:srgbClr val="212A33"/>
+                </a:solidFill>
+                <a:latin typeface="Calibri"/>
+                <a:ea typeface="Calibri"/>
+                <a:cs typeface="Calibri"/>
+              </a:rPr>
+              <a:t>value net of carbon 16.96 → 19.2 (simulation only).</a:t>
             </a:r>
           </a:p>
           <a:p>
@@ -2861,26 +2946,26 @@
               </a:defRPr>
             </a:pPr>
             <a:r>
-              <a:rPr sz="2500" b="1" dirty="0">
-                <a:solidFill>
-                  <a:srgbClr val="212A33"/>
-                </a:solidFill>
-                <a:latin typeface="Calibri"/>
-                <a:ea typeface="Calibri"/>
-                <a:cs typeface="Calibri"/>
-              </a:rPr>
-              <a:t>Benefits / risks: </a:t>
-            </a:r>
-            <a:r>
-              <a:rPr sz="2500" b="0" dirty="0">
-                <a:solidFill>
-                  <a:srgbClr val="212A33"/>
-                </a:solidFill>
-                <a:latin typeface="Calibri"/>
-                <a:ea typeface="Calibri"/>
-                <a:cs typeface="Calibri"/>
-              </a:rPr>
-              <a:t>compute goes to value net of carbon and every allocation is auditable; fewer teams are served, and a heavy λ penalizes compute-heavy research.</a:t>
+              <a:rPr sz="2200" b="1" dirty="0">
+                <a:solidFill>
+                  <a:srgbClr val="212A33"/>
+                </a:solidFill>
+                <a:latin typeface="Calibri"/>
+                <a:ea typeface="Calibri"/>
+                <a:cs typeface="Calibri"/>
+              </a:rPr>
+              <a:t>9.4 resource efficiency: </a:t>
+            </a:r>
+            <a:r>
+              <a:rPr sz="2200" b="0" dirty="0">
+                <a:solidFill>
+                  <a:srgbClr val="212A33"/>
+                </a:solidFill>
+                <a:latin typeface="Calibri"/>
+                <a:ea typeface="Calibri"/>
+                <a:cs typeface="Calibri"/>
+              </a:rPr>
+              <a:t>0.81 → 0.72 kg CO₂e per value; 0.55 with two pools (simulation only).</a:t>
             </a:r>
           </a:p>
           <a:p>
@@ -2898,26 +2983,26 @@
               </a:defRPr>
             </a:pPr>
             <a:r>
-              <a:rPr sz="2500" b="1" dirty="0">
-                <a:solidFill>
-                  <a:srgbClr val="212A33"/>
-                </a:solidFill>
-                <a:latin typeface="Calibri"/>
-                <a:ea typeface="Calibri"/>
-                <a:cs typeface="Calibri"/>
-              </a:rPr>
-              <a:t>Who needs what: </a:t>
-            </a:r>
-            <a:r>
-              <a:rPr sz="2500" b="0" dirty="0">
-                <a:solidFill>
-                  <a:srgbClr val="212A33"/>
-                </a:solidFill>
-                <a:latin typeface="Calibri"/>
-                <a:ea typeface="Calibri"/>
-                <a:cs typeface="Calibri"/>
-              </a:rPr>
-              <a:t>academia, a transparent pilot; industry, robustness at hundreds of teams; public institutions, a re-runnable audit.</a:t>
+              <a:rPr sz="2200" b="1" dirty="0">
+                <a:solidFill>
+                  <a:srgbClr val="212A33"/>
+                </a:solidFill>
+                <a:latin typeface="Calibri"/>
+                <a:ea typeface="Calibri"/>
+                <a:cs typeface="Calibri"/>
+              </a:rPr>
+              <a:t>13.3 institutional capacity: </a:t>
+            </a:r>
+            <a:r>
+              <a:rPr sz="2200" b="0" dirty="0">
+                <a:solidFill>
+                  <a:srgbClr val="212A33"/>
+                </a:solidFill>
+                <a:latin typeface="Calibri"/>
+                <a:ea typeface="Calibri"/>
+                <a:cs typeface="Calibri"/>
+              </a:rPr>
+              <a:t>published λ, fixed credit supply, re-runnable audit log (intended; no adoption).</a:t>
             </a:r>
           </a:p>
           <a:p>
@@ -2935,26 +3020,63 @@
               </a:defRPr>
             </a:pPr>
             <a:r>
-              <a:rPr sz="2500" b="1" dirty="0">
-                <a:solidFill>
-                  <a:srgbClr val="212A33"/>
-                </a:solidFill>
-                <a:latin typeface="Calibri"/>
-                <a:ea typeface="Calibri"/>
-                <a:cs typeface="Calibri"/>
-              </a:rPr>
-              <a:t>Correction: </a:t>
-            </a:r>
-            <a:r>
-              <a:rPr sz="2500" b="0" dirty="0">
-                <a:solidFill>
-                  <a:srgbClr val="212A33"/>
-                </a:solidFill>
-                <a:latin typeface="Calibri"/>
-                <a:ea typeface="Calibri"/>
-                <a:cs typeface="Calibri"/>
-              </a:rPr>
-              <a:t>rule, inputs, and code are public, so any team can re-run and challenge an allocation.</a:t>
+              <a:rPr sz="2200" b="1" dirty="0">
+                <a:solidFill>
+                  <a:srgbClr val="212A33"/>
+                </a:solidFill>
+                <a:latin typeface="Calibri"/>
+                <a:ea typeface="Calibri"/>
+                <a:cs typeface="Calibri"/>
+              </a:rPr>
+              <a:t>Stakeholders: </a:t>
+            </a:r>
+            <a:r>
+              <a:rPr sz="2200" b="0" dirty="0">
+                <a:solidFill>
+                  <a:srgbClr val="212A33"/>
+                </a:solidFill>
+                <a:latin typeface="Calibri"/>
+                <a:ea typeface="Calibri"/>
+                <a:cs typeface="Calibri"/>
+              </a:rPr>
+              <a:t>research teams, cluster admins, the institution, the public.</a:t>
+            </a:r>
+          </a:p>
+          <a:p>
+            <a:pPr algn="l" latinLnBrk="0">
+              <a:spcAft>
+                <a:spcPts val="600"/>
+              </a:spcAft>
+              <a:defRPr sz="3300" b="0">
+                <a:solidFill>
+                  <a:srgbClr val="212A33"/>
+                </a:solidFill>
+                <a:latin typeface="Calibri"/>
+                <a:ea typeface="Calibri"/>
+                <a:cs typeface="Calibri"/>
+              </a:defRPr>
+            </a:pPr>
+            <a:r>
+              <a:rPr sz="2200" b="1" dirty="0">
+                <a:solidFill>
+                  <a:srgbClr val="212A33"/>
+                </a:solidFill>
+                <a:latin typeface="Calibri"/>
+                <a:ea typeface="Calibri"/>
+                <a:cs typeface="Calibri"/>
+              </a:rPr>
+              <a:t>Risk → safeguard: </a:t>
+            </a:r>
+            <a:r>
+              <a:rPr sz="2200" b="0" dirty="0">
+                <a:solidFill>
+                  <a:srgbClr val="212A33"/>
+                </a:solidFill>
+                <a:latin typeface="Calibri"/>
+                <a:ea typeface="Calibri"/>
+                <a:cs typeface="Calibri"/>
+              </a:rPr>
+              <a:t>heavy λ trades 9.5 for 9.4 → publish λ below 1.25; repeated exclusion → history-based credits (planned); credit inflation → fixed supply (C2).</a:t>
             </a:r>
           </a:p>
         </p:txBody>
@@ -3084,7 +3206,7 @@
                 <a:ea typeface="Calibri"/>
                 <a:cs typeface="Calibri"/>
               </a:rPr>
-              <a:t>no misreport paid off; one overreport bought a seat for 36 credits and ended at u = −3.6.</a:t>
+              <a:t>no misreport paid off; one overreport bought a seat for 36 credits (u = −3.6).</a:t>
             </a:r>
           </a:p>
           <a:p>
@@ -3121,44 +3243,7 @@
                 <a:ea typeface="Calibri"/>
                 <a:cs typeface="Calibri"/>
               </a:rPr>
-              <a:t>three of five players overreported. Stated reasons: wanting to be selected, and misunderstanding the rule.</a:t>
-            </a:r>
-          </a:p>
-          <a:p>
-            <a:pPr algn="l" latinLnBrk="0">
-              <a:spcAft>
-                <a:spcPts val="600"/>
-              </a:spcAft>
-              <a:defRPr sz="3225" b="0">
-                <a:solidFill>
-                  <a:srgbClr val="212A33"/>
-                </a:solidFill>
-                <a:latin typeface="Calibri"/>
-                <a:ea typeface="Calibri"/>
-                <a:cs typeface="Calibri"/>
-              </a:defRPr>
-            </a:pPr>
-            <a:r>
-              <a:rPr sz="2500" b="1" dirty="0">
-                <a:solidFill>
-                  <a:srgbClr val="212A33"/>
-                </a:solidFill>
-                <a:latin typeface="Calibri"/>
-                <a:ea typeface="Calibri"/>
-                <a:cs typeface="Calibri"/>
-              </a:rPr>
-              <a:t>Integration: </a:t>
-            </a:r>
-            <a:r>
-              <a:rPr sz="2500" b="0" dirty="0">
-                <a:solidFill>
-                  <a:srgbClr val="212A33"/>
-                </a:solidFill>
-                <a:latin typeface="Calibri"/>
-                <a:ea typeface="Calibri"/>
-                <a:cs typeface="Calibri"/>
-              </a:rPr>
-              <a:t>the Space's what-if curve exposed that utility vᵢ − pᵢ rewards overreporting; each team now bears its own carbon.</a:t>
+              <a:t>three of five overreported (wanting to win; misunderstanding). Reflections were blank; new plays will ask for a reason first.</a:t>
             </a:r>
           </a:p>
         </p:txBody>
@@ -3216,7 +3301,7 @@
                 <a:ea typeface="Calibri"/>
                 <a:cs typeface="Calibri"/>
               </a:rPr>
-              <a:t>Peer review, limits &amp; next test</a:t>
+              <a:t>Feedback, recognition &amp; roadmap</a:t>
             </a:r>
           </a:p>
         </p:txBody>
@@ -3269,26 +3354,26 @@
               </a:defRPr>
             </a:pPr>
             <a:r>
-              <a:rPr sz="2500" b="1" dirty="0">
-                <a:solidFill>
-                  <a:srgbClr val="212A33"/>
-                </a:solidFill>
-                <a:latin typeface="Calibri"/>
-                <a:ea typeface="Calibri"/>
-                <a:cs typeface="Calibri"/>
-              </a:rPr>
-              <a:t>Why λ = 0.5? </a:t>
-            </a:r>
-            <a:r>
-              <a:rPr sz="2500" b="0" dirty="0">
-                <a:solidFill>
-                  <a:srgbClr val="212A33"/>
-                </a:solidFill>
-                <a:latin typeface="Calibri"/>
-                <a:ea typeface="Calibri"/>
-                <a:cs typeface="Calibri"/>
-              </a:rPr>
-              <a:t>Sweep 0 to 1: prices change, the best strategy does not.</a:t>
+              <a:rPr sz="2200" b="1" dirty="0">
+                <a:solidFill>
+                  <a:srgbClr val="212A33"/>
+                </a:solidFill>
+                <a:latin typeface="Calibri"/>
+                <a:ea typeface="Calibri"/>
+                <a:cs typeface="Calibri"/>
+              </a:rPr>
+              <a:t>Duet &amp; roundtable (Z. Wang, Q. (Aaron) Wang, FP8): </a:t>
+            </a:r>
+            <a:r>
+              <a:rPr sz="2200" b="0" dirty="0">
+                <a:solidFill>
+                  <a:srgbClr val="212A33"/>
+                </a:solidFill>
+                <a:latin typeface="Calibri"/>
+                <a:ea typeface="Calibri"/>
+                <a:cs typeface="Calibri"/>
+              </a:rPr>
+              <a:t>credits are not money → C1–C3 adopted; more GPU types → truth holds with 1 and 2 pools, more types next.</a:t>
             </a:r>
           </a:p>
           <a:p>
@@ -3306,26 +3391,26 @@
               </a:defRPr>
             </a:pPr>
             <a:r>
-              <a:rPr sz="2500" b="1" dirty="0">
-                <a:solidFill>
-                  <a:srgbClr val="212A33"/>
-                </a:solidFill>
-                <a:latin typeface="Calibri"/>
-                <a:ea typeface="Calibri"/>
-                <a:cs typeface="Calibri"/>
-              </a:rPr>
-              <a:t>One GPU type? </a:t>
-            </a:r>
-            <a:r>
-              <a:rPr sz="2500" b="0" dirty="0">
-                <a:solidFill>
-                  <a:srgbClr val="212A33"/>
-                </a:solidFill>
-                <a:latin typeface="Calibri"/>
-                <a:ea typeface="Calibri"/>
-                <a:cs typeface="Calibri"/>
-              </a:rPr>
-              <a:t>Two-pool extension: same winners, emissions −23%.</a:t>
+              <a:rPr sz="2200" b="1" dirty="0">
+                <a:solidFill>
+                  <a:srgbClr val="212A33"/>
+                </a:solidFill>
+                <a:latin typeface="Calibri"/>
+                <a:ea typeface="Calibri"/>
+                <a:cs typeface="Calibri"/>
+              </a:rPr>
+              <a:t>Instructor (Oct 14): </a:t>
+            </a:r>
+            <a:r>
+              <a:rPr sz="2200" b="0" dirty="0">
+                <a:solidFill>
+                  <a:srgbClr val="212A33"/>
+                </a:solidFill>
+                <a:latin typeface="Calibri"/>
+                <a:ea typeface="Calibri"/>
+                <a:cs typeface="Calibri"/>
+              </a:rPr>
+              <a:t>conditions beside the claim; two-page paper; SDG targets with evidence status.</a:t>
             </a:r>
           </a:p>
           <a:p>
@@ -3343,26 +3428,26 @@
               </a:defRPr>
             </a:pPr>
             <a:r>
-              <a:rPr sz="2500" b="1" dirty="0">
-                <a:solidFill>
-                  <a:srgbClr val="212A33"/>
-                </a:solidFill>
-                <a:latin typeface="Calibri"/>
-                <a:ea typeface="Calibri"/>
-                <a:cs typeface="Calibri"/>
-              </a:rPr>
-              <a:t>No play data? </a:t>
-            </a:r>
-            <a:r>
-              <a:rPr sz="2500" b="0" dirty="0">
-                <a:solidFill>
-                  <a:srgbClr val="212A33"/>
-                </a:solidFill>
-                <a:latin typeface="Calibri"/>
-                <a:ea typeface="Calibri"/>
-                <a:cs typeface="Calibri"/>
-              </a:rPr>
-              <a:t>Five recorded self-plays by the authors.</a:t>
+              <a:rPr sz="2200" b="1" dirty="0">
+                <a:solidFill>
+                  <a:srgbClr val="212A33"/>
+                </a:solidFill>
+                <a:latin typeface="Calibri"/>
+                <a:ea typeface="Calibri"/>
+                <a:cs typeface="Calibri"/>
+              </a:rPr>
+              <a:t>Award: </a:t>
+            </a:r>
+            <a:r>
+              <a:rPr sz="2200" b="0" dirty="0">
+                <a:solidFill>
+                  <a:srgbClr val="212A33"/>
+                </a:solidFill>
+                <a:latin typeface="Calibri"/>
+                <a:ea typeface="Calibri"/>
+                <a:cs typeface="Calibri"/>
+              </a:rPr>
+              <a:t>Interdisciplinary Mechanism Design Award from FP8.</a:t>
             </a:r>
           </a:p>
           <a:p>
@@ -3380,63 +3465,26 @@
               </a:defRPr>
             </a:pPr>
             <a:r>
-              <a:rPr sz="2500" b="1" dirty="0">
-                <a:solidFill>
-                  <a:srgbClr val="212A33"/>
-                </a:solidFill>
-                <a:latin typeface="Calibri"/>
-                <a:ea typeface="Calibri"/>
-                <a:cs typeface="Calibri"/>
-              </a:rPr>
-              <a:t>One instance? </a:t>
-            </a:r>
-            <a:r>
-              <a:rPr sz="2500" b="0" dirty="0">
-                <a:solidFill>
-                  <a:srgbClr val="212A33"/>
-                </a:solidFill>
-                <a:latin typeface="Calibri"/>
-                <a:ea typeface="Calibri"/>
-                <a:cs typeface="Calibri"/>
-              </a:rPr>
-              <a:t>Truth also holds on 100 random instances; the FCFS comparison over random draws is next.</a:t>
-            </a:r>
-          </a:p>
-          <a:p>
-            <a:pPr algn="l" latinLnBrk="0">
-              <a:spcAft>
-                <a:spcPts val="600"/>
-              </a:spcAft>
-              <a:defRPr sz="3225" b="0">
-                <a:solidFill>
-                  <a:srgbClr val="212A33"/>
-                </a:solidFill>
-                <a:latin typeface="Calibri"/>
-                <a:ea typeface="Calibri"/>
-                <a:cs typeface="Calibri"/>
-              </a:defRPr>
-            </a:pPr>
-            <a:r>
-              <a:rPr sz="2500" b="1" dirty="0">
-                <a:solidFill>
-                  <a:srgbClr val="212A33"/>
-                </a:solidFill>
-                <a:latin typeface="Calibri"/>
-                <a:ea typeface="Calibri"/>
-                <a:cs typeface="Calibri"/>
-              </a:rPr>
-              <a:t>Limits: </a:t>
-            </a:r>
-            <a:r>
-              <a:rPr sz="2500" b="0" dirty="0">
-                <a:solidFill>
-                  <a:srgbClr val="212A33"/>
-                </a:solidFill>
-                <a:latin typeface="Calibri"/>
-                <a:ea typeface="Calibri"/>
-                <a:cs typeface="Calibri"/>
-              </a:rPr>
-              <a:t>λ and 0.24 kg/GPU-h are assumptions; true values cannot be verified; authors played against simulated rivals.</a:t>
+              <a:rPr sz="2200" b="1" dirty="0">
+                <a:solidFill>
+                  <a:srgbClr val="212A33"/>
+                </a:solidFill>
+                <a:latin typeface="Calibri"/>
+                <a:ea typeface="Calibri"/>
+                <a:cs typeface="Calibri"/>
+              </a:rPr>
+              <a:t>Roadmap: </a:t>
+            </a:r>
+            <a:r>
+              <a:rPr sz="2200" b="0" dirty="0">
+                <a:solidFill>
+                  <a:srgbClr val="212A33"/>
+                </a:solidFill>
+                <a:latin typeface="Calibri"/>
+                <a:ea typeface="Calibri"/>
+                <a:cs typeface="Calibri"/>
+              </a:rPr>
+              <a:t>Econ: credit value over 10 rounds, announcing λ [9]. CS: GPU types with measured emissions, history-based credits [8]. Behavior: reason-before-result study, n ≥ 30.</a:t>
             </a:r>
           </a:p>
         </p:txBody>
@@ -3497,7 +3545,7 @@
         <p:spPr>
           <a:xfrm>
             <a:off x="1333500" y="27813000"/>
-            <a:ext cx="11049000" cy="666750"/>
+            <a:ext cx="18720000" cy="666750"/>
           </a:xfrm>
           <a:prstGeom prst="rect">
             <a:avLst/>
@@ -3555,7 +3603,7 @@
         <p:spPr>
           <a:xfrm>
             <a:off x="1333500" y="28479750"/>
-            <a:ext cx="11049000" cy="1285875"/>
+            <a:ext cx="18720000" cy="1800000"/>
           </a:xfrm>
           <a:prstGeom prst="rect">
             <a:avLst/>
@@ -3583,15 +3631,15 @@
               </a:defRPr>
             </a:pPr>
             <a:r>
-              <a:rPr sz="1700" b="0" dirty="0">
-                <a:solidFill>
-                  <a:srgbClr val="212A33"/>
-                </a:solidFill>
-                <a:latin typeface="Calibri"/>
-                <a:ea typeface="Calibri"/>
-                <a:cs typeface="Calibri"/>
-              </a:rPr>
-              <a:t>Instructor: Professor Luyao Zhang. Symposium reviewers: Y. Wu, Z. Zhou, Z. Wang, X. Sun, Y. Liu, A. Wang, M. Chen. Software: Python, Jupyter and Google Colab, matplotlib, Hugging Face Spaces. AI: Claude Code (Claude Opus 5.5) assisted the Space, notebook, tests, figures, and revision drafts; the authors are responsible for all content.</a:t>
+              <a:rPr sz="1500" b="0" dirty="0">
+                <a:solidFill>
+                  <a:srgbClr val="212A33"/>
+                </a:solidFill>
+                <a:latin typeface="Calibri"/>
+                <a:ea typeface="Calibri"/>
+                <a:cs typeface="Calibri"/>
+              </a:rPr>
+              <a:t>We thank Prof. Luyao Zhang for PS1, PS2, the COMPSCI/ECON 206 workshops and her formal feedback; Prof. Kenneth S. (Ken) Rogerson for advice on each member's PS1, the foundation of our question; and Han Zhang for a question that made us state the research question more concretely. Duet partners Zhenning Wang and Qianshuo (Aaron) Wang (FP8) recommended our three closest papers, challenged our credit and GPU-type assumptions, and gave us an award. Symposium reviewers (Sept 28): Yiqiao Liu (FP10) and Qianshuo (Aaron) Wang (FP8), carbon weight; Zimu Zhou (FP11), GPU types; Xinrong Sun (FP9), truthfulness with the carbon charge; Yongzhuo Wu (FP1), play data; Zijie Wang (FP7), figure and gap; Muhan Chen (FP12), one instance. We acknowledge Tencent's Shanghai office, the Shanghai Science and Technology Museum, and the whole COMPSCI/ECON 206 classroom community. Data are synthetic; SDG icons are official UN icons. Software: Python, Jupyter, Google Colab, matplotlib, Hugging Face Spaces. AI: Claude Code (Claude Opus 5.5) assisted code, figures, and drafts (paper App. A.3); the authors are responsible for all content. Named a missing credit? Please open a GitHub issue.</a:t>
             </a:r>
           </a:p>
         </p:txBody>
@@ -3612,8 +3660,8 @@
         </p:nvSpPr>
         <p:spPr>
           <a:xfrm>
-            <a:off x="13335000" y="27813000"/>
-            <a:ext cx="14192250" cy="666750"/>
+            <a:off x="20520000" y="27684000"/>
+            <a:ext cx="15120000" cy="666750"/>
           </a:xfrm>
           <a:prstGeom prst="rect">
             <a:avLst/>
@@ -3670,8 +3718,8 @@
         </p:nvSpPr>
         <p:spPr>
           <a:xfrm>
-            <a:off x="13335000" y="28479750"/>
-            <a:ext cx="14192250" cy="1285875"/>
+            <a:off x="20520000" y="28260000"/>
+            <a:ext cx="15120000" cy="1872000"/>
           </a:xfrm>
           <a:prstGeom prst="rect">
             <a:avLst/>
@@ -3699,15 +3747,15 @@
               </a:defRPr>
             </a:pPr>
             <a:r>
-              <a:rPr sz="1500" b="0">
-                <a:solidFill>
-                  <a:srgbClr val="212A33"/>
-                </a:solidFill>
-                <a:latin typeface="Calibri"/>
-                <a:ea typeface="Calibri"/>
-                <a:cs typeface="Calibri"/>
-              </a:rPr>
-              <a:t>[1] Vickrey, W. (1961). Counterspeculation, auctions, and competitive sealed tenders. J. Finance 16(1), 8–37. doi:10.1111/j.1540-6261.1961.tb02789.x</a:t>
+              <a:rPr sz="1200" b="0">
+                <a:solidFill>
+                  <a:srgbClr val="212A33"/>
+                </a:solidFill>
+                <a:latin typeface="Calibri"/>
+                <a:ea typeface="Calibri"/>
+                <a:cs typeface="Calibri"/>
+              </a:rPr>
+              <a:t>[1] Vickrey (1961). J. Finance 16(1), 8–37. doi:10.1111/j.1540-6261.1961.tb02789.x</a:t>
             </a:r>
           </a:p>
           <a:p>
@@ -3722,15 +3770,15 @@
               </a:defRPr>
             </a:pPr>
             <a:r>
-              <a:rPr sz="1500" b="0">
-                <a:solidFill>
-                  <a:srgbClr val="212A33"/>
-                </a:solidFill>
-                <a:latin typeface="Calibri"/>
-                <a:ea typeface="Calibri"/>
-                <a:cs typeface="Calibri"/>
-              </a:rPr>
-              <a:t>[2] Clarke, E. H. (1971). Multipart pricing of public goods. Public Choice 11, 17–33. doi:10.1007/BF01726210</a:t>
+              <a:rPr sz="1200" b="0">
+                <a:solidFill>
+                  <a:srgbClr val="212A33"/>
+                </a:solidFill>
+                <a:latin typeface="Calibri"/>
+                <a:ea typeface="Calibri"/>
+                <a:cs typeface="Calibri"/>
+              </a:rPr>
+              <a:t>[2] Clarke (1971). Public Choice 11, 17–33. doi:10.1007/BF01726210</a:t>
             </a:r>
           </a:p>
           <a:p>
@@ -3745,15 +3793,15 @@
               </a:defRPr>
             </a:pPr>
             <a:r>
-              <a:rPr sz="1500" b="0">
-                <a:solidFill>
-                  <a:srgbClr val="212A33"/>
-                </a:solidFill>
-                <a:latin typeface="Calibri"/>
-                <a:ea typeface="Calibri"/>
-                <a:cs typeface="Calibri"/>
-              </a:rPr>
-              <a:t>[3] Groves, T. (1973). Incentives in teams. Econometrica 41(4), 617–631. doi:10.2307/1914085</a:t>
+              <a:rPr sz="1200" b="0">
+                <a:solidFill>
+                  <a:srgbClr val="212A33"/>
+                </a:solidFill>
+                <a:latin typeface="Calibri"/>
+                <a:ea typeface="Calibri"/>
+                <a:cs typeface="Calibri"/>
+              </a:rPr>
+              <a:t>[3] Groves (1973). Econometrica 41(4), 617–631. doi:10.2307/1914085</a:t>
             </a:r>
           </a:p>
           <a:p>
@@ -3768,15 +3816,15 @@
               </a:defRPr>
             </a:pPr>
             <a:r>
-              <a:rPr sz="1500" b="0">
-                <a:solidFill>
-                  <a:srgbClr val="212A33"/>
-                </a:solidFill>
-                <a:latin typeface="Calibri"/>
-                <a:ea typeface="Calibri"/>
-                <a:cs typeface="Calibri"/>
-              </a:rPr>
-              <a:t>[4] Harsanyi, J. C. (1968). Games with incomplete information played by Bayesian players, II. Mgmt. Sci. 14(5), 320–334. doi:10.1287/mnsc.14.5.320</a:t>
+              <a:rPr sz="1200" b="0">
+                <a:solidFill>
+                  <a:srgbClr val="212A33"/>
+                </a:solidFill>
+                <a:latin typeface="Calibri"/>
+                <a:ea typeface="Calibri"/>
+                <a:cs typeface="Calibri"/>
+              </a:rPr>
+              <a:t>[4] Harsanyi (1968). Mgmt. Sci. 14(5), 320–334. doi:10.1287/mnsc.14.5.320</a:t>
             </a:r>
           </a:p>
           <a:p>
@@ -3791,15 +3839,107 @@
               </a:defRPr>
             </a:pPr>
             <a:r>
-              <a:rPr sz="1500" b="0">
-                <a:solidFill>
-                  <a:srgbClr val="212A33"/>
-                </a:solidFill>
-                <a:latin typeface="Calibri"/>
-                <a:ea typeface="Calibri"/>
-                <a:cs typeface="Calibri"/>
-              </a:rPr>
-              <a:t>[5] Zachariadis, K. E., et al. (2026). FAIR-Compute: A roadmap for fair and efficient allocation of federated digital research infrastructure. arXiv:2607.28290</a:t>
+              <a:rPr sz="1200" b="0">
+                <a:solidFill>
+                  <a:srgbClr val="212A33"/>
+                </a:solidFill>
+                <a:latin typeface="Calibri"/>
+                <a:ea typeface="Calibri"/>
+                <a:cs typeface="Calibri"/>
+              </a:rPr>
+              <a:t>[5] Zachariadis et al. (2026). FAIR-Compute. arXiv:2607.28290</a:t>
+            </a:r>
+          </a:p>
+          <a:p>
+            <a:pPr algn="l" latinLnBrk="0">
+              <a:defRPr sz="2400" b="0">
+                <a:solidFill>
+                  <a:srgbClr val="212A33"/>
+                </a:solidFill>
+                <a:latin typeface="Calibri"/>
+                <a:ea typeface="Calibri"/>
+                <a:cs typeface="Calibri"/>
+              </a:defRPr>
+            </a:pPr>
+            <a:r>
+              <a:rPr sz="1200" b="0">
+                <a:solidFill>
+                  <a:srgbClr val="212A33"/>
+                </a:solidFill>
+                <a:latin typeface="Calibri"/>
+                <a:ea typeface="Calibri"/>
+                <a:cs typeface="Calibri"/>
+              </a:rPr>
+              <a:t>[6] Zhang et al. (2015). Online auctions in IaaS clouds. SIGMETRICS, 3–15. doi:10.1145/2745844.2745855</a:t>
+            </a:r>
+          </a:p>
+          <a:p>
+            <a:pPr algn="l" latinLnBrk="0">
+              <a:defRPr sz="2400" b="0">
+                <a:solidFill>
+                  <a:srgbClr val="212A33"/>
+                </a:solidFill>
+                <a:latin typeface="Calibri"/>
+                <a:ea typeface="Calibri"/>
+                <a:cs typeface="Calibri"/>
+              </a:defRPr>
+            </a:pPr>
+            <a:r>
+              <a:rPr sz="1200" b="0">
+                <a:solidFill>
+                  <a:srgbClr val="212A33"/>
+                </a:solidFill>
+                <a:latin typeface="Calibri"/>
+                <a:ea typeface="Calibri"/>
+                <a:cs typeface="Calibri"/>
+              </a:rPr>
+              <a:t>[7] Radovanović et al. (2021). Carbon-aware computing for datacenters. arXiv:2106.11750</a:t>
+            </a:r>
+          </a:p>
+          <a:p>
+            <a:pPr algn="l" latinLnBrk="0">
+              <a:defRPr sz="2400" b="0">
+                <a:solidFill>
+                  <a:srgbClr val="212A33"/>
+                </a:solidFill>
+                <a:latin typeface="Calibri"/>
+                <a:ea typeface="Calibri"/>
+                <a:cs typeface="Calibri"/>
+              </a:defRPr>
+            </a:pPr>
+            <a:r>
+              <a:rPr sz="1200" b="0">
+                <a:solidFill>
+                  <a:srgbClr val="212A33"/>
+                </a:solidFill>
+                <a:latin typeface="Calibri"/>
+                <a:ea typeface="Calibri"/>
+                <a:cs typeface="Calibri"/>
+              </a:rPr>
+              <a:t>[8] Vuppalapati et al. (2023). Karma. USENIX OSDI, 645–662</a:t>
+            </a:r>
+          </a:p>
+          <a:p>
+            <a:pPr algn="l" latinLnBrk="0">
+              <a:defRPr sz="2400" b="0">
+                <a:solidFill>
+                  <a:srgbClr val="212A33"/>
+                </a:solidFill>
+                <a:latin typeface="Calibri"/>
+                <a:ea typeface="Calibri"/>
+                <a:cs typeface="Calibri"/>
+              </a:defRPr>
+            </a:pPr>
+            <a:r>
+              <a:rPr sz="1200" b="0">
+                <a:solidFill>
+                  <a:srgbClr val="212A33"/>
+                </a:solidFill>
+                <a:latin typeface="Calibri"/>
+                <a:ea typeface="Calibri"/>
+                <a:cs typeface="Calibri"/>
+              </a:rPr>
+              <a:t>[9] Royal Swedish Academy of Sciences (2026). Prize in Economic Sciences 2026 (Hall, Woodford)</a:t>
             </a:r>
           </a:p>
         </p:txBody>
@@ -3820,8 +3960,8 @@
         </p:nvSpPr>
         <p:spPr>
           <a:xfrm>
-            <a:off x="30421500" y="27813000"/>
-            <a:ext cx="11049000" cy="476250"/>
+            <a:off x="36000000" y="27813000"/>
+            <a:ext cx="5400000" cy="476250"/>
           </a:xfrm>
           <a:prstGeom prst="rect">
             <a:avLst/>
@@ -3878,8 +4018,8 @@
         </p:nvSpPr>
         <p:spPr>
           <a:xfrm>
-            <a:off x="30421500" y="28384500"/>
-            <a:ext cx="8096250" cy="1325880"/>
+            <a:off x="36000000" y="28368000"/>
+            <a:ext cx="2808000" cy="1332000"/>
           </a:xfrm>
           <a:prstGeom prst="rect">
             <a:avLst/>
@@ -3907,7 +4047,7 @@
               </a:defRPr>
             </a:pPr>
             <a:r>
-              <a:rPr sz="1500" b="0">
+              <a:rPr sz="1300" b="0">
                 <a:solidFill>
                   <a:srgbClr val="212A33"/>
                 </a:solidFill>
@@ -3916,7 +4056,7 @@
                 <a:cs typeface="Calibri"/>
                 <a:hlinkClick r:id="rId4"/>
               </a:rPr>
-              <a:t>Hugging Face: https://huggingface.co/spaces/dku-comsci-econ206-2026/PS2_Team_A</a:t>
+              <a:t>Left QR: Hugging Face Space</a:t>
             </a:r>
           </a:p>
           <a:p>
@@ -3931,7 +4071,7 @@
               </a:defRPr>
             </a:pPr>
             <a:r>
-              <a:rPr sz="1500" b="0">
+              <a:rPr sz="1300" b="0">
                 <a:solidFill>
                   <a:srgbClr val="212A33"/>
                 </a:solidFill>
@@ -3940,7 +4080,7 @@
                 <a:cs typeface="Calibri"/>
                 <a:hlinkClick r:id="rId4"/>
               </a:rPr>
-              <a:t>GitHub: https://github.com/dku-comsci-econ206-Autumn2026/FP05-PS2-Team-A (commit 8a656a4)</a:t>
+              <a:t>Right QR: GitHub (tested commit 2045024)</a:t>
             </a:r>
           </a:p>
           <a:p>
@@ -3955,7 +4095,7 @@
               </a:defRPr>
             </a:pPr>
             <a:r>
-              <a:rPr sz="1500" b="0">
+              <a:rPr sz="1300" b="0">
                 <a:solidFill>
                   <a:srgbClr val="212A33"/>
                 </a:solidFill>
@@ -3964,65 +4104,7 @@
                 <a:cs typeface="Calibri"/>
                 <a:hlinkClick r:id="rId4"/>
               </a:rPr>
-              <a:t>Colab: https://colab.research.google.com/drive/14eo8a2HWUbbBtv-m-ia4xRiL4V6Iwtun</a:t>
-            </a:r>
-          </a:p>
-        </p:txBody>
-      </p:sp>
-      <p:sp>
-        <p:nvSpPr>
-          <p:cNvPr id="51" name="format-note">
-            <a:extLst>
-              <a:ext uri="{FF2B5EF4-FFF2-40B4-BE49-F238E27FC236}">
-                <a16:creationId xmlns:a16="http://schemas.microsoft.com/office/drawing/2014/main" id="{49DEC60E-E378-41A7-B1C9-EC4712C55A58}"/>
-              </a:ext>
-            </a:extLst>
-          </p:cNvPr>
-          <p:cNvSpPr>
-            <a:spLocks noGrp="1"/>
-          </p:cNvSpPr>
-          <p:nvPr/>
-        </p:nvSpPr>
-        <p:spPr>
-          <a:xfrm>
-            <a:off x="35254071" y="27869878"/>
-            <a:ext cx="6527357" cy="476250"/>
-          </a:xfrm>
-          <a:prstGeom prst="rect">
-            <a:avLst/>
-          </a:prstGeom>
-          <a:noFill/>
-          <a:ln w="0">
-            <a:noFill/>
-            <a:prstDash val="solid"/>
-          </a:ln>
-        </p:spPr>
-        <p:txBody>
-          <a:bodyPr wrap="square">
-            <a:noAutofit/>
-          </a:bodyPr>
-          <a:lstStyle/>
-          <a:p>
-            <a:pPr algn="l" latinLnBrk="0">
-              <a:defRPr sz="1950" b="0">
-                <a:solidFill>
-                  <a:srgbClr val="56616B"/>
-                </a:solidFill>
-                <a:latin typeface="Calibri"/>
-                <a:ea typeface="Calibri"/>
-                <a:cs typeface="Calibri"/>
-              </a:defRPr>
-            </a:pPr>
-            <a:r>
-              <a:rPr sz="1950" b="0">
-                <a:solidFill>
-                  <a:srgbClr val="56616B"/>
-                </a:solidFill>
-                <a:latin typeface="Calibri"/>
-                <a:ea typeface="Calibri"/>
-                <a:cs typeface="Calibri"/>
-              </a:rPr>
-              <a:t>QR codes: left Hugging Face Space, right GitHub repository.</a:t>
+              <a:t>Colab and paper: links in the GitHub README</a:t>
             </a:r>
           </a:p>
         </p:txBody>
@@ -4075,279 +4157,6 @@
           </a:prstGeom>
         </p:spPr>
       </p:pic>
-      <p:graphicFrame>
-        <p:nvGraphicFramePr>
-          <p:cNvPr id="71" name="payoff-matrix"/>
-          <p:cNvGraphicFramePr>
-            <a:graphicFrameLocks noGrp="1"/>
-          </p:cNvGraphicFramePr>
-          <p:nvPr/>
-        </p:nvGraphicFramePr>
-        <p:xfrm>
-          <a:off x="1335024" y="20391120"/>
-          <a:ext cx="11045952" cy="1810512"/>
-        </p:xfrm>
-        <a:graphic>
-          <a:graphicData uri="http://schemas.openxmlformats.org/drawingml/2006/table">
-            <a:tbl>
-              <a:tblPr firstRow="1" bandRow="1">
-                <a:tableStyleId>{5C22544A-7EE6-4342-B048-85BDC9FD1C3A}</a:tableStyleId>
-              </a:tblPr>
-              <a:tblGrid>
-                <a:gridCol w="4206240">
-                  <a:extLst>
-                    <a:ext uri="{9D8B030D-6E8A-4147-A177-3AD203B41FA5}">
-                      <a16:colId xmlns:a16="http://schemas.microsoft.com/office/drawing/2014/main" val="20000"/>
-                    </a:ext>
-                  </a:extLst>
-                </a:gridCol>
-                <a:gridCol w="3291840">
-                  <a:extLst>
-                    <a:ext uri="{9D8B030D-6E8A-4147-A177-3AD203B41FA5}">
-                      <a16:colId xmlns:a16="http://schemas.microsoft.com/office/drawing/2014/main" val="20001"/>
-                    </a:ext>
-                  </a:extLst>
-                </a:gridCol>
-                <a:gridCol w="3547872">
-                  <a:extLst>
-                    <a:ext uri="{9D8B030D-6E8A-4147-A177-3AD203B41FA5}">
-                      <a16:colId xmlns:a16="http://schemas.microsoft.com/office/drawing/2014/main" val="20002"/>
-                    </a:ext>
-                  </a:extLst>
-                </a:gridCol>
-              </a:tblGrid>
-              <a:tr h="603504">
-                <a:tc>
-                  <a:txBody>
-                    <a:bodyPr/>
-                    <a:lstStyle/>
-                    <a:p>
-                      <a:pPr algn="l" latinLnBrk="0"/>
-                      <a:r>
-                        <a:rPr sz="2200" b="1">
-                          <a:solidFill>
-                            <a:srgbClr val="FFFFFF"/>
-                          </a:solidFill>
-                          <a:latin typeface="Calibri"/>
-                        </a:rPr>
-                        <a:t>(u_C, u_E)</a:t>
-                      </a:r>
-                    </a:p>
-                  </a:txBody>
-                  <a:tcPr marL="109728" marR="109728" anchor="ctr">
-                    <a:solidFill>
-                      <a:srgbClr val="003399"/>
-                    </a:solidFill>
-                  </a:tcPr>
-                </a:tc>
-                <a:tc>
-                  <a:txBody>
-                    <a:bodyPr/>
-                    <a:lstStyle/>
-                    <a:p>
-                      <a:pPr algn="ctr" latinLnBrk="0"/>
-                      <a:r>
-                        <a:rPr sz="2200" b="1">
-                          <a:solidFill>
-                            <a:srgbClr val="FFFFFF"/>
-                          </a:solidFill>
-                          <a:latin typeface="Calibri"/>
-                        </a:rPr>
-                        <a:t>E truthful (r = 6)</a:t>
-                      </a:r>
-                    </a:p>
-                  </a:txBody>
-                  <a:tcPr marL="109728" marR="109728" anchor="ctr">
-                    <a:solidFill>
-                      <a:srgbClr val="003399"/>
-                    </a:solidFill>
-                  </a:tcPr>
-                </a:tc>
-                <a:tc>
-                  <a:txBody>
-                    <a:bodyPr/>
-                    <a:lstStyle/>
-                    <a:p>
-                      <a:pPr algn="ctr" latinLnBrk="0"/>
-                      <a:r>
-                        <a:rPr sz="2200" b="1">
-                          <a:solidFill>
-                            <a:srgbClr val="FFFFFF"/>
-                          </a:solidFill>
-                          <a:latin typeface="Calibri"/>
-                        </a:rPr>
-                        <a:t>E underreports (r = 4)</a:t>
-                      </a:r>
-                    </a:p>
-                  </a:txBody>
-                  <a:tcPr marL="109728" marR="109728" anchor="ctr">
-                    <a:solidFill>
-                      <a:srgbClr val="003399"/>
-                    </a:solidFill>
-                  </a:tcPr>
-                </a:tc>
-                <a:extLst>
-                  <a:ext uri="{0D108BD9-81ED-4DB2-BD59-A6C34878D82A}">
-                    <a16:rowId xmlns:a16="http://schemas.microsoft.com/office/drawing/2014/main" val="10000"/>
-                  </a:ext>
-                </a:extLst>
-              </a:tr>
-              <a:tr h="603504">
-                <a:tc>
-                  <a:txBody>
-                    <a:bodyPr/>
-                    <a:lstStyle/>
-                    <a:p>
-                      <a:pPr algn="l" latinLnBrk="0"/>
-                      <a:r>
-                        <a:rPr sz="2200" b="1">
-                          <a:solidFill>
-                            <a:srgbClr val="212A33"/>
-                          </a:solidFill>
-                          <a:latin typeface="Calibri"/>
-                        </a:rPr>
-                        <a:t>C truthful (r = 3)</a:t>
-                      </a:r>
-                    </a:p>
-                  </a:txBody>
-                  <a:tcPr marL="109728" marR="109728" anchor="ctr">
-                    <a:solidFill>
-                      <a:srgbClr val="FFFFFF"/>
-                    </a:solidFill>
-                  </a:tcPr>
-                </a:tc>
-                <a:tc>
-                  <a:txBody>
-                    <a:bodyPr/>
-                    <a:lstStyle/>
-                    <a:p>
-                      <a:pPr algn="ctr" latinLnBrk="0"/>
-                      <a:r>
-                        <a:rPr sz="2200" b="0">
-                          <a:solidFill>
-                            <a:srgbClr val="212A33"/>
-                          </a:solidFill>
-                          <a:latin typeface="Calibri"/>
-                        </a:rPr>
-                        <a:t>(0, 1.2)</a:t>
-                      </a:r>
-                    </a:p>
-                  </a:txBody>
-                  <a:tcPr marL="109728" marR="109728" anchor="ctr">
-                    <a:solidFill>
-                      <a:srgbClr val="FFFFFF"/>
-                    </a:solidFill>
-                  </a:tcPr>
-                </a:tc>
-                <a:tc>
-                  <a:txBody>
-                    <a:bodyPr/>
-                    <a:lstStyle/>
-                    <a:p>
-                      <a:pPr algn="ctr" latinLnBrk="0"/>
-                      <a:r>
-                        <a:rPr sz="2200" b="0">
-                          <a:solidFill>
-                            <a:srgbClr val="212A33"/>
-                          </a:solidFill>
-                          <a:latin typeface="Calibri"/>
-                        </a:rPr>
-                        <a:t>(0.8, 0)</a:t>
-                      </a:r>
-                    </a:p>
-                  </a:txBody>
-                  <a:tcPr marL="109728" marR="109728" anchor="ctr">
-                    <a:solidFill>
-                      <a:srgbClr val="FFFFFF"/>
-                    </a:solidFill>
-                  </a:tcPr>
-                </a:tc>
-                <a:extLst>
-                  <a:ext uri="{0D108BD9-81ED-4DB2-BD59-A6C34878D82A}">
-                    <a16:rowId xmlns:a16="http://schemas.microsoft.com/office/drawing/2014/main" val="10001"/>
-                  </a:ext>
-                </a:extLst>
-              </a:tr>
-              <a:tr h="603504">
-                <a:tc>
-                  <a:txBody>
-                    <a:bodyPr/>
-                    <a:lstStyle/>
-                    <a:p>
-                      <a:pPr algn="l" latinLnBrk="0"/>
-                      <a:r>
-                        <a:rPr sz="2200" b="1">
-                          <a:solidFill>
-                            <a:srgbClr val="212A33"/>
-                          </a:solidFill>
-                          <a:latin typeface="Calibri"/>
-                        </a:rPr>
-                        <a:t>C overreports (r = 4.5)</a:t>
-                      </a:r>
-                    </a:p>
-                  </a:txBody>
-                  <a:tcPr marL="109728" marR="109728" anchor="ctr">
-                    <a:solidFill>
-                      <a:srgbClr val="F4F6F7"/>
-                    </a:solidFill>
-                  </a:tcPr>
-                </a:tc>
-                <a:tc>
-                  <a:txBody>
-                    <a:bodyPr/>
-                    <a:lstStyle/>
-                    <a:p>
-                      <a:pPr algn="ctr" latinLnBrk="0"/>
-                      <a:r>
-                        <a:rPr sz="2200" b="0">
-                          <a:solidFill>
-                            <a:srgbClr val="212A33"/>
-                          </a:solidFill>
-                          <a:latin typeface="Calibri"/>
-                        </a:rPr>
-                        <a:t>(−1.2, 0)</a:t>
-                      </a:r>
-                    </a:p>
-                  </a:txBody>
-                  <a:tcPr marL="109728" marR="109728" anchor="ctr">
-                    <a:solidFill>
-                      <a:srgbClr val="F4F6F7"/>
-                    </a:solidFill>
-                  </a:tcPr>
-                </a:tc>
-                <a:tc>
-                  <a:txBody>
-                    <a:bodyPr/>
-                    <a:lstStyle/>
-                    <a:p>
-                      <a:pPr algn="ctr" latinLnBrk="0"/>
-                      <a:r>
-                        <a:rPr sz="2200" b="0">
-                          <a:solidFill>
-                            <a:srgbClr val="212A33"/>
-                          </a:solidFill>
-                          <a:latin typeface="Calibri"/>
-                        </a:rPr>
-                        <a:t>(0.8, 0)</a:t>
-                      </a:r>
-                    </a:p>
-                  </a:txBody>
-                  <a:tcPr marL="109728" marR="109728" anchor="ctr">
-                    <a:solidFill>
-                      <a:srgbClr val="F4F6F7"/>
-                    </a:solidFill>
-                  </a:tcPr>
-                </a:tc>
-                <a:extLst>
-                  <a:ext uri="{0D108BD9-81ED-4DB2-BD59-A6C34878D82A}">
-                    <a16:rowId xmlns:a16="http://schemas.microsoft.com/office/drawing/2014/main" val="10002"/>
-                  </a:ext>
-                </a:extLst>
-              </a:tr>
-            </a:tbl>
-          </a:graphicData>
-        </a:graphic>
-      </p:graphicFrame>
       <p:sp>
         <p:nvSpPr>
           <p:cNvPr id="72" name="question-1"/>
@@ -5527,6 +5336,54 @@
           <a:xfrm>
             <a:off x="40279320" y="28300680"/>
             <a:ext cx="1143000" cy="1143000"/>
+          </a:xfrm>
+          <a:prstGeom prst="rect">
+            <a:avLst/>
+          </a:prstGeom>
+        </p:spPr>
+      </p:pic>
+      <p:pic>
+        <p:nvPicPr>
+          <p:cNvPr id="87" name="sdg-09-icon" descr="sdg_09.png"/>
+          <p:cNvPicPr>
+            <a:picLocks noChangeAspect="1"/>
+          </p:cNvPicPr>
+          <p:nvPr/>
+        </p:nvPicPr>
+        <p:blipFill>
+          <a:blip r:embed="rId8"/>
+          <a:stretch>
+            <a:fillRect/>
+          </a:stretch>
+        </p:blipFill>
+        <p:spPr>
+          <a:xfrm>
+            <a:off x="30420000" y="11916000"/>
+            <a:ext cx="936000" cy="936000"/>
+          </a:xfrm>
+          <a:prstGeom prst="rect">
+            <a:avLst/>
+          </a:prstGeom>
+        </p:spPr>
+      </p:pic>
+      <p:pic>
+        <p:nvPicPr>
+          <p:cNvPr id="88" name="sdg-13-icon" descr="sdg_13.png"/>
+          <p:cNvPicPr>
+            <a:picLocks noChangeAspect="1"/>
+          </p:cNvPicPr>
+          <p:nvPr/>
+        </p:nvPicPr>
+        <p:blipFill>
+          <a:blip r:embed="rId9"/>
+          <a:stretch>
+            <a:fillRect/>
+          </a:stretch>
+        </p:blipFill>
+        <p:spPr>
+          <a:xfrm>
+            <a:off x="30420000" y="12996000"/>
+            <a:ext cx="936000" cy="936000"/>
           </a:xfrm>
           <a:prstGeom prst="rect">
             <a:avLst/>

</xml_diff>

<commit_message>
Add SDG logo to poster header and a PNG export of the poster
Co-Authored-By: Claude Opus 5.5 <noreply@anthropic.com>
</commit_message>
<xml_diff>
--- a/PS2-FP05-TeamA-A0-Poster.pptx
+++ b/PS2-FP05-TeamA-A0-Poster.pptx
@@ -5384,6 +5384,30 @@
           <a:xfrm>
             <a:off x="30420000" y="12996000"/>
             <a:ext cx="936000" cy="936000"/>
+          </a:xfrm>
+          <a:prstGeom prst="rect">
+            <a:avLst/>
+          </a:prstGeom>
+        </p:spPr>
+      </p:pic>
+      <p:pic>
+        <p:nvPicPr>
+          <p:cNvPr id="89" name="sdg-logo" descr="E_SDG_logo_horizontal_PRINT_Transparent.png"/>
+          <p:cNvPicPr>
+            <a:picLocks noChangeAspect="1"/>
+          </p:cNvPicPr>
+          <p:nvPr/>
+        </p:nvPicPr>
+        <p:blipFill>
+          <a:blip r:embed="rId10"/>
+          <a:stretch>
+            <a:fillRect/>
+          </a:stretch>
+        </p:blipFill>
+        <p:spPr>
+          <a:xfrm>
+            <a:off x="35991750" y="4966568"/>
+            <a:ext cx="4680000" cy="855494"/>
           </a:xfrm>
           <a:prstGeom prst="rect">
             <a:avLst/>

</xml_diff>

<commit_message>
Poster: add Space, GitHub, and Colab URLs to Open Materials
Co-Authored-By: Claude Opus 5.5 <noreply@anthropic.com>
</commit_message>
<xml_diff>
--- a/PS2-FP05-TeamA-A0-Poster.pptx
+++ b/PS2-FP05-TeamA-A0-Poster.pptx
@@ -3661,7 +3661,7 @@
         <p:spPr>
           <a:xfrm>
             <a:off x="20520000" y="27684000"/>
-            <a:ext cx="15120000" cy="666750"/>
+            <a:ext cx="11700000" cy="666750"/>
           </a:xfrm>
           <a:prstGeom prst="rect">
             <a:avLst/>
@@ -3719,7 +3719,7 @@
         <p:spPr>
           <a:xfrm>
             <a:off x="20520000" y="28260000"/>
-            <a:ext cx="15120000" cy="1872000"/>
+            <a:ext cx="11700000" cy="1872000"/>
           </a:xfrm>
           <a:prstGeom prst="rect">
             <a:avLst/>
@@ -3960,8 +3960,8 @@
         </p:nvSpPr>
         <p:spPr>
           <a:xfrm>
-            <a:off x="36000000" y="27813000"/>
-            <a:ext cx="5400000" cy="476250"/>
+            <a:off x="32580000" y="27813000"/>
+            <a:ext cx="6120000" cy="476250"/>
           </a:xfrm>
           <a:prstGeom prst="rect">
             <a:avLst/>
@@ -4018,8 +4018,8 @@
         </p:nvSpPr>
         <p:spPr>
           <a:xfrm>
-            <a:off x="36000000" y="28368000"/>
-            <a:ext cx="2808000" cy="1332000"/>
+            <a:off x="32580000" y="28296000"/>
+            <a:ext cx="6192000" cy="1512000"/>
           </a:xfrm>
           <a:prstGeom prst="rect">
             <a:avLst/>
@@ -4047,7 +4047,30 @@
               </a:defRPr>
             </a:pPr>
             <a:r>
-              <a:rPr sz="1300" b="0">
+              <a:rPr sz="1150" b="1">
+                <a:solidFill>
+                  <a:srgbClr val="212A33"/>
+                </a:solidFill>
+                <a:latin typeface="Calibri"/>
+                <a:ea typeface="Calibri"/>
+                <a:cs typeface="Calibri"/>
+              </a:rPr>
+              <a:t>Hugging Face Space (left QR, commit dddebc7):</a:t>
+            </a:r>
+          </a:p>
+          <a:p>
+            <a:pPr algn="l" latinLnBrk="0">
+              <a:defRPr sz="2325" b="0">
+                <a:solidFill>
+                  <a:srgbClr val="212A33"/>
+                </a:solidFill>
+                <a:latin typeface="Calibri"/>
+                <a:ea typeface="Calibri"/>
+                <a:cs typeface="Calibri"/>
+              </a:defRPr>
+            </a:pPr>
+            <a:r>
+              <a:rPr sz="1150" b="0">
                 <a:solidFill>
                   <a:srgbClr val="212A33"/>
                 </a:solidFill>
@@ -4056,7 +4079,7 @@
                 <a:cs typeface="Calibri"/>
                 <a:hlinkClick r:id="rId4"/>
               </a:rPr>
-              <a:t>Left QR: Hugging Face Space (commit dddebc7)</a:t>
+              <a:t>https://huggingface.co/spaces/dku-comsci-econ206-2026/PS2_Team_A</a:t>
             </a:r>
           </a:p>
           <a:p>
@@ -4071,16 +4094,15 @@
               </a:defRPr>
             </a:pPr>
             <a:r>
-              <a:rPr sz="1300" b="0">
-                <a:solidFill>
-                  <a:srgbClr val="212A33"/>
-                </a:solidFill>
-                <a:latin typeface="Calibri"/>
-                <a:ea typeface="Calibri"/>
-                <a:cs typeface="Calibri"/>
-                <a:hlinkClick r:id="rId4"/>
-              </a:rPr>
-              <a:t>Right QR: GitHub (tested commit 2045024)</a:t>
+              <a:rPr sz="1150" b="1">
+                <a:solidFill>
+                  <a:srgbClr val="212A33"/>
+                </a:solidFill>
+                <a:latin typeface="Calibri"/>
+                <a:ea typeface="Calibri"/>
+                <a:cs typeface="Calibri"/>
+              </a:rPr>
+              <a:t>GitHub (right QR, tested commit 2045024):</a:t>
             </a:r>
           </a:p>
           <a:p>
@@ -4095,16 +4117,63 @@
               </a:defRPr>
             </a:pPr>
             <a:r>
-              <a:rPr sz="1300" b="0">
-                <a:solidFill>
-                  <a:srgbClr val="212A33"/>
-                </a:solidFill>
-                <a:latin typeface="Calibri"/>
-                <a:ea typeface="Calibri"/>
-                <a:cs typeface="Calibri"/>
-                <a:hlinkClick r:id="rId4"/>
-              </a:rPr>
-              <a:t>Colab and paper: links in the GitHub README</a:t>
+              <a:rPr sz="1150" b="0">
+                <a:solidFill>
+                  <a:srgbClr val="212A33"/>
+                </a:solidFill>
+                <a:latin typeface="Calibri"/>
+                <a:ea typeface="Calibri"/>
+                <a:cs typeface="Calibri"/>
+                <a:hlinkClick r:id="rId11"/>
+              </a:rPr>
+              <a:t>https://github.com/dku-comsci-econ206-Autumn2026/FP05-PS2-Team-A</a:t>
+            </a:r>
+          </a:p>
+          <a:p>
+            <a:pPr algn="l" latinLnBrk="0">
+              <a:defRPr sz="2325" b="0">
+                <a:solidFill>
+                  <a:srgbClr val="212A33"/>
+                </a:solidFill>
+                <a:latin typeface="Calibri"/>
+                <a:ea typeface="Calibri"/>
+                <a:cs typeface="Calibri"/>
+              </a:defRPr>
+            </a:pPr>
+            <a:r>
+              <a:rPr sz="1150" b="1">
+                <a:solidFill>
+                  <a:srgbClr val="212A33"/>
+                </a:solidFill>
+                <a:latin typeface="Calibri"/>
+                <a:ea typeface="Calibri"/>
+                <a:cs typeface="Calibri"/>
+              </a:rPr>
+              <a:t>Colab notebook:</a:t>
+            </a:r>
+          </a:p>
+          <a:p>
+            <a:pPr algn="l" latinLnBrk="0">
+              <a:defRPr sz="2325" b="0">
+                <a:solidFill>
+                  <a:srgbClr val="212A33"/>
+                </a:solidFill>
+                <a:latin typeface="Calibri"/>
+                <a:ea typeface="Calibri"/>
+                <a:cs typeface="Calibri"/>
+              </a:defRPr>
+            </a:pPr>
+            <a:r>
+              <a:rPr sz="1150" b="0">
+                <a:solidFill>
+                  <a:srgbClr val="212A33"/>
+                </a:solidFill>
+                <a:latin typeface="Calibri"/>
+                <a:ea typeface="Calibri"/>
+                <a:cs typeface="Calibri"/>
+                <a:hlinkClick r:id="rId12"/>
+              </a:rPr>
+              <a:t>https://colab.research.google.com/drive/1xYtctTPKXDszHMjdOS7IVz-OByt4edlD</a:t>
             </a:r>
           </a:p>
         </p:txBody>

</xml_diff>

<commit_message>
Align C1-C3 wording across paper, figures, poster, and README
C1 own carbon charge and C2 linear credit-cost assumption carry the
truthfulness claim; C3 (fixed 100-credit budget, no top-ups) is a
payment-feasibility check only. lambda = 1.25 is described as this
synthetic instance's threshold, not a cap. Includes the team's latest
Overleaf text, trimmed so the main text stays at two pages.

Co-Authored-By: Claude Opus 5.5 <noreply@anthropic.com>
</commit_message>
<xml_diff>
--- a/PS2-FP05-TeamA-A0-Poster.pptx
+++ b/PS2-FP05-TeamA-A0-Poster.pptx
@@ -1283,7 +1283,7 @@
                 <a:ea typeface="Calibri"/>
                 <a:cs typeface="Calibri"/>
               </a:rPr>
-              <a:t>cuts emissions per unit of value (0.72 vs. 0.81 kg), and keeps truthful reporting optimal when credits are a fixed budget (C1–C3), but serves fewer teams (4 vs. 4.93).</a:t>
+              <a:t>cuts emissions per unit of value (0.72 vs. 0.81 kg), and keeps truthful reporting optimal under C1 + C2 (own carbon charge, linear credit cost), but serves fewer teams (4 vs. 4.93).</a:t>
             </a:r>
           </a:p>
         </p:txBody>
@@ -1825,7 +1825,7 @@
                 <a:ea typeface="Calibri"/>
                 <a:cs typeface="Calibri"/>
               </a:rPr>
-              <a:t>truthful rᵢ = vᵢ is dominant (DSIC) [1–4] only if C1 each winner pays its own carbon charge λeᵢ in credits; C2 each team holds a fixed 100-credit budget per round, no top-ups; C3 the budget never binds (largest spend 60, checked).</a:t>
+              <a:t>truthful rᵢ = vᵢ is dominant (DSIC) [1–4] under C1 each winner pays its own carbon charge λeᵢ in credits, and C2 a charged credit has a linear opportunity cost (stated assumption). C3 checks feasibility: a fixed 100-credit budget per round, no top-ups; the largest spend, 60, fits in the tested cases.</a:t>
             </a:r>
           </a:p>
         </p:txBody>
@@ -3076,7 +3076,7 @@
                 <a:ea typeface="Calibri"/>
                 <a:cs typeface="Calibri"/>
               </a:rPr>
-              <a:t>heavy λ trades 9.5 for 9.4 → publish λ below 1.25; repeated exclusion → history-based credits (planned); credit inflation → fixed supply (C2).</a:t>
+              <a:t>heavy λ trades 9.5 for 9.4 → publish λ in advance from local carbon-price data (1.25 is only this instance's threshold); repeated exclusion → history-based credits (planned); credit inflation → fixed 100-credit budget, no top-ups (C3).</a:t>
             </a:r>
           </a:p>
         </p:txBody>
@@ -3373,7 +3373,7 @@
                 <a:ea typeface="Calibri"/>
                 <a:cs typeface="Calibri"/>
               </a:rPr>
-              <a:t>credits are not money → C1–C3 adopted; more GPU types → truth holds with 1 and 2 pools, more types next.</a:t>
+              <a:t>credits are not money → C1 + C2 stated, C3 checked; more GPU types → truth holds with 1 and 2 pools, more types next.</a:t>
             </a:r>
           </a:p>
           <a:p>

</xml_diff>